<commit_message>
Deck v3: align Index to v8 chapters (add 先行研究, drop Appendix)
Per the user's choice, relabel the Index chevrons (numbers/badges/format kept):
03 研究方法→先行研究, 04 実験と結果→研究方法, 05 考察と今後→実験と結果,
06 Appendix→考察と今後の展望. Index now matches the content slides and design
doc v8 (01 研究背景 / 02 本研究の目標 / 03 先行研究 / 04 研究方法 / 05 実験と結果 /
06 考察と今後の展望). Deck is internally consistent.

Co-Authored-By: Claude Opus 4.8 <noreply@anthropic.com>
</commit_message>
<xml_diff>
--- a/presentations/mid_term_202606/04_slides_draft/中間発表_スライド_v3.pptx
+++ b/presentations/mid_term_202606/04_slides_draft/中間発表_スライド_v3.pptx
@@ -6501,7 +6501,7 @@
 </p:sld>
 </file>
 
-<file path=ppt/slides/slide15.xml><?xml version="1.0" encoding="utf-8"?>
+<file path=ppt/slides/slide10.xml><?xml version="1.0" encoding="utf-8"?>
 <p:sld xmlns:a="http://schemas.openxmlformats.org/drawingml/2006/main" xmlns:p="http://schemas.openxmlformats.org/presentationml/2006/main" xmlns:r="http://schemas.openxmlformats.org/officeDocument/2006/relationships">
   <p:cSld>
     <p:spTree>
@@ -6547,7 +6547,7 @@
                 <a:latin typeface="Yu Gothic"/>
                 <a:ea typeface="Yu Gothic"/>
               </a:rPr>
-              <a:t>01. 研究背景</a:t>
+              <a:t>04. 研究方法</a:t>
             </a:r>
           </a:p>
           <a:p>
@@ -6567,7 +6567,7 @@
                 <a:latin typeface="Yu Gothic"/>
                 <a:ea typeface="Yu Gothic"/>
               </a:rPr>
-              <a:t>1-2. 基準信号の純度と現状</a:t>
+              <a:t>4-4. 予備実験：フィードバック電圧の感応度同定</a:t>
             </a:r>
           </a:p>
         </p:txBody>
@@ -6598,7 +6598,7 @@
                 <a:latin typeface="Yu Gothic"/>
                 <a:ea typeface="Yu Gothic"/>
               </a:rPr>
-              <a:t>市販データは概ね 1 Hz 止まり。近傍（0.1–1 Hz）は測定が難しい</a:t>
+              <a:t>1 LSB（≈305 µV）ずつ階段状に電圧を変え、各段の FRFR 傾きを電圧増分に直線回帰</a:t>
             </a:r>
           </a:p>
           <a:p>
@@ -6608,7 +6608,7 @@
                 <a:latin typeface="Yu Gothic"/>
                 <a:ea typeface="Yu Gothic"/>
               </a:rPr>
-              <a:t>近傍の測定純度をどう高めるかが本研究の論点</a:t>
+              <a:t>→ プラントゲイン K≈860 ns/(V·s) が得られた</a:t>
             </a:r>
           </a:p>
         </p:txBody>
@@ -6674,7 +6674,7 @@
                 <a:latin typeface="Yu Gothic"/>
                 <a:ea typeface="Yu Gothic"/>
               </a:rPr>
-              <a:t>通信・測位・計測は基準正弦波の位相雑音に支えられる。原子時計・水素メーザーは高純度だが高価で日単位の計測が必要、OCXOは安価で数秒〜数分の安定に優れるが単体に限界。</a:t>
+              <a:t>フィードバック電圧のLSBを測定し回帰検証することで、フィードバックロジックのパラメータをチューニングした。</a:t>
             </a:r>
           </a:p>
         </p:txBody>
@@ -6695,8 +6695,8 @@
         </p:blipFill>
         <p:spPr>
           <a:xfrm>
-            <a:off x="5074920" y="2869040"/>
-            <a:ext cx="4526280" cy="2491518"/>
+            <a:off x="5074920" y="2860414"/>
+            <a:ext cx="4526280" cy="2508770"/>
           </a:xfrm>
           <a:prstGeom prst="rect">
             <a:avLst/>
@@ -6711,7 +6711,7 @@
 </p:sld>
 </file>
 
-<file path=ppt/slides/slide16.xml><?xml version="1.0" encoding="utf-8"?>
+<file path=ppt/slides/slide11.xml><?xml version="1.0" encoding="utf-8"?>
 <p:sld xmlns:a="http://schemas.openxmlformats.org/drawingml/2006/main" xmlns:p="http://schemas.openxmlformats.org/presentationml/2006/main" xmlns:r="http://schemas.openxmlformats.org/officeDocument/2006/relationships">
   <p:cSld>
     <p:spTree>
@@ -6750,14 +6750,34 @@
               </a:spcAft>
             </a:pPr>
             <a:r>
-              <a:rPr b="1">
+              <a:rPr sz="1400" b="1">
                 <a:solidFill>
                   <a:srgbClr val="000F78"/>
                 </a:solidFill>
                 <a:latin typeface="Yu Gothic"/>
                 <a:ea typeface="Yu Gothic"/>
               </a:rPr>
-              <a:t>02. 本研究の目標</a:t>
+              <a:t>04. 研究方法</a:t>
+            </a:r>
+          </a:p>
+          <a:p>
+            <a:pPr>
+              <a:spcBef>
+                <a:spcPts val="0"/>
+              </a:spcBef>
+              <a:spcAft>
+                <a:spcPts val="0"/>
+              </a:spcAft>
+            </a:pPr>
+            <a:r>
+              <a:rPr b="1">
+                <a:solidFill>
+                  <a:srgbClr val="000F78"/>
+                </a:solidFill>
+                <a:latin typeface="Yu Gothic"/>
+                <a:ea typeface="Yu Gothic"/>
+              </a:rPr>
+              <a:t>4-5. フィードバックロジック</a:t>
             </a:r>
           </a:p>
         </p:txBody>
@@ -6788,7 +6808,7 @@
                 <a:latin typeface="Yu Gothic"/>
                 <a:ea typeface="Yu Gothic"/>
               </a:rPr>
-              <a:t>究極的な目標：安価な水晶発振器（OCXO）で高純度な基準信号源を実現</a:t>
+              <a:t>出自：ACC（車両追従制御）の状態方程式を波動系へ置き換え</a:t>
             </a:r>
           </a:p>
           <a:p>
@@ -6798,7 +6818,17 @@
                 <a:latin typeface="Yu Gothic"/>
                 <a:ea typeface="Yu Gothic"/>
               </a:rPr>
-              <a:t>アプローチ：複数OCXOを同期させ、1台では実現できない純度での計測を可能にする</a:t>
+              <a:t>更新：Δf_des=clamp(Kp_e·e) → 必要段数 dN=round(...) → 電圧更新</a:t>
+            </a:r>
+          </a:p>
+          <a:p>
+            <a:pPr/>
+            <a:r>
+              <a:rPr>
+                <a:latin typeface="Yu Gothic"/>
+                <a:ea typeface="Yu Gothic"/>
+              </a:rPr>
+              <a:t>不感帯で静かに同期。比例・微分（PID）は過剰動作で短期雑音（対比）</a:t>
             </a:r>
           </a:p>
         </p:txBody>
@@ -6864,7 +6894,7 @@
                 <a:latin typeface="Yu Gothic"/>
                 <a:ea typeface="Yu Gothic"/>
               </a:rPr>
-              <a:t>安価なOCXOで可能な限り高純度な基準信号源を実現することを目標とする。</a:t>
+              <a:t>位相のズレ e と周波数のズレ Δf を使う2状態フィードバックで、必要な分だけ電圧を動かす（1 LSB 未満は動かさない＝不感帯）。同期動作そのものが位相雑音を持ち込まない。</a:t>
             </a:r>
           </a:p>
         </p:txBody>
@@ -6885,8 +6915,32 @@
         </p:blipFill>
         <p:spPr>
           <a:xfrm>
-            <a:off x="5074920" y="2796677"/>
-            <a:ext cx="4526280" cy="2636244"/>
+            <a:off x="5074920" y="2288603"/>
+            <a:ext cx="4526280" cy="1732152"/>
+          </a:xfrm>
+          <a:prstGeom prst="rect">
+            <a:avLst/>
+          </a:prstGeom>
+        </p:spPr>
+      </p:pic>
+      <p:pic>
+        <p:nvPicPr>
+          <p:cNvPr id="6" name="Picture 5" descr="image.png"/>
+          <p:cNvPicPr>
+            <a:picLocks noChangeAspect="1"/>
+          </p:cNvPicPr>
+          <p:nvPr/>
+        </p:nvPicPr>
+        <p:blipFill>
+          <a:blip r:embed="rId3"/>
+          <a:stretch>
+            <a:fillRect/>
+          </a:stretch>
+        </p:blipFill>
+        <p:spPr>
+          <a:xfrm>
+            <a:off x="5737325" y="4224528"/>
+            <a:ext cx="3201469" cy="1810512"/>
           </a:xfrm>
           <a:prstGeom prst="rect">
             <a:avLst/>
@@ -6901,7 +6955,7 @@
 </p:sld>
 </file>
 
-<file path=ppt/slides/slide17.xml><?xml version="1.0" encoding="utf-8"?>
+<file path=ppt/slides/slide12.xml><?xml version="1.0" encoding="utf-8"?>
 <p:sld xmlns:a="http://schemas.openxmlformats.org/drawingml/2006/main" xmlns:p="http://schemas.openxmlformats.org/presentationml/2006/main" xmlns:r="http://schemas.openxmlformats.org/officeDocument/2006/relationships">
   <p:cSld>
     <p:spTree>
@@ -6940,34 +6994,14 @@
               </a:spcAft>
             </a:pPr>
             <a:r>
-              <a:rPr sz="1400" b="1">
+              <a:rPr b="1">
                 <a:solidFill>
                   <a:srgbClr val="000F78"/>
                 </a:solidFill>
                 <a:latin typeface="Yu Gothic"/>
                 <a:ea typeface="Yu Gothic"/>
               </a:rPr>
-              <a:t>03. 先行研究</a:t>
-            </a:r>
-          </a:p>
-          <a:p>
-            <a:pPr>
-              <a:spcBef>
-                <a:spcPts val="0"/>
-              </a:spcBef>
-              <a:spcAft>
-                <a:spcPts val="0"/>
-              </a:spcAft>
-            </a:pPr>
-            <a:r>
-              <a:rPr b="1">
-                <a:solidFill>
-                  <a:srgbClr val="000F78"/>
-                </a:solidFill>
-                <a:latin typeface="Yu Gothic"/>
-                <a:ea typeface="Yu Gothic"/>
-              </a:rPr>
-              <a:t>3-1. 同期・平均による位相雑音の改善（1/N の原理）</a:t>
+              <a:t>05. 実験と結果</a:t>
             </a:r>
           </a:p>
         </p:txBody>
@@ -6998,7 +7032,17 @@
                 <a:latin typeface="Yu Gothic"/>
                 <a:ea typeface="Yu Gothic"/>
               </a:rPr>
-              <a:t>無相関な雑音は平均すると電力が台数分の1（2台で 1/2）になり、近傍位相雑音が −3 dB 改善する</a:t>
+              <a:t>モデルFB と HOLD の近傍位相雑音がほぼ一致（差≈0 dB）</a:t>
+            </a:r>
+          </a:p>
+          <a:p>
+            <a:pPr/>
+            <a:r>
+              <a:rPr>
+                <a:latin typeface="Yu Gothic"/>
+                <a:ea typeface="Yu Gothic"/>
+              </a:rPr>
+              <a:t>比例・微分（PID）制御は過剰動作で短期ジッタを注入</a:t>
             </a:r>
           </a:p>
         </p:txBody>
@@ -7064,7 +7108,7 @@
                 <a:latin typeface="Yu Gothic"/>
                 <a:ea typeface="Yu Gothic"/>
               </a:rPr>
-              <a:t>互いに無相関な雑音は平均で打ち消し合うため、位相を揃えた複数OCXOの出力を平均すると単体を超える純度になる。</a:t>
+              <a:t>実測モデルに基づくモデルFB（Kp_e=0.08）は、無制御HOLDと同等の近傍位相雑音のまま同期できる（差≈0 dB）＝同期時に位相雑音を持ち込まない。PID制御は短期雑音を生む（対比）。</a:t>
             </a:r>
           </a:p>
         </p:txBody>
@@ -7085,8 +7129,32 @@
         </p:blipFill>
         <p:spPr>
           <a:xfrm>
-            <a:off x="5257333" y="2286000"/>
-            <a:ext cx="4161453" cy="3657600"/>
+            <a:off x="6037449" y="2249424"/>
+            <a:ext cx="2601220" cy="1810512"/>
+          </a:xfrm>
+          <a:prstGeom prst="rect">
+            <a:avLst/>
+          </a:prstGeom>
+        </p:spPr>
+      </p:pic>
+      <p:pic>
+        <p:nvPicPr>
+          <p:cNvPr id="6" name="Picture 5" descr="image.png"/>
+          <p:cNvPicPr>
+            <a:picLocks noChangeAspect="1"/>
+          </p:cNvPicPr>
+          <p:nvPr/>
+        </p:nvPicPr>
+        <p:blipFill>
+          <a:blip r:embed="rId3"/>
+          <a:stretch>
+            <a:fillRect/>
+          </a:stretch>
+        </p:blipFill>
+        <p:spPr>
+          <a:xfrm>
+            <a:off x="6037449" y="4224528"/>
+            <a:ext cx="2601220" cy="1810512"/>
           </a:xfrm>
           <a:prstGeom prst="rect">
             <a:avLst/>
@@ -7101,7 +7169,7 @@
 </p:sld>
 </file>
 
-<file path=ppt/slides/slide18.xml><?xml version="1.0" encoding="utf-8"?>
+<file path=ppt/slides/slide13.xml><?xml version="1.0" encoding="utf-8"?>
 <p:sld xmlns:a="http://schemas.openxmlformats.org/drawingml/2006/main" xmlns:p="http://schemas.openxmlformats.org/presentationml/2006/main" xmlns:r="http://schemas.openxmlformats.org/officeDocument/2006/relationships">
   <p:cSld>
     <p:spTree>
@@ -7140,34 +7208,14 @@
               </a:spcAft>
             </a:pPr>
             <a:r>
-              <a:rPr sz="1400" b="1">
+              <a:rPr b="1">
                 <a:solidFill>
                   <a:srgbClr val="000F78"/>
                 </a:solidFill>
                 <a:latin typeface="Yu Gothic"/>
                 <a:ea typeface="Yu Gothic"/>
               </a:rPr>
-              <a:t>04. 研究方法</a:t>
-            </a:r>
-          </a:p>
-          <a:p>
-            <a:pPr>
-              <a:spcBef>
-                <a:spcPts val="0"/>
-              </a:spcBef>
-              <a:spcAft>
-                <a:spcPts val="0"/>
-              </a:spcAft>
-            </a:pPr>
-            <a:r>
-              <a:rPr b="1">
-                <a:solidFill>
-                  <a:srgbClr val="000F78"/>
-                </a:solidFill>
-                <a:latin typeface="Yu Gothic"/>
-                <a:ea typeface="Yu Gothic"/>
-              </a:rPr>
-              <a:t>4-1. アプローチ：能動的に同期して平均する</a:t>
+              <a:t>06. 考察と今後の展望</a:t>
             </a:r>
           </a:p>
         </p:txBody>
@@ -7198,7 +7246,7 @@
                 <a:latin typeface="Yu Gothic"/>
                 <a:ea typeface="Yu Gothic"/>
               </a:rPr>
-              <a:t>平均には各発振器の位相が揃うことが前提</a:t>
+              <a:t>現状：実測モデルに基づくFBで近傍位相雑音を注入せず同期を実現</a:t>
             </a:r>
           </a:p>
           <a:p>
@@ -7208,7 +7256,7 @@
                 <a:latin typeface="Yu Gothic"/>
                 <a:ea typeface="Yu Gothic"/>
               </a:rPr>
-              <a:t>本研究の方式：能動的フィードバックで実時間同期し、出力を平均する</a:t>
+              <a:t>Step1：二つのOCXOの平均に対して同期させる</a:t>
             </a:r>
           </a:p>
           <a:p>
@@ -7218,7 +7266,17 @@
                 <a:latin typeface="Yu Gothic"/>
                 <a:ea typeface="Yu Gothic"/>
               </a:rPr>
-              <a:t>同期を『雑音を加えずに』行うことが中核課題</a:t>
+              <a:t>Step2：同期したOCXOを合成器で平均し測定</a:t>
+            </a:r>
+          </a:p>
+          <a:p>
+            <a:pPr/>
+            <a:r>
+              <a:rPr>
+                <a:latin typeface="Yu Gothic"/>
+                <a:ea typeface="Yu Gothic"/>
+              </a:rPr>
+              <a:t>Step3：N台へ拡張</a:t>
             </a:r>
           </a:p>
         </p:txBody>
@@ -7284,207 +7342,7 @@
                 <a:latin typeface="Yu Gothic"/>
                 <a:ea typeface="Yu Gothic"/>
               </a:rPr>
-              <a:t>互いに無相関な雑音は平均で打ち消し合う。位相を揃えた複数OCXOの出力を能動的フィードバックで実時間に同期・平均し、単体を超える純度を実現する（国際原子時のクロックアンサンブルを小規模・実時間で適用）。</a:t>
-            </a:r>
-          </a:p>
-        </p:txBody>
-      </p:sp>
-      <p:pic>
-        <p:nvPicPr>
-          <p:cNvPr id="5" name="Picture 4" descr="image.png"/>
-          <p:cNvPicPr>
-            <a:picLocks noChangeAspect="1"/>
-          </p:cNvPicPr>
-          <p:nvPr/>
-        </p:nvPicPr>
-        <p:blipFill>
-          <a:blip r:embed="rId2"/>
-          <a:stretch>
-            <a:fillRect/>
-          </a:stretch>
-        </p:blipFill>
-        <p:spPr>
-          <a:xfrm>
-            <a:off x="5074920" y="2968671"/>
-            <a:ext cx="4526280" cy="2292256"/>
-          </a:xfrm>
-          <a:prstGeom prst="rect">
-            <a:avLst/>
-          </a:prstGeom>
-        </p:spPr>
-      </p:pic>
-    </p:spTree>
-  </p:cSld>
-  <p:clrMapOvr>
-    <a:masterClrMapping/>
-  </p:clrMapOvr>
-</p:sld>
-</file>
-
-<file path=ppt/slides/slide19.xml><?xml version="1.0" encoding="utf-8"?>
-<p:sld xmlns:a="http://schemas.openxmlformats.org/drawingml/2006/main" xmlns:p="http://schemas.openxmlformats.org/presentationml/2006/main" xmlns:r="http://schemas.openxmlformats.org/officeDocument/2006/relationships">
-  <p:cSld>
-    <p:spTree>
-      <p:nvGrpSpPr>
-        <p:cNvPr id="1" name=""/>
-        <p:cNvGrpSpPr/>
-        <p:nvPr/>
-      </p:nvGrpSpPr>
-      <p:grpSpPr/>
-      <p:sp>
-        <p:nvSpPr>
-          <p:cNvPr id="2" name="Title 1"/>
-          <p:cNvSpPr>
-            <a:spLocks noGrp="1"/>
-          </p:cNvSpPr>
-          <p:nvPr>
-            <p:ph type="title"/>
-          </p:nvPr>
-        </p:nvSpPr>
-        <p:spPr>
-          <a:xfrm>
-            <a:off x="228600" y="237744"/>
-            <a:ext cx="9473184" cy="969264"/>
-          </a:xfrm>
-        </p:spPr>
-        <p:txBody>
-          <a:bodyPr/>
-          <a:lstStyle/>
-          <a:p>
-            <a:pPr>
-              <a:spcBef>
-                <a:spcPts val="0"/>
-              </a:spcBef>
-              <a:spcAft>
-                <a:spcPts val="0"/>
-              </a:spcAft>
-            </a:pPr>
-            <a:r>
-              <a:rPr sz="1400" b="1">
-                <a:solidFill>
-                  <a:srgbClr val="000F78"/>
-                </a:solidFill>
-                <a:latin typeface="Yu Gothic"/>
-                <a:ea typeface="Yu Gothic"/>
-              </a:rPr>
-              <a:t>04. 研究方法</a:t>
-            </a:r>
-          </a:p>
-          <a:p>
-            <a:pPr>
-              <a:spcBef>
-                <a:spcPts val="0"/>
-              </a:spcBef>
-              <a:spcAft>
-                <a:spcPts val="0"/>
-              </a:spcAft>
-            </a:pPr>
-            <a:r>
-              <a:rPr b="1">
-                <a:solidFill>
-                  <a:srgbClr val="000F78"/>
-                </a:solidFill>
-                <a:latin typeface="Yu Gothic"/>
-                <a:ea typeface="Yu Gothic"/>
-              </a:rPr>
-              <a:t>4-2. 実験系</a:t>
-            </a:r>
-          </a:p>
-        </p:txBody>
-      </p:sp>
-      <p:sp>
-        <p:nvSpPr>
-          <p:cNvPr id="3" name="Text Placeholder 2"/>
-          <p:cNvSpPr>
-            <a:spLocks noGrp="1"/>
-          </p:cNvSpPr>
-          <p:nvPr>
-            <p:ph type="body" idx="1"/>
-          </p:nvPr>
-        </p:nvSpPr>
-        <p:spPr>
-          <a:xfrm>
-            <a:off x="274320" y="2212848"/>
-            <a:ext cx="4526280" cy="4297680"/>
-          </a:xfrm>
-        </p:spPr>
-        <p:txBody>
-          <a:bodyPr wrap="square"/>
-          <a:lstStyle/>
-          <a:p>
-            <a:pPr/>
-            <a:r>
-              <a:rPr>
-                <a:latin typeface="Yu Gothic"/>
-                <a:ea typeface="Yu Gothic"/>
-              </a:rPr>
-              <a:t>制御系統（オシロ FRFR）と精度評価系統（録音→ヒルベルト変換）の二系統で構成</a:t>
-            </a:r>
-          </a:p>
-        </p:txBody>
-      </p:sp>
-      <p:sp>
-        <p:nvSpPr>
-          <p:cNvPr id="4" name="Rounded Rectangle 3"/>
-          <p:cNvSpPr/>
-          <p:nvPr/>
-        </p:nvSpPr>
-        <p:spPr>
-          <a:xfrm>
-            <a:off x="274320" y="1335024"/>
-            <a:ext cx="9354312" cy="731520"/>
-          </a:xfrm>
-          <a:prstGeom prst="roundRect">
-            <a:avLst>
-              <a:gd name="adj" fmla="val 8000"/>
-            </a:avLst>
-          </a:prstGeom>
-          <a:solidFill>
-            <a:srgbClr val="EAEFF7"/>
-          </a:solidFill>
-          <a:ln>
-            <a:noFill/>
-          </a:ln>
-          <a:effectLst/>
-        </p:spPr>
-        <p:style>
-          <a:lnRef idx="1">
-            <a:schemeClr val="accent1"/>
-          </a:lnRef>
-          <a:fillRef idx="3">
-            <a:schemeClr val="accent1"/>
-          </a:fillRef>
-          <a:effectRef idx="2">
-            <a:schemeClr val="accent1"/>
-          </a:effectRef>
-          <a:fontRef idx="minor">
-            <a:schemeClr val="lt1"/>
-          </a:fontRef>
-        </p:style>
-        <p:txBody>
-          <a:bodyPr rtlCol="0" anchor="ctr" wrap="square" lIns="127000" rIns="127000" tIns="25400" bIns="25400"/>
-          <a:lstStyle/>
-          <a:p>
-            <a:pPr algn="ctr"/>
-            <a:r>
-              <a:rPr sz="1100" b="1">
-                <a:solidFill>
-                  <a:srgbClr val="B03010"/>
-                </a:solidFill>
-                <a:latin typeface="Yu Gothic"/>
-                <a:ea typeface="Yu Gothic"/>
-              </a:rPr>
-              <a:t>結論  </a:t>
-            </a:r>
-            <a:r>
-              <a:rPr sz="1300" b="1">
-                <a:solidFill>
-                  <a:srgbClr val="1B2A5A"/>
-                </a:solidFill>
-                <a:latin typeface="Yu Gothic"/>
-                <a:ea typeface="Yu Gothic"/>
-              </a:rPr>
-              <a:t>OCXO2台に対し、位相差FRFRをターゲットとしてオシロスコープで計測。計測結果を基に片方のOCXOへフィードバック電圧を印加する。</a:t>
+              <a:t>フィードバック制御により、近傍位相雑音（同期動作に伴う短期の位相ゆらぎ）を持ち込まずに同期させることに成功した。今後は2台を同時制御・合成器で平均して −3 dB を実証し、N台へ拡張する。</a:t>
             </a:r>
           </a:p>
         </p:txBody>
@@ -7540,9 +7398,8 @@
                 <a:latin typeface="Yu Gothic"/>
                 <a:ea typeface="Yu Gothic"/>
               </a:rPr>
-              <a:t>実験系ブロック図
-（image1.png を白黒で清書。
-FB→OCXO 帰還矢印・PC(MATLAB) ラベルを追記）</a:t>
+              <a:t>今後のロードマップ
+片方向同期 → 平均で −3 dB → N台 → 双方向結合</a:t>
             </a:r>
           </a:p>
         </p:txBody>
@@ -8221,7 +8078,7 @@
                   <a:cs typeface="Arial"/>
                   <a:sym typeface="Arial"/>
                 </a:rPr>
-                <a:t> </a:t>
+                <a:t>先行研究</a:t>
               </a:r>
               <a:r>
                 <a:rPr lang="ja-JP" altLang="en-US" sz="2000" b="1" i="0" u="none" strike="noStrike" cap="none">
@@ -8233,7 +8090,7 @@
                   <a:cs typeface="Arial"/>
                   <a:sym typeface="Arial"/>
                 </a:rPr>
-                <a:t>研究方法</a:t>
+                <a:t/>
               </a:r>
               <a:endParaRPr lang="en-US" altLang="ja-JP" sz="2000" b="1" i="0" u="none" strike="noStrike" cap="none" dirty="0">
                 <a:solidFill>
@@ -8495,7 +8352,7 @@
                   <a:cs typeface="Arial"/>
                   <a:sym typeface="Arial"/>
                 </a:rPr>
-                <a:t> </a:t>
+                <a:t>研究方法</a:t>
               </a:r>
               <a:r>
                 <a:rPr lang="ja-JP" altLang="en-US" sz="2000" b="1" i="0" u="none" strike="noStrike" cap="none">
@@ -8507,7 +8364,7 @@
                   <a:cs typeface="Arial"/>
                   <a:sym typeface="Arial"/>
                 </a:rPr>
-                <a:t>実験と結果</a:t>
+                <a:t/>
               </a:r>
               <a:endParaRPr lang="en-US" altLang="ja-JP" sz="2000" b="1" i="0" u="none" strike="noStrike" cap="none" dirty="0">
                 <a:solidFill>
@@ -8769,7 +8626,7 @@
                   <a:cs typeface="Arial"/>
                   <a:sym typeface="Arial"/>
                 </a:rPr>
-                <a:t> </a:t>
+                <a:t>実験と結果</a:t>
               </a:r>
               <a:r>
                 <a:rPr lang="ja-JP" altLang="en-US" sz="2000" b="1">
@@ -8777,7 +8634,7 @@
                     <a:schemeClr val="dk1"/>
                   </a:solidFill>
                 </a:rPr>
-                <a:t>考察と今後の展望</a:t>
+                <a:t/>
               </a:r>
               <a:endParaRPr lang="en-US" altLang="ja-JP" sz="2000" b="1" i="0" u="none" strike="noStrike" cap="none" dirty="0">
                 <a:solidFill>
@@ -9372,7 +9229,7 @@
                   <a:cs typeface="Arial"/>
                   <a:sym typeface="Arial"/>
                 </a:rPr>
-                <a:t> </a:t>
+                <a:t>考察と今後の展望</a:t>
               </a:r>
               <a:r>
                 <a:rPr lang="en-US" altLang="ja-JP" sz="2000" b="1" i="0" u="none" strike="noStrike" cap="none" dirty="0">
@@ -9384,7 +9241,7 @@
                   <a:cs typeface="Arial"/>
                   <a:sym typeface="Arial"/>
                 </a:rPr>
-                <a:t>Appendix</a:t>
+                <a:t/>
               </a:r>
             </a:p>
           </p:txBody>
@@ -9396,1160 +9253,6 @@
         <p14:creationId xmlns:p14="http://schemas.microsoft.com/office/powerpoint/2010/main" val="3626579769"/>
       </p:ext>
     </p:extLst>
-  </p:cSld>
-  <p:clrMapOvr>
-    <a:masterClrMapping/>
-  </p:clrMapOvr>
-</p:sld>
-</file>
-
-<file path=ppt/slides/slide20.xml><?xml version="1.0" encoding="utf-8"?>
-<p:sld xmlns:a="http://schemas.openxmlformats.org/drawingml/2006/main" xmlns:p="http://schemas.openxmlformats.org/presentationml/2006/main" xmlns:r="http://schemas.openxmlformats.org/officeDocument/2006/relationships">
-  <p:cSld>
-    <p:spTree>
-      <p:nvGrpSpPr>
-        <p:cNvPr id="1" name=""/>
-        <p:cNvGrpSpPr/>
-        <p:nvPr/>
-      </p:nvGrpSpPr>
-      <p:grpSpPr/>
-      <p:sp>
-        <p:nvSpPr>
-          <p:cNvPr id="2" name="Title 1"/>
-          <p:cNvSpPr>
-            <a:spLocks noGrp="1"/>
-          </p:cNvSpPr>
-          <p:nvPr>
-            <p:ph type="title"/>
-          </p:nvPr>
-        </p:nvSpPr>
-        <p:spPr>
-          <a:xfrm>
-            <a:off x="228600" y="237744"/>
-            <a:ext cx="9473184" cy="969264"/>
-          </a:xfrm>
-        </p:spPr>
-        <p:txBody>
-          <a:bodyPr/>
-          <a:lstStyle/>
-          <a:p>
-            <a:pPr>
-              <a:spcBef>
-                <a:spcPts val="0"/>
-              </a:spcBef>
-              <a:spcAft>
-                <a:spcPts val="0"/>
-              </a:spcAft>
-            </a:pPr>
-            <a:r>
-              <a:rPr sz="1400" b="1">
-                <a:solidFill>
-                  <a:srgbClr val="000F78"/>
-                </a:solidFill>
-                <a:latin typeface="Yu Gothic"/>
-                <a:ea typeface="Yu Gothic"/>
-              </a:rPr>
-              <a:t>04. 研究方法</a:t>
-            </a:r>
-          </a:p>
-          <a:p>
-            <a:pPr>
-              <a:spcBef>
-                <a:spcPts val="0"/>
-              </a:spcBef>
-              <a:spcAft>
-                <a:spcPts val="0"/>
-              </a:spcAft>
-            </a:pPr>
-            <a:r>
-              <a:rPr b="1">
-                <a:solidFill>
-                  <a:srgbClr val="000F78"/>
-                </a:solidFill>
-                <a:latin typeface="Yu Gothic"/>
-                <a:ea typeface="Yu Gothic"/>
-              </a:rPr>
-              <a:t>4-3. 測定法：オーディオレコーダを使う理由</a:t>
-            </a:r>
-          </a:p>
-        </p:txBody>
-      </p:sp>
-      <p:sp>
-        <p:nvSpPr>
-          <p:cNvPr id="3" name="Text Placeholder 2"/>
-          <p:cNvSpPr>
-            <a:spLocks noGrp="1"/>
-          </p:cNvSpPr>
-          <p:nvPr>
-            <p:ph type="body" idx="1"/>
-          </p:nvPr>
-        </p:nvSpPr>
-        <p:spPr>
-          <a:xfrm>
-            <a:off x="274320" y="2212848"/>
-            <a:ext cx="4526280" cy="4297680"/>
-          </a:xfrm>
-        </p:spPr>
-        <p:txBody>
-          <a:bodyPr wrap="square"/>
-          <a:lstStyle/>
-          <a:p>
-            <a:pPr/>
-            <a:r>
-              <a:rPr>
-                <a:latin typeface="Yu Gothic"/>
-                <a:ea typeface="Yu Gothic"/>
-              </a:rPr>
-              <a:t>オシロの FRFR は精度が要る／録音は高精度・長時間測定が可能</a:t>
-            </a:r>
-          </a:p>
-          <a:p>
-            <a:pPr/>
-            <a:r>
-              <a:rPr>
-                <a:latin typeface="Yu Gothic"/>
-                <a:ea typeface="Yu Gothic"/>
-              </a:rPr>
-              <a:t>卒論で確立した測定法を継承</a:t>
-            </a:r>
-          </a:p>
-        </p:txBody>
-      </p:sp>
-      <p:sp>
-        <p:nvSpPr>
-          <p:cNvPr id="4" name="Rounded Rectangle 3"/>
-          <p:cNvSpPr/>
-          <p:nvPr/>
-        </p:nvSpPr>
-        <p:spPr>
-          <a:xfrm>
-            <a:off x="274320" y="1335024"/>
-            <a:ext cx="9354312" cy="731520"/>
-          </a:xfrm>
-          <a:prstGeom prst="roundRect">
-            <a:avLst>
-              <a:gd name="adj" fmla="val 8000"/>
-            </a:avLst>
-          </a:prstGeom>
-          <a:solidFill>
-            <a:srgbClr val="EAEFF7"/>
-          </a:solidFill>
-          <a:ln>
-            <a:noFill/>
-          </a:ln>
-          <a:effectLst/>
-        </p:spPr>
-        <p:style>
-          <a:lnRef idx="1">
-            <a:schemeClr val="accent1"/>
-          </a:lnRef>
-          <a:fillRef idx="3">
-            <a:schemeClr val="accent1"/>
-          </a:fillRef>
-          <a:effectRef idx="2">
-            <a:schemeClr val="accent1"/>
-          </a:effectRef>
-          <a:fontRef idx="minor">
-            <a:schemeClr val="lt1"/>
-          </a:fontRef>
-        </p:style>
-        <p:txBody>
-          <a:bodyPr rtlCol="0" anchor="ctr" wrap="square" lIns="127000" rIns="127000" tIns="25400" bIns="25400"/>
-          <a:lstStyle/>
-          <a:p>
-            <a:pPr algn="ctr"/>
-            <a:r>
-              <a:rPr sz="1100" b="1">
-                <a:solidFill>
-                  <a:srgbClr val="B03010"/>
-                </a:solidFill>
-                <a:latin typeface="Yu Gothic"/>
-                <a:ea typeface="Yu Gothic"/>
-              </a:rPr>
-              <a:t>結論  </a:t>
-            </a:r>
-            <a:r>
-              <a:rPr sz="1300" b="1">
-                <a:solidFill>
-                  <a:srgbClr val="1B2A5A"/>
-                </a:solidFill>
-                <a:latin typeface="Yu Gothic"/>
-                <a:ea typeface="Yu Gothic"/>
-              </a:rPr>
-              <a:t>オーディオレコーディングは高分解能（10秒測定で std 20–30 ps）かつ長時間測定が可能で、0.1–1 Hz の評価に向いている。</a:t>
-            </a:r>
-          </a:p>
-        </p:txBody>
-      </p:sp>
-      <p:sp>
-        <p:nvSpPr>
-          <p:cNvPr id="5" name="Rounded Rectangle 4"/>
-          <p:cNvSpPr/>
-          <p:nvPr/>
-        </p:nvSpPr>
-        <p:spPr>
-          <a:xfrm>
-            <a:off x="5074920" y="2286000"/>
-            <a:ext cx="4526280" cy="3566160"/>
-          </a:xfrm>
-          <a:prstGeom prst="roundRect">
-            <a:avLst/>
-          </a:prstGeom>
-          <a:solidFill>
-            <a:srgbClr val="F2F2F2"/>
-          </a:solidFill>
-          <a:ln w="12700">
-            <a:solidFill>
-              <a:srgbClr val="595959"/>
-            </a:solidFill>
-          </a:ln>
-          <a:effectLst/>
-        </p:spPr>
-        <p:style>
-          <a:lnRef idx="1">
-            <a:schemeClr val="accent1"/>
-          </a:lnRef>
-          <a:fillRef idx="3">
-            <a:schemeClr val="accent1"/>
-          </a:fillRef>
-          <a:effectRef idx="2">
-            <a:schemeClr val="accent1"/>
-          </a:effectRef>
-          <a:fontRef idx="minor">
-            <a:schemeClr val="lt1"/>
-          </a:fontRef>
-        </p:style>
-        <p:txBody>
-          <a:bodyPr rtlCol="0" anchor="ctr" wrap="square"/>
-          <a:lstStyle/>
-          <a:p>
-            <a:pPr algn="ctr"/>
-            <a:r>
-              <a:rPr sz="1200">
-                <a:solidFill>
-                  <a:srgbClr val="595959"/>
-                </a:solidFill>
-                <a:latin typeface="Yu Gothic"/>
-                <a:ea typeface="Yu Gothic"/>
-              </a:rPr>
-              <a:t>録音系統図・分周・サンプル数比較表
-（卒論PPTXの該当図を流用）</a:t>
-            </a:r>
-          </a:p>
-        </p:txBody>
-      </p:sp>
-    </p:spTree>
-  </p:cSld>
-  <p:clrMapOvr>
-    <a:masterClrMapping/>
-  </p:clrMapOvr>
-</p:sld>
-</file>
-
-<file path=ppt/slides/slide21.xml><?xml version="1.0" encoding="utf-8"?>
-<p:sld xmlns:a="http://schemas.openxmlformats.org/drawingml/2006/main" xmlns:p="http://schemas.openxmlformats.org/presentationml/2006/main" xmlns:r="http://schemas.openxmlformats.org/officeDocument/2006/relationships">
-  <p:cSld>
-    <p:spTree>
-      <p:nvGrpSpPr>
-        <p:cNvPr id="1" name=""/>
-        <p:cNvGrpSpPr/>
-        <p:nvPr/>
-      </p:nvGrpSpPr>
-      <p:grpSpPr/>
-      <p:sp>
-        <p:nvSpPr>
-          <p:cNvPr id="2" name="Title 1"/>
-          <p:cNvSpPr>
-            <a:spLocks noGrp="1"/>
-          </p:cNvSpPr>
-          <p:nvPr>
-            <p:ph type="title"/>
-          </p:nvPr>
-        </p:nvSpPr>
-        <p:spPr>
-          <a:xfrm>
-            <a:off x="228600" y="237744"/>
-            <a:ext cx="9473184" cy="969264"/>
-          </a:xfrm>
-        </p:spPr>
-        <p:txBody>
-          <a:bodyPr/>
-          <a:lstStyle/>
-          <a:p>
-            <a:pPr>
-              <a:spcBef>
-                <a:spcPts val="0"/>
-              </a:spcBef>
-              <a:spcAft>
-                <a:spcPts val="0"/>
-              </a:spcAft>
-            </a:pPr>
-            <a:r>
-              <a:rPr sz="1400" b="1">
-                <a:solidFill>
-                  <a:srgbClr val="000F78"/>
-                </a:solidFill>
-                <a:latin typeface="Yu Gothic"/>
-                <a:ea typeface="Yu Gothic"/>
-              </a:rPr>
-              <a:t>04. 研究方法</a:t>
-            </a:r>
-          </a:p>
-          <a:p>
-            <a:pPr>
-              <a:spcBef>
-                <a:spcPts val="0"/>
-              </a:spcBef>
-              <a:spcAft>
-                <a:spcPts val="0"/>
-              </a:spcAft>
-            </a:pPr>
-            <a:r>
-              <a:rPr b="1">
-                <a:solidFill>
-                  <a:srgbClr val="000F78"/>
-                </a:solidFill>
-                <a:latin typeface="Yu Gothic"/>
-                <a:ea typeface="Yu Gothic"/>
-              </a:rPr>
-              <a:t>4-4. 予備実験：フィードバック電圧の感応度同定</a:t>
-            </a:r>
-          </a:p>
-        </p:txBody>
-      </p:sp>
-      <p:sp>
-        <p:nvSpPr>
-          <p:cNvPr id="3" name="Text Placeholder 2"/>
-          <p:cNvSpPr>
-            <a:spLocks noGrp="1"/>
-          </p:cNvSpPr>
-          <p:nvPr>
-            <p:ph type="body" idx="1"/>
-          </p:nvPr>
-        </p:nvSpPr>
-        <p:spPr>
-          <a:xfrm>
-            <a:off x="274320" y="2212848"/>
-            <a:ext cx="4526280" cy="4297680"/>
-          </a:xfrm>
-        </p:spPr>
-        <p:txBody>
-          <a:bodyPr wrap="square"/>
-          <a:lstStyle/>
-          <a:p>
-            <a:pPr/>
-            <a:r>
-              <a:rPr>
-                <a:latin typeface="Yu Gothic"/>
-                <a:ea typeface="Yu Gothic"/>
-              </a:rPr>
-              <a:t>1 LSB（≈305 µV）ずつ階段状に電圧を変え、各段の FRFR 傾きを電圧増分に直線回帰</a:t>
-            </a:r>
-          </a:p>
-          <a:p>
-            <a:pPr/>
-            <a:r>
-              <a:rPr>
-                <a:latin typeface="Yu Gothic"/>
-                <a:ea typeface="Yu Gothic"/>
-              </a:rPr>
-              <a:t>→ プラントゲイン K≈860 ns/(V·s) が得られた</a:t>
-            </a:r>
-          </a:p>
-        </p:txBody>
-      </p:sp>
-      <p:sp>
-        <p:nvSpPr>
-          <p:cNvPr id="4" name="Rounded Rectangle 3"/>
-          <p:cNvSpPr/>
-          <p:nvPr/>
-        </p:nvSpPr>
-        <p:spPr>
-          <a:xfrm>
-            <a:off x="274320" y="1335024"/>
-            <a:ext cx="9354312" cy="731520"/>
-          </a:xfrm>
-          <a:prstGeom prst="roundRect">
-            <a:avLst>
-              <a:gd name="adj" fmla="val 8000"/>
-            </a:avLst>
-          </a:prstGeom>
-          <a:solidFill>
-            <a:srgbClr val="EAEFF7"/>
-          </a:solidFill>
-          <a:ln>
-            <a:noFill/>
-          </a:ln>
-          <a:effectLst/>
-        </p:spPr>
-        <p:style>
-          <a:lnRef idx="1">
-            <a:schemeClr val="accent1"/>
-          </a:lnRef>
-          <a:fillRef idx="3">
-            <a:schemeClr val="accent1"/>
-          </a:fillRef>
-          <a:effectRef idx="2">
-            <a:schemeClr val="accent1"/>
-          </a:effectRef>
-          <a:fontRef idx="minor">
-            <a:schemeClr val="lt1"/>
-          </a:fontRef>
-        </p:style>
-        <p:txBody>
-          <a:bodyPr rtlCol="0" anchor="ctr" wrap="square" lIns="127000" rIns="127000" tIns="25400" bIns="25400"/>
-          <a:lstStyle/>
-          <a:p>
-            <a:pPr algn="ctr"/>
-            <a:r>
-              <a:rPr sz="1100" b="1">
-                <a:solidFill>
-                  <a:srgbClr val="B03010"/>
-                </a:solidFill>
-                <a:latin typeface="Yu Gothic"/>
-                <a:ea typeface="Yu Gothic"/>
-              </a:rPr>
-              <a:t>結論  </a:t>
-            </a:r>
-            <a:r>
-              <a:rPr sz="1300" b="1">
-                <a:solidFill>
-                  <a:srgbClr val="1B2A5A"/>
-                </a:solidFill>
-                <a:latin typeface="Yu Gothic"/>
-                <a:ea typeface="Yu Gothic"/>
-              </a:rPr>
-              <a:t>フィードバック電圧のLSBを測定し回帰検証することで、フィードバックロジックのパラメータをチューニングした。</a:t>
-            </a:r>
-          </a:p>
-        </p:txBody>
-      </p:sp>
-      <p:pic>
-        <p:nvPicPr>
-          <p:cNvPr id="5" name="Picture 4" descr="image.png"/>
-          <p:cNvPicPr>
-            <a:picLocks noChangeAspect="1"/>
-          </p:cNvPicPr>
-          <p:nvPr/>
-        </p:nvPicPr>
-        <p:blipFill>
-          <a:blip r:embed="rId2"/>
-          <a:stretch>
-            <a:fillRect/>
-          </a:stretch>
-        </p:blipFill>
-        <p:spPr>
-          <a:xfrm>
-            <a:off x="5074920" y="2860414"/>
-            <a:ext cx="4526280" cy="2508770"/>
-          </a:xfrm>
-          <a:prstGeom prst="rect">
-            <a:avLst/>
-          </a:prstGeom>
-        </p:spPr>
-      </p:pic>
-    </p:spTree>
-  </p:cSld>
-  <p:clrMapOvr>
-    <a:masterClrMapping/>
-  </p:clrMapOvr>
-</p:sld>
-</file>
-
-<file path=ppt/slides/slide22.xml><?xml version="1.0" encoding="utf-8"?>
-<p:sld xmlns:a="http://schemas.openxmlformats.org/drawingml/2006/main" xmlns:p="http://schemas.openxmlformats.org/presentationml/2006/main" xmlns:r="http://schemas.openxmlformats.org/officeDocument/2006/relationships">
-  <p:cSld>
-    <p:spTree>
-      <p:nvGrpSpPr>
-        <p:cNvPr id="1" name=""/>
-        <p:cNvGrpSpPr/>
-        <p:nvPr/>
-      </p:nvGrpSpPr>
-      <p:grpSpPr/>
-      <p:sp>
-        <p:nvSpPr>
-          <p:cNvPr id="2" name="Title 1"/>
-          <p:cNvSpPr>
-            <a:spLocks noGrp="1"/>
-          </p:cNvSpPr>
-          <p:nvPr>
-            <p:ph type="title"/>
-          </p:nvPr>
-        </p:nvSpPr>
-        <p:spPr>
-          <a:xfrm>
-            <a:off x="228600" y="237744"/>
-            <a:ext cx="9473184" cy="969264"/>
-          </a:xfrm>
-        </p:spPr>
-        <p:txBody>
-          <a:bodyPr/>
-          <a:lstStyle/>
-          <a:p>
-            <a:pPr>
-              <a:spcBef>
-                <a:spcPts val="0"/>
-              </a:spcBef>
-              <a:spcAft>
-                <a:spcPts val="0"/>
-              </a:spcAft>
-            </a:pPr>
-            <a:r>
-              <a:rPr sz="1400" b="1">
-                <a:solidFill>
-                  <a:srgbClr val="000F78"/>
-                </a:solidFill>
-                <a:latin typeface="Yu Gothic"/>
-                <a:ea typeface="Yu Gothic"/>
-              </a:rPr>
-              <a:t>04. 研究方法</a:t>
-            </a:r>
-          </a:p>
-          <a:p>
-            <a:pPr>
-              <a:spcBef>
-                <a:spcPts val="0"/>
-              </a:spcBef>
-              <a:spcAft>
-                <a:spcPts val="0"/>
-              </a:spcAft>
-            </a:pPr>
-            <a:r>
-              <a:rPr b="1">
-                <a:solidFill>
-                  <a:srgbClr val="000F78"/>
-                </a:solidFill>
-                <a:latin typeface="Yu Gothic"/>
-                <a:ea typeface="Yu Gothic"/>
-              </a:rPr>
-              <a:t>4-5. フィードバックロジック</a:t>
-            </a:r>
-          </a:p>
-        </p:txBody>
-      </p:sp>
-      <p:sp>
-        <p:nvSpPr>
-          <p:cNvPr id="3" name="Text Placeholder 2"/>
-          <p:cNvSpPr>
-            <a:spLocks noGrp="1"/>
-          </p:cNvSpPr>
-          <p:nvPr>
-            <p:ph type="body" idx="1"/>
-          </p:nvPr>
-        </p:nvSpPr>
-        <p:spPr>
-          <a:xfrm>
-            <a:off x="274320" y="2212848"/>
-            <a:ext cx="4526280" cy="4297680"/>
-          </a:xfrm>
-        </p:spPr>
-        <p:txBody>
-          <a:bodyPr wrap="square"/>
-          <a:lstStyle/>
-          <a:p>
-            <a:pPr/>
-            <a:r>
-              <a:rPr>
-                <a:latin typeface="Yu Gothic"/>
-                <a:ea typeface="Yu Gothic"/>
-              </a:rPr>
-              <a:t>出自：ACC（車両追従制御）の状態方程式を波動系へ置き換え</a:t>
-            </a:r>
-          </a:p>
-          <a:p>
-            <a:pPr/>
-            <a:r>
-              <a:rPr>
-                <a:latin typeface="Yu Gothic"/>
-                <a:ea typeface="Yu Gothic"/>
-              </a:rPr>
-              <a:t>更新：Δf_des=clamp(Kp_e·e) → 必要段数 dN=round(...) → 電圧更新</a:t>
-            </a:r>
-          </a:p>
-          <a:p>
-            <a:pPr/>
-            <a:r>
-              <a:rPr>
-                <a:latin typeface="Yu Gothic"/>
-                <a:ea typeface="Yu Gothic"/>
-              </a:rPr>
-              <a:t>不感帯で静かに同期。比例・微分（PID）は過剰動作で短期雑音（対比）</a:t>
-            </a:r>
-          </a:p>
-        </p:txBody>
-      </p:sp>
-      <p:sp>
-        <p:nvSpPr>
-          <p:cNvPr id="4" name="Rounded Rectangle 3"/>
-          <p:cNvSpPr/>
-          <p:nvPr/>
-        </p:nvSpPr>
-        <p:spPr>
-          <a:xfrm>
-            <a:off x="274320" y="1335024"/>
-            <a:ext cx="9354312" cy="731520"/>
-          </a:xfrm>
-          <a:prstGeom prst="roundRect">
-            <a:avLst>
-              <a:gd name="adj" fmla="val 8000"/>
-            </a:avLst>
-          </a:prstGeom>
-          <a:solidFill>
-            <a:srgbClr val="EAEFF7"/>
-          </a:solidFill>
-          <a:ln>
-            <a:noFill/>
-          </a:ln>
-          <a:effectLst/>
-        </p:spPr>
-        <p:style>
-          <a:lnRef idx="1">
-            <a:schemeClr val="accent1"/>
-          </a:lnRef>
-          <a:fillRef idx="3">
-            <a:schemeClr val="accent1"/>
-          </a:fillRef>
-          <a:effectRef idx="2">
-            <a:schemeClr val="accent1"/>
-          </a:effectRef>
-          <a:fontRef idx="minor">
-            <a:schemeClr val="lt1"/>
-          </a:fontRef>
-        </p:style>
-        <p:txBody>
-          <a:bodyPr rtlCol="0" anchor="ctr" wrap="square" lIns="127000" rIns="127000" tIns="25400" bIns="25400"/>
-          <a:lstStyle/>
-          <a:p>
-            <a:pPr algn="ctr"/>
-            <a:r>
-              <a:rPr sz="1100" b="1">
-                <a:solidFill>
-                  <a:srgbClr val="B03010"/>
-                </a:solidFill>
-                <a:latin typeface="Yu Gothic"/>
-                <a:ea typeface="Yu Gothic"/>
-              </a:rPr>
-              <a:t>結論  </a:t>
-            </a:r>
-            <a:r>
-              <a:rPr sz="1300" b="1">
-                <a:solidFill>
-                  <a:srgbClr val="1B2A5A"/>
-                </a:solidFill>
-                <a:latin typeface="Yu Gothic"/>
-                <a:ea typeface="Yu Gothic"/>
-              </a:rPr>
-              <a:t>位相のズレ e と周波数のズレ Δf を使う2状態フィードバックで、必要な分だけ電圧を動かす（1 LSB 未満は動かさない＝不感帯）。同期動作そのものが位相雑音を持ち込まない。</a:t>
-            </a:r>
-          </a:p>
-        </p:txBody>
-      </p:sp>
-      <p:pic>
-        <p:nvPicPr>
-          <p:cNvPr id="5" name="Picture 4" descr="image.png"/>
-          <p:cNvPicPr>
-            <a:picLocks noChangeAspect="1"/>
-          </p:cNvPicPr>
-          <p:nvPr/>
-        </p:nvPicPr>
-        <p:blipFill>
-          <a:blip r:embed="rId2"/>
-          <a:stretch>
-            <a:fillRect/>
-          </a:stretch>
-        </p:blipFill>
-        <p:spPr>
-          <a:xfrm>
-            <a:off x="5074920" y="2288603"/>
-            <a:ext cx="4526280" cy="1732152"/>
-          </a:xfrm>
-          <a:prstGeom prst="rect">
-            <a:avLst/>
-          </a:prstGeom>
-        </p:spPr>
-      </p:pic>
-      <p:pic>
-        <p:nvPicPr>
-          <p:cNvPr id="6" name="Picture 5" descr="image.png"/>
-          <p:cNvPicPr>
-            <a:picLocks noChangeAspect="1"/>
-          </p:cNvPicPr>
-          <p:nvPr/>
-        </p:nvPicPr>
-        <p:blipFill>
-          <a:blip r:embed="rId3"/>
-          <a:stretch>
-            <a:fillRect/>
-          </a:stretch>
-        </p:blipFill>
-        <p:spPr>
-          <a:xfrm>
-            <a:off x="5737325" y="4224528"/>
-            <a:ext cx="3201469" cy="1810512"/>
-          </a:xfrm>
-          <a:prstGeom prst="rect">
-            <a:avLst/>
-          </a:prstGeom>
-        </p:spPr>
-      </p:pic>
-    </p:spTree>
-  </p:cSld>
-  <p:clrMapOvr>
-    <a:masterClrMapping/>
-  </p:clrMapOvr>
-</p:sld>
-</file>
-
-<file path=ppt/slides/slide23.xml><?xml version="1.0" encoding="utf-8"?>
-<p:sld xmlns:a="http://schemas.openxmlformats.org/drawingml/2006/main" xmlns:p="http://schemas.openxmlformats.org/presentationml/2006/main" xmlns:r="http://schemas.openxmlformats.org/officeDocument/2006/relationships">
-  <p:cSld>
-    <p:spTree>
-      <p:nvGrpSpPr>
-        <p:cNvPr id="1" name=""/>
-        <p:cNvGrpSpPr/>
-        <p:nvPr/>
-      </p:nvGrpSpPr>
-      <p:grpSpPr/>
-      <p:sp>
-        <p:nvSpPr>
-          <p:cNvPr id="2" name="Title 1"/>
-          <p:cNvSpPr>
-            <a:spLocks noGrp="1"/>
-          </p:cNvSpPr>
-          <p:nvPr>
-            <p:ph type="title"/>
-          </p:nvPr>
-        </p:nvSpPr>
-        <p:spPr>
-          <a:xfrm>
-            <a:off x="228600" y="237744"/>
-            <a:ext cx="9473184" cy="969264"/>
-          </a:xfrm>
-        </p:spPr>
-        <p:txBody>
-          <a:bodyPr/>
-          <a:lstStyle/>
-          <a:p>
-            <a:pPr>
-              <a:spcBef>
-                <a:spcPts val="0"/>
-              </a:spcBef>
-              <a:spcAft>
-                <a:spcPts val="0"/>
-              </a:spcAft>
-            </a:pPr>
-            <a:r>
-              <a:rPr b="1">
-                <a:solidFill>
-                  <a:srgbClr val="000F78"/>
-                </a:solidFill>
-                <a:latin typeface="Yu Gothic"/>
-                <a:ea typeface="Yu Gothic"/>
-              </a:rPr>
-              <a:t>05. 実験と結果</a:t>
-            </a:r>
-          </a:p>
-        </p:txBody>
-      </p:sp>
-      <p:sp>
-        <p:nvSpPr>
-          <p:cNvPr id="3" name="Text Placeholder 2"/>
-          <p:cNvSpPr>
-            <a:spLocks noGrp="1"/>
-          </p:cNvSpPr>
-          <p:nvPr>
-            <p:ph type="body" idx="1"/>
-          </p:nvPr>
-        </p:nvSpPr>
-        <p:spPr>
-          <a:xfrm>
-            <a:off x="274320" y="2212848"/>
-            <a:ext cx="4526280" cy="4297680"/>
-          </a:xfrm>
-        </p:spPr>
-        <p:txBody>
-          <a:bodyPr wrap="square"/>
-          <a:lstStyle/>
-          <a:p>
-            <a:pPr/>
-            <a:r>
-              <a:rPr>
-                <a:latin typeface="Yu Gothic"/>
-                <a:ea typeface="Yu Gothic"/>
-              </a:rPr>
-              <a:t>モデルFB と HOLD の近傍位相雑音がほぼ一致（差≈0 dB）</a:t>
-            </a:r>
-          </a:p>
-          <a:p>
-            <a:pPr/>
-            <a:r>
-              <a:rPr>
-                <a:latin typeface="Yu Gothic"/>
-                <a:ea typeface="Yu Gothic"/>
-              </a:rPr>
-              <a:t>比例・微分（PID）制御は過剰動作で短期ジッタを注入</a:t>
-            </a:r>
-          </a:p>
-        </p:txBody>
-      </p:sp>
-      <p:sp>
-        <p:nvSpPr>
-          <p:cNvPr id="4" name="Rounded Rectangle 3"/>
-          <p:cNvSpPr/>
-          <p:nvPr/>
-        </p:nvSpPr>
-        <p:spPr>
-          <a:xfrm>
-            <a:off x="274320" y="1335024"/>
-            <a:ext cx="9354312" cy="731520"/>
-          </a:xfrm>
-          <a:prstGeom prst="roundRect">
-            <a:avLst>
-              <a:gd name="adj" fmla="val 8000"/>
-            </a:avLst>
-          </a:prstGeom>
-          <a:solidFill>
-            <a:srgbClr val="EAEFF7"/>
-          </a:solidFill>
-          <a:ln>
-            <a:noFill/>
-          </a:ln>
-          <a:effectLst/>
-        </p:spPr>
-        <p:style>
-          <a:lnRef idx="1">
-            <a:schemeClr val="accent1"/>
-          </a:lnRef>
-          <a:fillRef idx="3">
-            <a:schemeClr val="accent1"/>
-          </a:fillRef>
-          <a:effectRef idx="2">
-            <a:schemeClr val="accent1"/>
-          </a:effectRef>
-          <a:fontRef idx="minor">
-            <a:schemeClr val="lt1"/>
-          </a:fontRef>
-        </p:style>
-        <p:txBody>
-          <a:bodyPr rtlCol="0" anchor="ctr" wrap="square" lIns="127000" rIns="127000" tIns="25400" bIns="25400"/>
-          <a:lstStyle/>
-          <a:p>
-            <a:pPr algn="ctr"/>
-            <a:r>
-              <a:rPr sz="1100" b="1">
-                <a:solidFill>
-                  <a:srgbClr val="B03010"/>
-                </a:solidFill>
-                <a:latin typeface="Yu Gothic"/>
-                <a:ea typeface="Yu Gothic"/>
-              </a:rPr>
-              <a:t>結論  </a:t>
-            </a:r>
-            <a:r>
-              <a:rPr sz="1300" b="1">
-                <a:solidFill>
-                  <a:srgbClr val="1B2A5A"/>
-                </a:solidFill>
-                <a:latin typeface="Yu Gothic"/>
-                <a:ea typeface="Yu Gothic"/>
-              </a:rPr>
-              <a:t>実測モデルに基づくモデルFB（Kp_e=0.08）は、無制御HOLDと同等の近傍位相雑音のまま同期できる（差≈0 dB）＝同期時に位相雑音を持ち込まない。PID制御は短期雑音を生む（対比）。</a:t>
-            </a:r>
-          </a:p>
-        </p:txBody>
-      </p:sp>
-      <p:pic>
-        <p:nvPicPr>
-          <p:cNvPr id="5" name="Picture 4" descr="image.png"/>
-          <p:cNvPicPr>
-            <a:picLocks noChangeAspect="1"/>
-          </p:cNvPicPr>
-          <p:nvPr/>
-        </p:nvPicPr>
-        <p:blipFill>
-          <a:blip r:embed="rId2"/>
-          <a:stretch>
-            <a:fillRect/>
-          </a:stretch>
-        </p:blipFill>
-        <p:spPr>
-          <a:xfrm>
-            <a:off x="6037449" y="2249424"/>
-            <a:ext cx="2601220" cy="1810512"/>
-          </a:xfrm>
-          <a:prstGeom prst="rect">
-            <a:avLst/>
-          </a:prstGeom>
-        </p:spPr>
-      </p:pic>
-      <p:pic>
-        <p:nvPicPr>
-          <p:cNvPr id="6" name="Picture 5" descr="image.png"/>
-          <p:cNvPicPr>
-            <a:picLocks noChangeAspect="1"/>
-          </p:cNvPicPr>
-          <p:nvPr/>
-        </p:nvPicPr>
-        <p:blipFill>
-          <a:blip r:embed="rId3"/>
-          <a:stretch>
-            <a:fillRect/>
-          </a:stretch>
-        </p:blipFill>
-        <p:spPr>
-          <a:xfrm>
-            <a:off x="6037449" y="4224528"/>
-            <a:ext cx="2601220" cy="1810512"/>
-          </a:xfrm>
-          <a:prstGeom prst="rect">
-            <a:avLst/>
-          </a:prstGeom>
-        </p:spPr>
-      </p:pic>
-    </p:spTree>
-  </p:cSld>
-  <p:clrMapOvr>
-    <a:masterClrMapping/>
-  </p:clrMapOvr>
-</p:sld>
-</file>
-
-<file path=ppt/slides/slide24.xml><?xml version="1.0" encoding="utf-8"?>
-<p:sld xmlns:a="http://schemas.openxmlformats.org/drawingml/2006/main" xmlns:p="http://schemas.openxmlformats.org/presentationml/2006/main" xmlns:r="http://schemas.openxmlformats.org/officeDocument/2006/relationships">
-  <p:cSld>
-    <p:spTree>
-      <p:nvGrpSpPr>
-        <p:cNvPr id="1" name=""/>
-        <p:cNvGrpSpPr/>
-        <p:nvPr/>
-      </p:nvGrpSpPr>
-      <p:grpSpPr/>
-      <p:sp>
-        <p:nvSpPr>
-          <p:cNvPr id="2" name="Title 1"/>
-          <p:cNvSpPr>
-            <a:spLocks noGrp="1"/>
-          </p:cNvSpPr>
-          <p:nvPr>
-            <p:ph type="title"/>
-          </p:nvPr>
-        </p:nvSpPr>
-        <p:spPr>
-          <a:xfrm>
-            <a:off x="228600" y="237744"/>
-            <a:ext cx="9473184" cy="969264"/>
-          </a:xfrm>
-        </p:spPr>
-        <p:txBody>
-          <a:bodyPr/>
-          <a:lstStyle/>
-          <a:p>
-            <a:pPr>
-              <a:spcBef>
-                <a:spcPts val="0"/>
-              </a:spcBef>
-              <a:spcAft>
-                <a:spcPts val="0"/>
-              </a:spcAft>
-            </a:pPr>
-            <a:r>
-              <a:rPr b="1">
-                <a:solidFill>
-                  <a:srgbClr val="000F78"/>
-                </a:solidFill>
-                <a:latin typeface="Yu Gothic"/>
-                <a:ea typeface="Yu Gothic"/>
-              </a:rPr>
-              <a:t>06. 考察と今後の展望</a:t>
-            </a:r>
-          </a:p>
-        </p:txBody>
-      </p:sp>
-      <p:sp>
-        <p:nvSpPr>
-          <p:cNvPr id="3" name="Text Placeholder 2"/>
-          <p:cNvSpPr>
-            <a:spLocks noGrp="1"/>
-          </p:cNvSpPr>
-          <p:nvPr>
-            <p:ph type="body" idx="1"/>
-          </p:nvPr>
-        </p:nvSpPr>
-        <p:spPr>
-          <a:xfrm>
-            <a:off x="274320" y="2212848"/>
-            <a:ext cx="4526280" cy="4297680"/>
-          </a:xfrm>
-        </p:spPr>
-        <p:txBody>
-          <a:bodyPr wrap="square"/>
-          <a:lstStyle/>
-          <a:p>
-            <a:pPr/>
-            <a:r>
-              <a:rPr>
-                <a:latin typeface="Yu Gothic"/>
-                <a:ea typeface="Yu Gothic"/>
-              </a:rPr>
-              <a:t>現状：実測モデルに基づくFBで近傍位相雑音を注入せず同期を実現</a:t>
-            </a:r>
-          </a:p>
-          <a:p>
-            <a:pPr/>
-            <a:r>
-              <a:rPr>
-                <a:latin typeface="Yu Gothic"/>
-                <a:ea typeface="Yu Gothic"/>
-              </a:rPr>
-              <a:t>Step1：二つのOCXOの平均に対して同期させる</a:t>
-            </a:r>
-          </a:p>
-          <a:p>
-            <a:pPr/>
-            <a:r>
-              <a:rPr>
-                <a:latin typeface="Yu Gothic"/>
-                <a:ea typeface="Yu Gothic"/>
-              </a:rPr>
-              <a:t>Step2：同期したOCXOを合成器で平均し測定</a:t>
-            </a:r>
-          </a:p>
-          <a:p>
-            <a:pPr/>
-            <a:r>
-              <a:rPr>
-                <a:latin typeface="Yu Gothic"/>
-                <a:ea typeface="Yu Gothic"/>
-              </a:rPr>
-              <a:t>Step3：N台へ拡張</a:t>
-            </a:r>
-          </a:p>
-        </p:txBody>
-      </p:sp>
-      <p:sp>
-        <p:nvSpPr>
-          <p:cNvPr id="4" name="Rounded Rectangle 3"/>
-          <p:cNvSpPr/>
-          <p:nvPr/>
-        </p:nvSpPr>
-        <p:spPr>
-          <a:xfrm>
-            <a:off x="274320" y="1335024"/>
-            <a:ext cx="9354312" cy="731520"/>
-          </a:xfrm>
-          <a:prstGeom prst="roundRect">
-            <a:avLst>
-              <a:gd name="adj" fmla="val 8000"/>
-            </a:avLst>
-          </a:prstGeom>
-          <a:solidFill>
-            <a:srgbClr val="EAEFF7"/>
-          </a:solidFill>
-          <a:ln>
-            <a:noFill/>
-          </a:ln>
-          <a:effectLst/>
-        </p:spPr>
-        <p:style>
-          <a:lnRef idx="1">
-            <a:schemeClr val="accent1"/>
-          </a:lnRef>
-          <a:fillRef idx="3">
-            <a:schemeClr val="accent1"/>
-          </a:fillRef>
-          <a:effectRef idx="2">
-            <a:schemeClr val="accent1"/>
-          </a:effectRef>
-          <a:fontRef idx="minor">
-            <a:schemeClr val="lt1"/>
-          </a:fontRef>
-        </p:style>
-        <p:txBody>
-          <a:bodyPr rtlCol="0" anchor="ctr" wrap="square" lIns="127000" rIns="127000" tIns="25400" bIns="25400"/>
-          <a:lstStyle/>
-          <a:p>
-            <a:pPr algn="ctr"/>
-            <a:r>
-              <a:rPr sz="1100" b="1">
-                <a:solidFill>
-                  <a:srgbClr val="B03010"/>
-                </a:solidFill>
-                <a:latin typeface="Yu Gothic"/>
-                <a:ea typeface="Yu Gothic"/>
-              </a:rPr>
-              <a:t>結論  </a:t>
-            </a:r>
-            <a:r>
-              <a:rPr sz="1300" b="1">
-                <a:solidFill>
-                  <a:srgbClr val="1B2A5A"/>
-                </a:solidFill>
-                <a:latin typeface="Yu Gothic"/>
-                <a:ea typeface="Yu Gothic"/>
-              </a:rPr>
-              <a:t>フィードバック制御により、近傍位相雑音（同期動作に伴う短期の位相ゆらぎ）を持ち込まずに同期させることに成功した。今後は2台を同時制御・合成器で平均して −3 dB を実証し、N台へ拡張する。</a:t>
-            </a:r>
-          </a:p>
-        </p:txBody>
-      </p:sp>
-      <p:sp>
-        <p:nvSpPr>
-          <p:cNvPr id="5" name="Rounded Rectangle 4"/>
-          <p:cNvSpPr/>
-          <p:nvPr/>
-        </p:nvSpPr>
-        <p:spPr>
-          <a:xfrm>
-            <a:off x="5074920" y="2286000"/>
-            <a:ext cx="4526280" cy="3566160"/>
-          </a:xfrm>
-          <a:prstGeom prst="roundRect">
-            <a:avLst/>
-          </a:prstGeom>
-          <a:solidFill>
-            <a:srgbClr val="F2F2F2"/>
-          </a:solidFill>
-          <a:ln w="12700">
-            <a:solidFill>
-              <a:srgbClr val="595959"/>
-            </a:solidFill>
-          </a:ln>
-          <a:effectLst/>
-        </p:spPr>
-        <p:style>
-          <a:lnRef idx="1">
-            <a:schemeClr val="accent1"/>
-          </a:lnRef>
-          <a:fillRef idx="3">
-            <a:schemeClr val="accent1"/>
-          </a:fillRef>
-          <a:effectRef idx="2">
-            <a:schemeClr val="accent1"/>
-          </a:effectRef>
-          <a:fontRef idx="minor">
-            <a:schemeClr val="lt1"/>
-          </a:fontRef>
-        </p:style>
-        <p:txBody>
-          <a:bodyPr rtlCol="0" anchor="ctr" wrap="square"/>
-          <a:lstStyle/>
-          <a:p>
-            <a:pPr algn="ctr"/>
-            <a:r>
-              <a:rPr sz="1200">
-                <a:solidFill>
-                  <a:srgbClr val="595959"/>
-                </a:solidFill>
-                <a:latin typeface="Yu Gothic"/>
-                <a:ea typeface="Yu Gothic"/>
-              </a:rPr>
-              <a:t>今後のロードマップ
-片方向同期 → 平均で −3 dB → N台 → 双方向結合</a:t>
-            </a:r>
-          </a:p>
-        </p:txBody>
-      </p:sp>
-    </p:spTree>
   </p:cSld>
   <p:clrMapOvr>
     <a:masterClrMapping/>
@@ -11873,6 +10576,1303 @@
 </p:sld>
 </file>
 
+<file path=ppt/slides/slide4.xml><?xml version="1.0" encoding="utf-8"?>
+<p:sld xmlns:a="http://schemas.openxmlformats.org/drawingml/2006/main" xmlns:p="http://schemas.openxmlformats.org/presentationml/2006/main" xmlns:r="http://schemas.openxmlformats.org/officeDocument/2006/relationships">
+  <p:cSld>
+    <p:spTree>
+      <p:nvGrpSpPr>
+        <p:cNvPr id="1" name=""/>
+        <p:cNvGrpSpPr/>
+        <p:nvPr/>
+      </p:nvGrpSpPr>
+      <p:grpSpPr/>
+      <p:sp>
+        <p:nvSpPr>
+          <p:cNvPr id="2" name="Title 1"/>
+          <p:cNvSpPr>
+            <a:spLocks noGrp="1"/>
+          </p:cNvSpPr>
+          <p:nvPr>
+            <p:ph type="title"/>
+          </p:nvPr>
+        </p:nvSpPr>
+        <p:spPr>
+          <a:xfrm>
+            <a:off x="228600" y="237744"/>
+            <a:ext cx="9473184" cy="969264"/>
+          </a:xfrm>
+        </p:spPr>
+        <p:txBody>
+          <a:bodyPr/>
+          <a:lstStyle/>
+          <a:p>
+            <a:pPr>
+              <a:spcBef>
+                <a:spcPts val="0"/>
+              </a:spcBef>
+              <a:spcAft>
+                <a:spcPts val="0"/>
+              </a:spcAft>
+            </a:pPr>
+            <a:r>
+              <a:rPr sz="1400" b="1">
+                <a:solidFill>
+                  <a:srgbClr val="000F78"/>
+                </a:solidFill>
+                <a:latin typeface="Yu Gothic"/>
+                <a:ea typeface="Yu Gothic"/>
+              </a:rPr>
+              <a:t>01. 研究背景</a:t>
+            </a:r>
+          </a:p>
+          <a:p>
+            <a:pPr>
+              <a:spcBef>
+                <a:spcPts val="0"/>
+              </a:spcBef>
+              <a:spcAft>
+                <a:spcPts val="0"/>
+              </a:spcAft>
+            </a:pPr>
+            <a:r>
+              <a:rPr b="1">
+                <a:solidFill>
+                  <a:srgbClr val="000F78"/>
+                </a:solidFill>
+                <a:latin typeface="Yu Gothic"/>
+                <a:ea typeface="Yu Gothic"/>
+              </a:rPr>
+              <a:t>1-2. 基準信号の純度と現状</a:t>
+            </a:r>
+          </a:p>
+        </p:txBody>
+      </p:sp>
+      <p:sp>
+        <p:nvSpPr>
+          <p:cNvPr id="3" name="Text Placeholder 2"/>
+          <p:cNvSpPr>
+            <a:spLocks noGrp="1"/>
+          </p:cNvSpPr>
+          <p:nvPr>
+            <p:ph type="body" idx="1"/>
+          </p:nvPr>
+        </p:nvSpPr>
+        <p:spPr>
+          <a:xfrm>
+            <a:off x="274320" y="2212848"/>
+            <a:ext cx="4526280" cy="4297680"/>
+          </a:xfrm>
+        </p:spPr>
+        <p:txBody>
+          <a:bodyPr wrap="square"/>
+          <a:lstStyle/>
+          <a:p>
+            <a:pPr/>
+            <a:r>
+              <a:rPr>
+                <a:latin typeface="Yu Gothic"/>
+                <a:ea typeface="Yu Gothic"/>
+              </a:rPr>
+              <a:t>市販データは概ね 1 Hz 止まり。近傍（0.1–1 Hz）は測定が難しい</a:t>
+            </a:r>
+          </a:p>
+          <a:p>
+            <a:pPr/>
+            <a:r>
+              <a:rPr>
+                <a:latin typeface="Yu Gothic"/>
+                <a:ea typeface="Yu Gothic"/>
+              </a:rPr>
+              <a:t>近傍の測定純度をどう高めるかが本研究の論点</a:t>
+            </a:r>
+          </a:p>
+        </p:txBody>
+      </p:sp>
+      <p:sp>
+        <p:nvSpPr>
+          <p:cNvPr id="4" name="Rounded Rectangle 3"/>
+          <p:cNvSpPr/>
+          <p:nvPr/>
+        </p:nvSpPr>
+        <p:spPr>
+          <a:xfrm>
+            <a:off x="274320" y="1335024"/>
+            <a:ext cx="9354312" cy="731520"/>
+          </a:xfrm>
+          <a:prstGeom prst="roundRect">
+            <a:avLst>
+              <a:gd name="adj" fmla="val 8000"/>
+            </a:avLst>
+          </a:prstGeom>
+          <a:solidFill>
+            <a:srgbClr val="EAEFF7"/>
+          </a:solidFill>
+          <a:ln>
+            <a:noFill/>
+          </a:ln>
+          <a:effectLst/>
+        </p:spPr>
+        <p:style>
+          <a:lnRef idx="1">
+            <a:schemeClr val="accent1"/>
+          </a:lnRef>
+          <a:fillRef idx="3">
+            <a:schemeClr val="accent1"/>
+          </a:fillRef>
+          <a:effectRef idx="2">
+            <a:schemeClr val="accent1"/>
+          </a:effectRef>
+          <a:fontRef idx="minor">
+            <a:schemeClr val="lt1"/>
+          </a:fontRef>
+        </p:style>
+        <p:txBody>
+          <a:bodyPr rtlCol="0" anchor="ctr" wrap="square" lIns="127000" rIns="127000" tIns="25400" bIns="25400"/>
+          <a:lstStyle/>
+          <a:p>
+            <a:pPr algn="ctr"/>
+            <a:r>
+              <a:rPr sz="1100" b="1">
+                <a:solidFill>
+                  <a:srgbClr val="B03010"/>
+                </a:solidFill>
+                <a:latin typeface="Yu Gothic"/>
+                <a:ea typeface="Yu Gothic"/>
+              </a:rPr>
+              <a:t>結論  </a:t>
+            </a:r>
+            <a:r>
+              <a:rPr sz="1300" b="1">
+                <a:solidFill>
+                  <a:srgbClr val="1B2A5A"/>
+                </a:solidFill>
+                <a:latin typeface="Yu Gothic"/>
+                <a:ea typeface="Yu Gothic"/>
+              </a:rPr>
+              <a:t>通信・測位・計測は基準正弦波の位相雑音に支えられる。原子時計・水素メーザーは高純度だが高価で日単位の計測が必要、OCXOは安価で数秒〜数分の安定に優れるが単体に限界。</a:t>
+            </a:r>
+          </a:p>
+        </p:txBody>
+      </p:sp>
+      <p:pic>
+        <p:nvPicPr>
+          <p:cNvPr id="5" name="Picture 4" descr="image.png"/>
+          <p:cNvPicPr>
+            <a:picLocks noChangeAspect="1"/>
+          </p:cNvPicPr>
+          <p:nvPr/>
+        </p:nvPicPr>
+        <p:blipFill>
+          <a:blip r:embed="rId2"/>
+          <a:stretch>
+            <a:fillRect/>
+          </a:stretch>
+        </p:blipFill>
+        <p:spPr>
+          <a:xfrm>
+            <a:off x="5074920" y="2869040"/>
+            <a:ext cx="4526280" cy="2491518"/>
+          </a:xfrm>
+          <a:prstGeom prst="rect">
+            <a:avLst/>
+          </a:prstGeom>
+        </p:spPr>
+      </p:pic>
+    </p:spTree>
+  </p:cSld>
+  <p:clrMapOvr>
+    <a:masterClrMapping/>
+  </p:clrMapOvr>
+</p:sld>
+</file>
+
+<file path=ppt/slides/slide5.xml><?xml version="1.0" encoding="utf-8"?>
+<p:sld xmlns:a="http://schemas.openxmlformats.org/drawingml/2006/main" xmlns:p="http://schemas.openxmlformats.org/presentationml/2006/main" xmlns:r="http://schemas.openxmlformats.org/officeDocument/2006/relationships">
+  <p:cSld>
+    <p:spTree>
+      <p:nvGrpSpPr>
+        <p:cNvPr id="1" name=""/>
+        <p:cNvGrpSpPr/>
+        <p:nvPr/>
+      </p:nvGrpSpPr>
+      <p:grpSpPr/>
+      <p:sp>
+        <p:nvSpPr>
+          <p:cNvPr id="2" name="Title 1"/>
+          <p:cNvSpPr>
+            <a:spLocks noGrp="1"/>
+          </p:cNvSpPr>
+          <p:nvPr>
+            <p:ph type="title"/>
+          </p:nvPr>
+        </p:nvSpPr>
+        <p:spPr>
+          <a:xfrm>
+            <a:off x="228600" y="237744"/>
+            <a:ext cx="9473184" cy="969264"/>
+          </a:xfrm>
+        </p:spPr>
+        <p:txBody>
+          <a:bodyPr/>
+          <a:lstStyle/>
+          <a:p>
+            <a:pPr>
+              <a:spcBef>
+                <a:spcPts val="0"/>
+              </a:spcBef>
+              <a:spcAft>
+                <a:spcPts val="0"/>
+              </a:spcAft>
+            </a:pPr>
+            <a:r>
+              <a:rPr b="1">
+                <a:solidFill>
+                  <a:srgbClr val="000F78"/>
+                </a:solidFill>
+                <a:latin typeface="Yu Gothic"/>
+                <a:ea typeface="Yu Gothic"/>
+              </a:rPr>
+              <a:t>02. 本研究の目標</a:t>
+            </a:r>
+          </a:p>
+        </p:txBody>
+      </p:sp>
+      <p:sp>
+        <p:nvSpPr>
+          <p:cNvPr id="3" name="Text Placeholder 2"/>
+          <p:cNvSpPr>
+            <a:spLocks noGrp="1"/>
+          </p:cNvSpPr>
+          <p:nvPr>
+            <p:ph type="body" idx="1"/>
+          </p:nvPr>
+        </p:nvSpPr>
+        <p:spPr>
+          <a:xfrm>
+            <a:off x="274320" y="2212848"/>
+            <a:ext cx="4526280" cy="4297680"/>
+          </a:xfrm>
+        </p:spPr>
+        <p:txBody>
+          <a:bodyPr wrap="square"/>
+          <a:lstStyle/>
+          <a:p>
+            <a:pPr/>
+            <a:r>
+              <a:rPr>
+                <a:latin typeface="Yu Gothic"/>
+                <a:ea typeface="Yu Gothic"/>
+              </a:rPr>
+              <a:t>究極的な目標：安価な水晶発振器（OCXO）で高純度な基準信号源を実現</a:t>
+            </a:r>
+          </a:p>
+          <a:p>
+            <a:pPr/>
+            <a:r>
+              <a:rPr>
+                <a:latin typeface="Yu Gothic"/>
+                <a:ea typeface="Yu Gothic"/>
+              </a:rPr>
+              <a:t>アプローチ：複数OCXOを同期させ、1台では実現できない純度での計測を可能にする</a:t>
+            </a:r>
+          </a:p>
+        </p:txBody>
+      </p:sp>
+      <p:sp>
+        <p:nvSpPr>
+          <p:cNvPr id="4" name="Rounded Rectangle 3"/>
+          <p:cNvSpPr/>
+          <p:nvPr/>
+        </p:nvSpPr>
+        <p:spPr>
+          <a:xfrm>
+            <a:off x="274320" y="1335024"/>
+            <a:ext cx="9354312" cy="731520"/>
+          </a:xfrm>
+          <a:prstGeom prst="roundRect">
+            <a:avLst>
+              <a:gd name="adj" fmla="val 8000"/>
+            </a:avLst>
+          </a:prstGeom>
+          <a:solidFill>
+            <a:srgbClr val="EAEFF7"/>
+          </a:solidFill>
+          <a:ln>
+            <a:noFill/>
+          </a:ln>
+          <a:effectLst/>
+        </p:spPr>
+        <p:style>
+          <a:lnRef idx="1">
+            <a:schemeClr val="accent1"/>
+          </a:lnRef>
+          <a:fillRef idx="3">
+            <a:schemeClr val="accent1"/>
+          </a:fillRef>
+          <a:effectRef idx="2">
+            <a:schemeClr val="accent1"/>
+          </a:effectRef>
+          <a:fontRef idx="minor">
+            <a:schemeClr val="lt1"/>
+          </a:fontRef>
+        </p:style>
+        <p:txBody>
+          <a:bodyPr rtlCol="0" anchor="ctr" wrap="square" lIns="127000" rIns="127000" tIns="25400" bIns="25400"/>
+          <a:lstStyle/>
+          <a:p>
+            <a:pPr algn="ctr"/>
+            <a:r>
+              <a:rPr sz="1100" b="1">
+                <a:solidFill>
+                  <a:srgbClr val="B03010"/>
+                </a:solidFill>
+                <a:latin typeface="Yu Gothic"/>
+                <a:ea typeface="Yu Gothic"/>
+              </a:rPr>
+              <a:t>結論  </a:t>
+            </a:r>
+            <a:r>
+              <a:rPr sz="1300" b="1">
+                <a:solidFill>
+                  <a:srgbClr val="1B2A5A"/>
+                </a:solidFill>
+                <a:latin typeface="Yu Gothic"/>
+                <a:ea typeface="Yu Gothic"/>
+              </a:rPr>
+              <a:t>安価なOCXOで可能な限り高純度な基準信号源を実現することを目標とする。</a:t>
+            </a:r>
+          </a:p>
+        </p:txBody>
+      </p:sp>
+      <p:pic>
+        <p:nvPicPr>
+          <p:cNvPr id="5" name="Picture 4" descr="image.png"/>
+          <p:cNvPicPr>
+            <a:picLocks noChangeAspect="1"/>
+          </p:cNvPicPr>
+          <p:nvPr/>
+        </p:nvPicPr>
+        <p:blipFill>
+          <a:blip r:embed="rId2"/>
+          <a:stretch>
+            <a:fillRect/>
+          </a:stretch>
+        </p:blipFill>
+        <p:spPr>
+          <a:xfrm>
+            <a:off x="5074920" y="2796677"/>
+            <a:ext cx="4526280" cy="2636244"/>
+          </a:xfrm>
+          <a:prstGeom prst="rect">
+            <a:avLst/>
+          </a:prstGeom>
+        </p:spPr>
+      </p:pic>
+    </p:spTree>
+  </p:cSld>
+  <p:clrMapOvr>
+    <a:masterClrMapping/>
+  </p:clrMapOvr>
+</p:sld>
+</file>
+
+<file path=ppt/slides/slide6.xml><?xml version="1.0" encoding="utf-8"?>
+<p:sld xmlns:a="http://schemas.openxmlformats.org/drawingml/2006/main" xmlns:p="http://schemas.openxmlformats.org/presentationml/2006/main" xmlns:r="http://schemas.openxmlformats.org/officeDocument/2006/relationships">
+  <p:cSld>
+    <p:spTree>
+      <p:nvGrpSpPr>
+        <p:cNvPr id="1" name=""/>
+        <p:cNvGrpSpPr/>
+        <p:nvPr/>
+      </p:nvGrpSpPr>
+      <p:grpSpPr/>
+      <p:sp>
+        <p:nvSpPr>
+          <p:cNvPr id="2" name="Title 1"/>
+          <p:cNvSpPr>
+            <a:spLocks noGrp="1"/>
+          </p:cNvSpPr>
+          <p:nvPr>
+            <p:ph type="title"/>
+          </p:nvPr>
+        </p:nvSpPr>
+        <p:spPr>
+          <a:xfrm>
+            <a:off x="228600" y="237744"/>
+            <a:ext cx="9473184" cy="969264"/>
+          </a:xfrm>
+        </p:spPr>
+        <p:txBody>
+          <a:bodyPr/>
+          <a:lstStyle/>
+          <a:p>
+            <a:pPr>
+              <a:spcBef>
+                <a:spcPts val="0"/>
+              </a:spcBef>
+              <a:spcAft>
+                <a:spcPts val="0"/>
+              </a:spcAft>
+            </a:pPr>
+            <a:r>
+              <a:rPr sz="1400" b="1">
+                <a:solidFill>
+                  <a:srgbClr val="000F78"/>
+                </a:solidFill>
+                <a:latin typeface="Yu Gothic"/>
+                <a:ea typeface="Yu Gothic"/>
+              </a:rPr>
+              <a:t>03. 先行研究</a:t>
+            </a:r>
+          </a:p>
+          <a:p>
+            <a:pPr>
+              <a:spcBef>
+                <a:spcPts val="0"/>
+              </a:spcBef>
+              <a:spcAft>
+                <a:spcPts val="0"/>
+              </a:spcAft>
+            </a:pPr>
+            <a:r>
+              <a:rPr b="1">
+                <a:solidFill>
+                  <a:srgbClr val="000F78"/>
+                </a:solidFill>
+                <a:latin typeface="Yu Gothic"/>
+                <a:ea typeface="Yu Gothic"/>
+              </a:rPr>
+              <a:t>3-1. 同期・平均による位相雑音の改善（1/N の原理）</a:t>
+            </a:r>
+          </a:p>
+        </p:txBody>
+      </p:sp>
+      <p:sp>
+        <p:nvSpPr>
+          <p:cNvPr id="3" name="Text Placeholder 2"/>
+          <p:cNvSpPr>
+            <a:spLocks noGrp="1"/>
+          </p:cNvSpPr>
+          <p:nvPr>
+            <p:ph type="body" idx="1"/>
+          </p:nvPr>
+        </p:nvSpPr>
+        <p:spPr>
+          <a:xfrm>
+            <a:off x="274320" y="2212848"/>
+            <a:ext cx="4526280" cy="4297680"/>
+          </a:xfrm>
+        </p:spPr>
+        <p:txBody>
+          <a:bodyPr wrap="square"/>
+          <a:lstStyle/>
+          <a:p>
+            <a:pPr/>
+            <a:r>
+              <a:rPr>
+                <a:latin typeface="Yu Gothic"/>
+                <a:ea typeface="Yu Gothic"/>
+              </a:rPr>
+              <a:t>無相関な雑音は平均すると電力が台数分の1（2台で 1/2）になり、近傍位相雑音が −3 dB 改善する</a:t>
+            </a:r>
+          </a:p>
+        </p:txBody>
+      </p:sp>
+      <p:sp>
+        <p:nvSpPr>
+          <p:cNvPr id="4" name="Rounded Rectangle 3"/>
+          <p:cNvSpPr/>
+          <p:nvPr/>
+        </p:nvSpPr>
+        <p:spPr>
+          <a:xfrm>
+            <a:off x="274320" y="1335024"/>
+            <a:ext cx="9354312" cy="731520"/>
+          </a:xfrm>
+          <a:prstGeom prst="roundRect">
+            <a:avLst>
+              <a:gd name="adj" fmla="val 8000"/>
+            </a:avLst>
+          </a:prstGeom>
+          <a:solidFill>
+            <a:srgbClr val="EAEFF7"/>
+          </a:solidFill>
+          <a:ln>
+            <a:noFill/>
+          </a:ln>
+          <a:effectLst/>
+        </p:spPr>
+        <p:style>
+          <a:lnRef idx="1">
+            <a:schemeClr val="accent1"/>
+          </a:lnRef>
+          <a:fillRef idx="3">
+            <a:schemeClr val="accent1"/>
+          </a:fillRef>
+          <a:effectRef idx="2">
+            <a:schemeClr val="accent1"/>
+          </a:effectRef>
+          <a:fontRef idx="minor">
+            <a:schemeClr val="lt1"/>
+          </a:fontRef>
+        </p:style>
+        <p:txBody>
+          <a:bodyPr rtlCol="0" anchor="ctr" wrap="square" lIns="127000" rIns="127000" tIns="25400" bIns="25400"/>
+          <a:lstStyle/>
+          <a:p>
+            <a:pPr algn="ctr"/>
+            <a:r>
+              <a:rPr sz="1100" b="1">
+                <a:solidFill>
+                  <a:srgbClr val="B03010"/>
+                </a:solidFill>
+                <a:latin typeface="Yu Gothic"/>
+                <a:ea typeface="Yu Gothic"/>
+              </a:rPr>
+              <a:t>結論  </a:t>
+            </a:r>
+            <a:r>
+              <a:rPr sz="1300" b="1">
+                <a:solidFill>
+                  <a:srgbClr val="1B2A5A"/>
+                </a:solidFill>
+                <a:latin typeface="Yu Gothic"/>
+                <a:ea typeface="Yu Gothic"/>
+              </a:rPr>
+              <a:t>互いに無相関な雑音は平均で打ち消し合うため、位相を揃えた複数OCXOの出力を平均すると単体を超える純度になる。</a:t>
+            </a:r>
+          </a:p>
+        </p:txBody>
+      </p:sp>
+      <p:pic>
+        <p:nvPicPr>
+          <p:cNvPr id="5" name="Picture 4" descr="image.png"/>
+          <p:cNvPicPr>
+            <a:picLocks noChangeAspect="1"/>
+          </p:cNvPicPr>
+          <p:nvPr/>
+        </p:nvPicPr>
+        <p:blipFill>
+          <a:blip r:embed="rId2"/>
+          <a:stretch>
+            <a:fillRect/>
+          </a:stretch>
+        </p:blipFill>
+        <p:spPr>
+          <a:xfrm>
+            <a:off x="5257333" y="2286000"/>
+            <a:ext cx="4161453" cy="3657600"/>
+          </a:xfrm>
+          <a:prstGeom prst="rect">
+            <a:avLst/>
+          </a:prstGeom>
+        </p:spPr>
+      </p:pic>
+    </p:spTree>
+  </p:cSld>
+  <p:clrMapOvr>
+    <a:masterClrMapping/>
+  </p:clrMapOvr>
+</p:sld>
+</file>
+
+<file path=ppt/slides/slide7.xml><?xml version="1.0" encoding="utf-8"?>
+<p:sld xmlns:a="http://schemas.openxmlformats.org/drawingml/2006/main" xmlns:p="http://schemas.openxmlformats.org/presentationml/2006/main" xmlns:r="http://schemas.openxmlformats.org/officeDocument/2006/relationships">
+  <p:cSld>
+    <p:spTree>
+      <p:nvGrpSpPr>
+        <p:cNvPr id="1" name=""/>
+        <p:cNvGrpSpPr/>
+        <p:nvPr/>
+      </p:nvGrpSpPr>
+      <p:grpSpPr/>
+      <p:sp>
+        <p:nvSpPr>
+          <p:cNvPr id="2" name="Title 1"/>
+          <p:cNvSpPr>
+            <a:spLocks noGrp="1"/>
+          </p:cNvSpPr>
+          <p:nvPr>
+            <p:ph type="title"/>
+          </p:nvPr>
+        </p:nvSpPr>
+        <p:spPr>
+          <a:xfrm>
+            <a:off x="228600" y="237744"/>
+            <a:ext cx="9473184" cy="969264"/>
+          </a:xfrm>
+        </p:spPr>
+        <p:txBody>
+          <a:bodyPr/>
+          <a:lstStyle/>
+          <a:p>
+            <a:pPr>
+              <a:spcBef>
+                <a:spcPts val="0"/>
+              </a:spcBef>
+              <a:spcAft>
+                <a:spcPts val="0"/>
+              </a:spcAft>
+            </a:pPr>
+            <a:r>
+              <a:rPr sz="1400" b="1">
+                <a:solidFill>
+                  <a:srgbClr val="000F78"/>
+                </a:solidFill>
+                <a:latin typeface="Yu Gothic"/>
+                <a:ea typeface="Yu Gothic"/>
+              </a:rPr>
+              <a:t>04. 研究方法</a:t>
+            </a:r>
+          </a:p>
+          <a:p>
+            <a:pPr>
+              <a:spcBef>
+                <a:spcPts val="0"/>
+              </a:spcBef>
+              <a:spcAft>
+                <a:spcPts val="0"/>
+              </a:spcAft>
+            </a:pPr>
+            <a:r>
+              <a:rPr b="1">
+                <a:solidFill>
+                  <a:srgbClr val="000F78"/>
+                </a:solidFill>
+                <a:latin typeface="Yu Gothic"/>
+                <a:ea typeface="Yu Gothic"/>
+              </a:rPr>
+              <a:t>4-1. アプローチ：能動的に同期して平均する</a:t>
+            </a:r>
+          </a:p>
+        </p:txBody>
+      </p:sp>
+      <p:sp>
+        <p:nvSpPr>
+          <p:cNvPr id="3" name="Text Placeholder 2"/>
+          <p:cNvSpPr>
+            <a:spLocks noGrp="1"/>
+          </p:cNvSpPr>
+          <p:nvPr>
+            <p:ph type="body" idx="1"/>
+          </p:nvPr>
+        </p:nvSpPr>
+        <p:spPr>
+          <a:xfrm>
+            <a:off x="274320" y="2212848"/>
+            <a:ext cx="4526280" cy="4297680"/>
+          </a:xfrm>
+        </p:spPr>
+        <p:txBody>
+          <a:bodyPr wrap="square"/>
+          <a:lstStyle/>
+          <a:p>
+            <a:pPr/>
+            <a:r>
+              <a:rPr>
+                <a:latin typeface="Yu Gothic"/>
+                <a:ea typeface="Yu Gothic"/>
+              </a:rPr>
+              <a:t>平均には各発振器の位相が揃うことが前提</a:t>
+            </a:r>
+          </a:p>
+          <a:p>
+            <a:pPr/>
+            <a:r>
+              <a:rPr>
+                <a:latin typeface="Yu Gothic"/>
+                <a:ea typeface="Yu Gothic"/>
+              </a:rPr>
+              <a:t>本研究の方式：能動的フィードバックで実時間同期し、出力を平均する</a:t>
+            </a:r>
+          </a:p>
+          <a:p>
+            <a:pPr/>
+            <a:r>
+              <a:rPr>
+                <a:latin typeface="Yu Gothic"/>
+                <a:ea typeface="Yu Gothic"/>
+              </a:rPr>
+              <a:t>同期を『雑音を加えずに』行うことが中核課題</a:t>
+            </a:r>
+          </a:p>
+        </p:txBody>
+      </p:sp>
+      <p:sp>
+        <p:nvSpPr>
+          <p:cNvPr id="4" name="Rounded Rectangle 3"/>
+          <p:cNvSpPr/>
+          <p:nvPr/>
+        </p:nvSpPr>
+        <p:spPr>
+          <a:xfrm>
+            <a:off x="274320" y="1335024"/>
+            <a:ext cx="9354312" cy="731520"/>
+          </a:xfrm>
+          <a:prstGeom prst="roundRect">
+            <a:avLst>
+              <a:gd name="adj" fmla="val 8000"/>
+            </a:avLst>
+          </a:prstGeom>
+          <a:solidFill>
+            <a:srgbClr val="EAEFF7"/>
+          </a:solidFill>
+          <a:ln>
+            <a:noFill/>
+          </a:ln>
+          <a:effectLst/>
+        </p:spPr>
+        <p:style>
+          <a:lnRef idx="1">
+            <a:schemeClr val="accent1"/>
+          </a:lnRef>
+          <a:fillRef idx="3">
+            <a:schemeClr val="accent1"/>
+          </a:fillRef>
+          <a:effectRef idx="2">
+            <a:schemeClr val="accent1"/>
+          </a:effectRef>
+          <a:fontRef idx="minor">
+            <a:schemeClr val="lt1"/>
+          </a:fontRef>
+        </p:style>
+        <p:txBody>
+          <a:bodyPr rtlCol="0" anchor="ctr" wrap="square" lIns="127000" rIns="127000" tIns="25400" bIns="25400"/>
+          <a:lstStyle/>
+          <a:p>
+            <a:pPr algn="ctr"/>
+            <a:r>
+              <a:rPr sz="1100" b="1">
+                <a:solidFill>
+                  <a:srgbClr val="B03010"/>
+                </a:solidFill>
+                <a:latin typeface="Yu Gothic"/>
+                <a:ea typeface="Yu Gothic"/>
+              </a:rPr>
+              <a:t>結論  </a:t>
+            </a:r>
+            <a:r>
+              <a:rPr sz="1300" b="1">
+                <a:solidFill>
+                  <a:srgbClr val="1B2A5A"/>
+                </a:solidFill>
+                <a:latin typeface="Yu Gothic"/>
+                <a:ea typeface="Yu Gothic"/>
+              </a:rPr>
+              <a:t>互いに無相関な雑音は平均で打ち消し合う。位相を揃えた複数OCXOの出力を能動的フィードバックで実時間に同期・平均し、単体を超える純度を実現する（国際原子時のクロックアンサンブルを小規模・実時間で適用）。</a:t>
+            </a:r>
+          </a:p>
+        </p:txBody>
+      </p:sp>
+      <p:pic>
+        <p:nvPicPr>
+          <p:cNvPr id="5" name="Picture 4" descr="image.png"/>
+          <p:cNvPicPr>
+            <a:picLocks noChangeAspect="1"/>
+          </p:cNvPicPr>
+          <p:nvPr/>
+        </p:nvPicPr>
+        <p:blipFill>
+          <a:blip r:embed="rId2"/>
+          <a:stretch>
+            <a:fillRect/>
+          </a:stretch>
+        </p:blipFill>
+        <p:spPr>
+          <a:xfrm>
+            <a:off x="5074920" y="2968671"/>
+            <a:ext cx="4526280" cy="2292256"/>
+          </a:xfrm>
+          <a:prstGeom prst="rect">
+            <a:avLst/>
+          </a:prstGeom>
+        </p:spPr>
+      </p:pic>
+    </p:spTree>
+  </p:cSld>
+  <p:clrMapOvr>
+    <a:masterClrMapping/>
+  </p:clrMapOvr>
+</p:sld>
+</file>
+
+<file path=ppt/slides/slide8.xml><?xml version="1.0" encoding="utf-8"?>
+<p:sld xmlns:a="http://schemas.openxmlformats.org/drawingml/2006/main" xmlns:p="http://schemas.openxmlformats.org/presentationml/2006/main" xmlns:r="http://schemas.openxmlformats.org/officeDocument/2006/relationships">
+  <p:cSld>
+    <p:spTree>
+      <p:nvGrpSpPr>
+        <p:cNvPr id="1" name=""/>
+        <p:cNvGrpSpPr/>
+        <p:nvPr/>
+      </p:nvGrpSpPr>
+      <p:grpSpPr/>
+      <p:sp>
+        <p:nvSpPr>
+          <p:cNvPr id="2" name="Title 1"/>
+          <p:cNvSpPr>
+            <a:spLocks noGrp="1"/>
+          </p:cNvSpPr>
+          <p:nvPr>
+            <p:ph type="title"/>
+          </p:nvPr>
+        </p:nvSpPr>
+        <p:spPr>
+          <a:xfrm>
+            <a:off x="228600" y="237744"/>
+            <a:ext cx="9473184" cy="969264"/>
+          </a:xfrm>
+        </p:spPr>
+        <p:txBody>
+          <a:bodyPr/>
+          <a:lstStyle/>
+          <a:p>
+            <a:pPr>
+              <a:spcBef>
+                <a:spcPts val="0"/>
+              </a:spcBef>
+              <a:spcAft>
+                <a:spcPts val="0"/>
+              </a:spcAft>
+            </a:pPr>
+            <a:r>
+              <a:rPr sz="1400" b="1">
+                <a:solidFill>
+                  <a:srgbClr val="000F78"/>
+                </a:solidFill>
+                <a:latin typeface="Yu Gothic"/>
+                <a:ea typeface="Yu Gothic"/>
+              </a:rPr>
+              <a:t>04. 研究方法</a:t>
+            </a:r>
+          </a:p>
+          <a:p>
+            <a:pPr>
+              <a:spcBef>
+                <a:spcPts val="0"/>
+              </a:spcBef>
+              <a:spcAft>
+                <a:spcPts val="0"/>
+              </a:spcAft>
+            </a:pPr>
+            <a:r>
+              <a:rPr b="1">
+                <a:solidFill>
+                  <a:srgbClr val="000F78"/>
+                </a:solidFill>
+                <a:latin typeface="Yu Gothic"/>
+                <a:ea typeface="Yu Gothic"/>
+              </a:rPr>
+              <a:t>4-2. 実験系</a:t>
+            </a:r>
+          </a:p>
+        </p:txBody>
+      </p:sp>
+      <p:sp>
+        <p:nvSpPr>
+          <p:cNvPr id="3" name="Text Placeholder 2"/>
+          <p:cNvSpPr>
+            <a:spLocks noGrp="1"/>
+          </p:cNvSpPr>
+          <p:nvPr>
+            <p:ph type="body" idx="1"/>
+          </p:nvPr>
+        </p:nvSpPr>
+        <p:spPr>
+          <a:xfrm>
+            <a:off x="274320" y="2212848"/>
+            <a:ext cx="4526280" cy="4297680"/>
+          </a:xfrm>
+        </p:spPr>
+        <p:txBody>
+          <a:bodyPr wrap="square"/>
+          <a:lstStyle/>
+          <a:p>
+            <a:pPr/>
+            <a:r>
+              <a:rPr>
+                <a:latin typeface="Yu Gothic"/>
+                <a:ea typeface="Yu Gothic"/>
+              </a:rPr>
+              <a:t>制御系統（オシロ FRFR）と精度評価系統（録音→ヒルベルト変換）の二系統で構成</a:t>
+            </a:r>
+          </a:p>
+        </p:txBody>
+      </p:sp>
+      <p:sp>
+        <p:nvSpPr>
+          <p:cNvPr id="4" name="Rounded Rectangle 3"/>
+          <p:cNvSpPr/>
+          <p:nvPr/>
+        </p:nvSpPr>
+        <p:spPr>
+          <a:xfrm>
+            <a:off x="274320" y="1335024"/>
+            <a:ext cx="9354312" cy="731520"/>
+          </a:xfrm>
+          <a:prstGeom prst="roundRect">
+            <a:avLst>
+              <a:gd name="adj" fmla="val 8000"/>
+            </a:avLst>
+          </a:prstGeom>
+          <a:solidFill>
+            <a:srgbClr val="EAEFF7"/>
+          </a:solidFill>
+          <a:ln>
+            <a:noFill/>
+          </a:ln>
+          <a:effectLst/>
+        </p:spPr>
+        <p:style>
+          <a:lnRef idx="1">
+            <a:schemeClr val="accent1"/>
+          </a:lnRef>
+          <a:fillRef idx="3">
+            <a:schemeClr val="accent1"/>
+          </a:fillRef>
+          <a:effectRef idx="2">
+            <a:schemeClr val="accent1"/>
+          </a:effectRef>
+          <a:fontRef idx="minor">
+            <a:schemeClr val="lt1"/>
+          </a:fontRef>
+        </p:style>
+        <p:txBody>
+          <a:bodyPr rtlCol="0" anchor="ctr" wrap="square" lIns="127000" rIns="127000" tIns="25400" bIns="25400"/>
+          <a:lstStyle/>
+          <a:p>
+            <a:pPr algn="ctr"/>
+            <a:r>
+              <a:rPr sz="1100" b="1">
+                <a:solidFill>
+                  <a:srgbClr val="B03010"/>
+                </a:solidFill>
+                <a:latin typeface="Yu Gothic"/>
+                <a:ea typeface="Yu Gothic"/>
+              </a:rPr>
+              <a:t>結論  </a:t>
+            </a:r>
+            <a:r>
+              <a:rPr sz="1300" b="1">
+                <a:solidFill>
+                  <a:srgbClr val="1B2A5A"/>
+                </a:solidFill>
+                <a:latin typeface="Yu Gothic"/>
+                <a:ea typeface="Yu Gothic"/>
+              </a:rPr>
+              <a:t>OCXO2台に対し、位相差FRFRをターゲットとしてオシロスコープで計測。計測結果を基に片方のOCXOへフィードバック電圧を印加する。</a:t>
+            </a:r>
+          </a:p>
+        </p:txBody>
+      </p:sp>
+      <p:sp>
+        <p:nvSpPr>
+          <p:cNvPr id="5" name="Rounded Rectangle 4"/>
+          <p:cNvSpPr/>
+          <p:nvPr/>
+        </p:nvSpPr>
+        <p:spPr>
+          <a:xfrm>
+            <a:off x="5074920" y="2286000"/>
+            <a:ext cx="4526280" cy="3566160"/>
+          </a:xfrm>
+          <a:prstGeom prst="roundRect">
+            <a:avLst/>
+          </a:prstGeom>
+          <a:solidFill>
+            <a:srgbClr val="F2F2F2"/>
+          </a:solidFill>
+          <a:ln w="12700">
+            <a:solidFill>
+              <a:srgbClr val="595959"/>
+            </a:solidFill>
+          </a:ln>
+          <a:effectLst/>
+        </p:spPr>
+        <p:style>
+          <a:lnRef idx="1">
+            <a:schemeClr val="accent1"/>
+          </a:lnRef>
+          <a:fillRef idx="3">
+            <a:schemeClr val="accent1"/>
+          </a:fillRef>
+          <a:effectRef idx="2">
+            <a:schemeClr val="accent1"/>
+          </a:effectRef>
+          <a:fontRef idx="minor">
+            <a:schemeClr val="lt1"/>
+          </a:fontRef>
+        </p:style>
+        <p:txBody>
+          <a:bodyPr rtlCol="0" anchor="ctr" wrap="square"/>
+          <a:lstStyle/>
+          <a:p>
+            <a:pPr algn="ctr"/>
+            <a:r>
+              <a:rPr sz="1200">
+                <a:solidFill>
+                  <a:srgbClr val="595959"/>
+                </a:solidFill>
+                <a:latin typeface="Yu Gothic"/>
+                <a:ea typeface="Yu Gothic"/>
+              </a:rPr>
+              <a:t>実験系ブロック図
+（image1.png を白黒で清書。
+FB→OCXO 帰還矢印・PC(MATLAB) ラベルを追記）</a:t>
+            </a:r>
+          </a:p>
+        </p:txBody>
+      </p:sp>
+    </p:spTree>
+  </p:cSld>
+  <p:clrMapOvr>
+    <a:masterClrMapping/>
+  </p:clrMapOvr>
+</p:sld>
+</file>
+
+<file path=ppt/slides/slide9.xml><?xml version="1.0" encoding="utf-8"?>
+<p:sld xmlns:a="http://schemas.openxmlformats.org/drawingml/2006/main" xmlns:p="http://schemas.openxmlformats.org/presentationml/2006/main" xmlns:r="http://schemas.openxmlformats.org/officeDocument/2006/relationships">
+  <p:cSld>
+    <p:spTree>
+      <p:nvGrpSpPr>
+        <p:cNvPr id="1" name=""/>
+        <p:cNvGrpSpPr/>
+        <p:nvPr/>
+      </p:nvGrpSpPr>
+      <p:grpSpPr/>
+      <p:sp>
+        <p:nvSpPr>
+          <p:cNvPr id="2" name="Title 1"/>
+          <p:cNvSpPr>
+            <a:spLocks noGrp="1"/>
+          </p:cNvSpPr>
+          <p:nvPr>
+            <p:ph type="title"/>
+          </p:nvPr>
+        </p:nvSpPr>
+        <p:spPr>
+          <a:xfrm>
+            <a:off x="228600" y="237744"/>
+            <a:ext cx="9473184" cy="969264"/>
+          </a:xfrm>
+        </p:spPr>
+        <p:txBody>
+          <a:bodyPr/>
+          <a:lstStyle/>
+          <a:p>
+            <a:pPr>
+              <a:spcBef>
+                <a:spcPts val="0"/>
+              </a:spcBef>
+              <a:spcAft>
+                <a:spcPts val="0"/>
+              </a:spcAft>
+            </a:pPr>
+            <a:r>
+              <a:rPr sz="1400" b="1">
+                <a:solidFill>
+                  <a:srgbClr val="000F78"/>
+                </a:solidFill>
+                <a:latin typeface="Yu Gothic"/>
+                <a:ea typeface="Yu Gothic"/>
+              </a:rPr>
+              <a:t>04. 研究方法</a:t>
+            </a:r>
+          </a:p>
+          <a:p>
+            <a:pPr>
+              <a:spcBef>
+                <a:spcPts val="0"/>
+              </a:spcBef>
+              <a:spcAft>
+                <a:spcPts val="0"/>
+              </a:spcAft>
+            </a:pPr>
+            <a:r>
+              <a:rPr b="1">
+                <a:solidFill>
+                  <a:srgbClr val="000F78"/>
+                </a:solidFill>
+                <a:latin typeface="Yu Gothic"/>
+                <a:ea typeface="Yu Gothic"/>
+              </a:rPr>
+              <a:t>4-3. 測定法：オーディオレコーダを使う理由</a:t>
+            </a:r>
+          </a:p>
+        </p:txBody>
+      </p:sp>
+      <p:sp>
+        <p:nvSpPr>
+          <p:cNvPr id="3" name="Text Placeholder 2"/>
+          <p:cNvSpPr>
+            <a:spLocks noGrp="1"/>
+          </p:cNvSpPr>
+          <p:nvPr>
+            <p:ph type="body" idx="1"/>
+          </p:nvPr>
+        </p:nvSpPr>
+        <p:spPr>
+          <a:xfrm>
+            <a:off x="274320" y="2212848"/>
+            <a:ext cx="4526280" cy="4297680"/>
+          </a:xfrm>
+        </p:spPr>
+        <p:txBody>
+          <a:bodyPr wrap="square"/>
+          <a:lstStyle/>
+          <a:p>
+            <a:pPr/>
+            <a:r>
+              <a:rPr>
+                <a:latin typeface="Yu Gothic"/>
+                <a:ea typeface="Yu Gothic"/>
+              </a:rPr>
+              <a:t>オシロの FRFR は精度が要る／録音は高精度・長時間測定が可能</a:t>
+            </a:r>
+          </a:p>
+          <a:p>
+            <a:pPr/>
+            <a:r>
+              <a:rPr>
+                <a:latin typeface="Yu Gothic"/>
+                <a:ea typeface="Yu Gothic"/>
+              </a:rPr>
+              <a:t>卒論で確立した測定法を継承</a:t>
+            </a:r>
+          </a:p>
+        </p:txBody>
+      </p:sp>
+      <p:sp>
+        <p:nvSpPr>
+          <p:cNvPr id="4" name="Rounded Rectangle 3"/>
+          <p:cNvSpPr/>
+          <p:nvPr/>
+        </p:nvSpPr>
+        <p:spPr>
+          <a:xfrm>
+            <a:off x="274320" y="1335024"/>
+            <a:ext cx="9354312" cy="731520"/>
+          </a:xfrm>
+          <a:prstGeom prst="roundRect">
+            <a:avLst>
+              <a:gd name="adj" fmla="val 8000"/>
+            </a:avLst>
+          </a:prstGeom>
+          <a:solidFill>
+            <a:srgbClr val="EAEFF7"/>
+          </a:solidFill>
+          <a:ln>
+            <a:noFill/>
+          </a:ln>
+          <a:effectLst/>
+        </p:spPr>
+        <p:style>
+          <a:lnRef idx="1">
+            <a:schemeClr val="accent1"/>
+          </a:lnRef>
+          <a:fillRef idx="3">
+            <a:schemeClr val="accent1"/>
+          </a:fillRef>
+          <a:effectRef idx="2">
+            <a:schemeClr val="accent1"/>
+          </a:effectRef>
+          <a:fontRef idx="minor">
+            <a:schemeClr val="lt1"/>
+          </a:fontRef>
+        </p:style>
+        <p:txBody>
+          <a:bodyPr rtlCol="0" anchor="ctr" wrap="square" lIns="127000" rIns="127000" tIns="25400" bIns="25400"/>
+          <a:lstStyle/>
+          <a:p>
+            <a:pPr algn="ctr"/>
+            <a:r>
+              <a:rPr sz="1100" b="1">
+                <a:solidFill>
+                  <a:srgbClr val="B03010"/>
+                </a:solidFill>
+                <a:latin typeface="Yu Gothic"/>
+                <a:ea typeface="Yu Gothic"/>
+              </a:rPr>
+              <a:t>結論  </a:t>
+            </a:r>
+            <a:r>
+              <a:rPr sz="1300" b="1">
+                <a:solidFill>
+                  <a:srgbClr val="1B2A5A"/>
+                </a:solidFill>
+                <a:latin typeface="Yu Gothic"/>
+                <a:ea typeface="Yu Gothic"/>
+              </a:rPr>
+              <a:t>オーディオレコーディングは高分解能（10秒測定で std 20–30 ps）かつ長時間測定が可能で、0.1–1 Hz の評価に向いている。</a:t>
+            </a:r>
+          </a:p>
+        </p:txBody>
+      </p:sp>
+      <p:sp>
+        <p:nvSpPr>
+          <p:cNvPr id="5" name="Rounded Rectangle 4"/>
+          <p:cNvSpPr/>
+          <p:nvPr/>
+        </p:nvSpPr>
+        <p:spPr>
+          <a:xfrm>
+            <a:off x="5074920" y="2286000"/>
+            <a:ext cx="4526280" cy="3566160"/>
+          </a:xfrm>
+          <a:prstGeom prst="roundRect">
+            <a:avLst/>
+          </a:prstGeom>
+          <a:solidFill>
+            <a:srgbClr val="F2F2F2"/>
+          </a:solidFill>
+          <a:ln w="12700">
+            <a:solidFill>
+              <a:srgbClr val="595959"/>
+            </a:solidFill>
+          </a:ln>
+          <a:effectLst/>
+        </p:spPr>
+        <p:style>
+          <a:lnRef idx="1">
+            <a:schemeClr val="accent1"/>
+          </a:lnRef>
+          <a:fillRef idx="3">
+            <a:schemeClr val="accent1"/>
+          </a:fillRef>
+          <a:effectRef idx="2">
+            <a:schemeClr val="accent1"/>
+          </a:effectRef>
+          <a:fontRef idx="minor">
+            <a:schemeClr val="lt1"/>
+          </a:fontRef>
+        </p:style>
+        <p:txBody>
+          <a:bodyPr rtlCol="0" anchor="ctr" wrap="square"/>
+          <a:lstStyle/>
+          <a:p>
+            <a:pPr algn="ctr"/>
+            <a:r>
+              <a:rPr sz="1200">
+                <a:solidFill>
+                  <a:srgbClr val="595959"/>
+                </a:solidFill>
+                <a:latin typeface="Yu Gothic"/>
+                <a:ea typeface="Yu Gothic"/>
+              </a:rPr>
+              <a:t>録音系統図・分周・サンプル数比較表
+（卒論PPTXの該当図を流用）</a:t>
+            </a:r>
+          </a:p>
+        </p:txBody>
+      </p:sp>
+    </p:spTree>
+  </p:cSld>
+  <p:clrMapOvr>
+    <a:masterClrMapping/>
+  </p:clrMapOvr>
+</p:sld>
+</file>
+
 <file path=ppt/theme/theme1.xml><?xml version="1.0" encoding="utf-8"?>
 <a:theme xmlns:a="http://schemas.openxmlformats.org/drawingml/2006/main" name="mb_標準テンプレート01">
   <a:themeElements>

</xml_diff>

<commit_message>
Commit mid-term docs/decks; add presentation feedback; ignore scratch dumps
- Commit current state of decks v2–v5 (v5 = latest, key message in body / state-space
  4-4 / FB-logic 4-7 / terminology「低オフセット周波数の位相雑音」).
- Commit updated docs: たたき台_v5, 制御則_検討用_v2, 背景知識メモ.
- Add 06_presentation_feedback/20260624_中間発表FB.docx (mid-term feedback).
- .gitignore: ignore tool scratch dumps (_*_dump.txt, _status_*.txt); removed the
  two stray dumps from the tree.

Co-Authored-By: Claude Opus 4.8 <noreply@anthropic.com>
</commit_message>
<xml_diff>
--- a/presentations/mid_term_202606/04_slides_draft/中間発表_スライド_v3.pptx
+++ b/presentations/mid_term_202606/04_slides_draft/中間発表_スライド_v3.pptx
@@ -11,16 +11,17 @@
     <p:sldId id="425" r:id="rId2"/>
     <p:sldId id="426" r:id="rId3"/>
     <p:sldId id="388" r:id="rId4"/>
-    <p:sldId id="427" r:id="rId23"/>
-    <p:sldId id="428" r:id="rId24"/>
-    <p:sldId id="429" r:id="rId25"/>
-    <p:sldId id="430" r:id="rId26"/>
-    <p:sldId id="431" r:id="rId27"/>
-    <p:sldId id="432" r:id="rId28"/>
-    <p:sldId id="433" r:id="rId29"/>
-    <p:sldId id="434" r:id="rId30"/>
-    <p:sldId id="435" r:id="rId31"/>
-    <p:sldId id="436" r:id="rId32"/>
+    <p:sldId id="427" r:id="rId5"/>
+    <p:sldId id="437" r:id="rId6"/>
+    <p:sldId id="428" r:id="rId7"/>
+    <p:sldId id="429" r:id="rId8"/>
+    <p:sldId id="430" r:id="rId9"/>
+    <p:sldId id="431" r:id="rId10"/>
+    <p:sldId id="432" r:id="rId11"/>
+    <p:sldId id="433" r:id="rId12"/>
+    <p:sldId id="434" r:id="rId13"/>
+    <p:sldId id="435" r:id="rId14"/>
+    <p:sldId id="436" r:id="rId15"/>
   </p:sldIdLst>
   <p:sldSz cx="9906000" cy="6858000" type="A4"/>
   <p:notesSz cx="6858000" cy="9874250"/>
@@ -297,7 +298,7 @@
       <p15:notesGuideLst xmlns:p15="http://schemas.microsoft.com/office/powerpoint/2012/main"/>
     </p:ext>
     <p:ext uri="GoogleSlidesCustomDataVersion2">
-      <go:slidesCustomData xmlns:go="http://customooxmlschemas.google.com/" xmlns:ahyp="http://schemas.microsoft.com/office/drawing/2018/hyperlinkcolor" xmlns:p15="http://schemas.microsoft.com/office/powerpoint/2012/main" xmlns:p14="http://schemas.microsoft.com/office/powerpoint/2010/main" xmlns:com="http://schemas.openxmlformats.org/drawingml/2006/compatibility" xmlns:pvml="urn:schemas-microsoft-com:office:powerpoint" xmlns:v="urn:schemas-microsoft-com:vml" xmlns:o="urn:schemas-microsoft-com:office:office" xmlns:dgm="http://schemas.openxmlformats.org/drawingml/2006/diagram" xmlns:c="http://schemas.openxmlformats.org/drawingml/2006/chart" xmlns:mv="urn:schemas-microsoft-com:mac:vml" xmlns:mc="http://schemas.openxmlformats.org/markup-compatibility/2006" xmlns="" r:id="rId51" roundtripDataSignature="AMtx7mhGZ7uZ5vFhmAr7D05oSO2hGt9NUg=="/>
+      <go:slidesCustomData xmlns="" xmlns:mc="http://schemas.openxmlformats.org/markup-compatibility/2006" xmlns:mv="urn:schemas-microsoft-com:mac:vml" xmlns:c="http://schemas.openxmlformats.org/drawingml/2006/chart" xmlns:dgm="http://schemas.openxmlformats.org/drawingml/2006/diagram" xmlns:o="urn:schemas-microsoft-com:office:office" xmlns:v="urn:schemas-microsoft-com:vml" xmlns:pvml="urn:schemas-microsoft-com:office:powerpoint" xmlns:com="http://schemas.openxmlformats.org/drawingml/2006/compatibility" xmlns:p14="http://schemas.microsoft.com/office/powerpoint/2010/main" xmlns:p15="http://schemas.microsoft.com/office/powerpoint/2012/main" xmlns:ahyp="http://schemas.microsoft.com/office/drawing/2018/hyperlinkcolor" xmlns:go="http://customooxmlschemas.google.com/" r:id="rId51" roundtripDataSignature="AMtx7mhGZ7uZ5vFhmAr7D05oSO2hGt9NUg=="/>
     </p:ext>
   </p:extLst>
 </p:presentation>
@@ -6502,7 +6503,7 @@
 </file>
 
 <file path=ppt/slides/slide10.xml><?xml version="1.0" encoding="utf-8"?>
-<p:sld xmlns:a="http://schemas.openxmlformats.org/drawingml/2006/main" xmlns:p="http://schemas.openxmlformats.org/presentationml/2006/main" xmlns:r="http://schemas.openxmlformats.org/officeDocument/2006/relationships">
+<p:sld xmlns:a="http://schemas.openxmlformats.org/drawingml/2006/main" xmlns:r="http://schemas.openxmlformats.org/officeDocument/2006/relationships" xmlns:p="http://schemas.openxmlformats.org/presentationml/2006/main">
   <p:cSld>
     <p:spTree>
       <p:nvGrpSpPr>
@@ -6510,7 +6511,14 @@
         <p:cNvGrpSpPr/>
         <p:nvPr/>
       </p:nvGrpSpPr>
-      <p:grpSpPr/>
+      <p:grpSpPr>
+        <a:xfrm>
+          <a:off x="0" y="0"/>
+          <a:ext cx="0" cy="0"/>
+          <a:chOff x="0" y="0"/>
+          <a:chExt cx="0" cy="0"/>
+        </a:xfrm>
+      </p:grpSpPr>
       <p:sp>
         <p:nvSpPr>
           <p:cNvPr id="2" name="Title 1"/>
@@ -6567,7 +6575,7 @@
                 <a:latin typeface="Yu Gothic"/>
                 <a:ea typeface="Yu Gothic"/>
               </a:rPr>
-              <a:t>4-4. 予備実験：フィードバック電圧の感応度同定</a:t>
+              <a:t>4-3. 測定法：オーディオレコーダを使う理由</a:t>
             </a:r>
           </a:p>
         </p:txBody>
@@ -6592,23 +6600,21 @@
           <a:bodyPr wrap="square"/>
           <a:lstStyle/>
           <a:p>
-            <a:pPr/>
             <a:r>
               <a:rPr>
                 <a:latin typeface="Yu Gothic"/>
                 <a:ea typeface="Yu Gothic"/>
               </a:rPr>
-              <a:t>1 LSB（≈305 µV）ずつ階段状に電圧を変え、各段の FRFR 傾きを電圧増分に直線回帰</a:t>
+              <a:t>オシロの FRFR は精度が要る／録音は高精度・長時間測定が可能</a:t>
             </a:r>
           </a:p>
           <a:p>
-            <a:pPr/>
             <a:r>
               <a:rPr>
                 <a:latin typeface="Yu Gothic"/>
                 <a:ea typeface="Yu Gothic"/>
               </a:rPr>
-              <a:t>→ プラントゲイン K≈860 ns/(V·s) が得られた</a:t>
+              <a:t>卒論で確立した測定法を継承</a:t>
             </a:r>
           </a:p>
         </p:txBody>
@@ -6652,7 +6658,7 @@
           </a:fontRef>
         </p:style>
         <p:txBody>
-          <a:bodyPr rtlCol="0" anchor="ctr" wrap="square" lIns="127000" rIns="127000" tIns="25400" bIns="25400"/>
+          <a:bodyPr wrap="square" lIns="127000" tIns="25400" rIns="127000" bIns="25400" rtlCol="0" anchor="ctr"/>
           <a:lstStyle/>
           <a:p>
             <a:pPr algn="ctr"/>
@@ -6674,35 +6680,68 @@
                 <a:latin typeface="Yu Gothic"/>
                 <a:ea typeface="Yu Gothic"/>
               </a:rPr>
-              <a:t>フィードバック電圧のLSBを測定し回帰検証することで、フィードバックロジックのパラメータをチューニングした。</a:t>
+              <a:t>オーディオレコーディングは高分解能（10秒測定で std 20–30 ps）かつ長時間測定が可能で、0.1–1 Hz の評価に向いている。</a:t>
             </a:r>
           </a:p>
         </p:txBody>
       </p:sp>
-      <p:pic>
-        <p:nvPicPr>
-          <p:cNvPr id="5" name="Picture 4" descr="image.png"/>
-          <p:cNvPicPr>
-            <a:picLocks noChangeAspect="1"/>
-          </p:cNvPicPr>
+      <p:sp>
+        <p:nvSpPr>
+          <p:cNvPr id="5" name="Rounded Rectangle 4"/>
+          <p:cNvSpPr/>
           <p:nvPr/>
-        </p:nvPicPr>
-        <p:blipFill>
-          <a:blip r:embed="rId2"/>
-          <a:stretch>
-            <a:fillRect/>
-          </a:stretch>
-        </p:blipFill>
+        </p:nvSpPr>
         <p:spPr>
           <a:xfrm>
-            <a:off x="5074920" y="2860414"/>
-            <a:ext cx="4526280" cy="2508770"/>
+            <a:off x="5074920" y="2286000"/>
+            <a:ext cx="4526280" cy="3566160"/>
           </a:xfrm>
-          <a:prstGeom prst="rect">
+          <a:prstGeom prst="roundRect">
             <a:avLst/>
           </a:prstGeom>
+          <a:solidFill>
+            <a:srgbClr val="F2F2F2"/>
+          </a:solidFill>
+          <a:ln w="12700">
+            <a:solidFill>
+              <a:srgbClr val="595959"/>
+            </a:solidFill>
+          </a:ln>
+          <a:effectLst/>
         </p:spPr>
-      </p:pic>
+        <p:style>
+          <a:lnRef idx="1">
+            <a:schemeClr val="accent1"/>
+          </a:lnRef>
+          <a:fillRef idx="3">
+            <a:schemeClr val="accent1"/>
+          </a:fillRef>
+          <a:effectRef idx="2">
+            <a:schemeClr val="accent1"/>
+          </a:effectRef>
+          <a:fontRef idx="minor">
+            <a:schemeClr val="lt1"/>
+          </a:fontRef>
+        </p:style>
+        <p:txBody>
+          <a:bodyPr wrap="square" rtlCol="0" anchor="ctr"/>
+          <a:lstStyle/>
+          <a:p>
+            <a:pPr algn="ctr"/>
+            <a:r>
+              <a:rPr sz="1200">
+                <a:solidFill>
+                  <a:srgbClr val="595959"/>
+                </a:solidFill>
+                <a:latin typeface="Yu Gothic"/>
+                <a:ea typeface="Yu Gothic"/>
+              </a:rPr>
+              <a:t>録音系統図・分周・サンプル数比較表
+（卒論PPTXの該当図を流用）</a:t>
+            </a:r>
+          </a:p>
+        </p:txBody>
+      </p:sp>
     </p:spTree>
   </p:cSld>
   <p:clrMapOvr>
@@ -6712,7 +6751,7 @@
 </file>
 
 <file path=ppt/slides/slide11.xml><?xml version="1.0" encoding="utf-8"?>
-<p:sld xmlns:a="http://schemas.openxmlformats.org/drawingml/2006/main" xmlns:p="http://schemas.openxmlformats.org/presentationml/2006/main" xmlns:r="http://schemas.openxmlformats.org/officeDocument/2006/relationships">
+<p:sld xmlns:a="http://schemas.openxmlformats.org/drawingml/2006/main" xmlns:r="http://schemas.openxmlformats.org/officeDocument/2006/relationships" xmlns:p="http://schemas.openxmlformats.org/presentationml/2006/main">
   <p:cSld>
     <p:spTree>
       <p:nvGrpSpPr>
@@ -6720,7 +6759,14 @@
         <p:cNvGrpSpPr/>
         <p:nvPr/>
       </p:nvGrpSpPr>
-      <p:grpSpPr/>
+      <p:grpSpPr>
+        <a:xfrm>
+          <a:off x="0" y="0"/>
+          <a:ext cx="0" cy="0"/>
+          <a:chOff x="0" y="0"/>
+          <a:chExt cx="0" cy="0"/>
+        </a:xfrm>
+      </p:grpSpPr>
       <p:sp>
         <p:nvSpPr>
           <p:cNvPr id="2" name="Title 1"/>
@@ -6777,7 +6823,7 @@
                 <a:latin typeface="Yu Gothic"/>
                 <a:ea typeface="Yu Gothic"/>
               </a:rPr>
-              <a:t>4-5. フィードバックロジック</a:t>
+              <a:t>4-4. 予備実験：フィードバック電圧の感応度同定</a:t>
             </a:r>
           </a:p>
         </p:txBody>
@@ -6802,33 +6848,21 @@
           <a:bodyPr wrap="square"/>
           <a:lstStyle/>
           <a:p>
-            <a:pPr/>
             <a:r>
               <a:rPr>
                 <a:latin typeface="Yu Gothic"/>
                 <a:ea typeface="Yu Gothic"/>
               </a:rPr>
-              <a:t>出自：ACC（車両追従制御）の状態方程式を波動系へ置き換え</a:t>
+              <a:t>1 LSB（≈305 µV）ずつ階段状に電圧を変え、各段の FRFR 傾きを電圧増分に直線回帰</a:t>
             </a:r>
           </a:p>
           <a:p>
-            <a:pPr/>
             <a:r>
               <a:rPr>
                 <a:latin typeface="Yu Gothic"/>
                 <a:ea typeface="Yu Gothic"/>
               </a:rPr>
-              <a:t>更新：Δf_des=clamp(Kp_e·e) → 必要段数 dN=round(...) → 電圧更新</a:t>
-            </a:r>
-          </a:p>
-          <a:p>
-            <a:pPr/>
-            <a:r>
-              <a:rPr>
-                <a:latin typeface="Yu Gothic"/>
-                <a:ea typeface="Yu Gothic"/>
-              </a:rPr>
-              <a:t>不感帯で静かに同期。比例・微分（PID）は過剰動作で短期雑音（対比）</a:t>
+              <a:t>→ プラントゲイン K≈860 ns/(V·s) が得られた</a:t>
             </a:r>
           </a:p>
         </p:txBody>
@@ -6872,7 +6906,231 @@
           </a:fontRef>
         </p:style>
         <p:txBody>
-          <a:bodyPr rtlCol="0" anchor="ctr" wrap="square" lIns="127000" rIns="127000" tIns="25400" bIns="25400"/>
+          <a:bodyPr wrap="square" lIns="127000" tIns="25400" rIns="127000" bIns="25400" rtlCol="0" anchor="ctr"/>
+          <a:lstStyle/>
+          <a:p>
+            <a:pPr algn="ctr"/>
+            <a:r>
+              <a:rPr sz="1100" b="1">
+                <a:solidFill>
+                  <a:srgbClr val="B03010"/>
+                </a:solidFill>
+                <a:latin typeface="Yu Gothic"/>
+                <a:ea typeface="Yu Gothic"/>
+              </a:rPr>
+              <a:t>結論  </a:t>
+            </a:r>
+            <a:r>
+              <a:rPr sz="1300" b="1">
+                <a:solidFill>
+                  <a:srgbClr val="1B2A5A"/>
+                </a:solidFill>
+                <a:latin typeface="Yu Gothic"/>
+                <a:ea typeface="Yu Gothic"/>
+              </a:rPr>
+              <a:t>フィードバック電圧のLSBを測定し回帰検証することで、フィードバックロジックのパラメータをチューニングした。</a:t>
+            </a:r>
+          </a:p>
+        </p:txBody>
+      </p:sp>
+      <p:pic>
+        <p:nvPicPr>
+          <p:cNvPr id="5" name="Picture 4" descr="image.png"/>
+          <p:cNvPicPr>
+            <a:picLocks noChangeAspect="1"/>
+          </p:cNvPicPr>
+          <p:nvPr/>
+        </p:nvPicPr>
+        <p:blipFill>
+          <a:blip r:embed="rId2"/>
+          <a:stretch>
+            <a:fillRect/>
+          </a:stretch>
+        </p:blipFill>
+        <p:spPr>
+          <a:xfrm>
+            <a:off x="5074920" y="2860414"/>
+            <a:ext cx="4526280" cy="2508770"/>
+          </a:xfrm>
+          <a:prstGeom prst="rect">
+            <a:avLst/>
+          </a:prstGeom>
+        </p:spPr>
+      </p:pic>
+    </p:spTree>
+  </p:cSld>
+  <p:clrMapOvr>
+    <a:masterClrMapping/>
+  </p:clrMapOvr>
+</p:sld>
+</file>
+
+<file path=ppt/slides/slide12.xml><?xml version="1.0" encoding="utf-8"?>
+<p:sld xmlns:a="http://schemas.openxmlformats.org/drawingml/2006/main" xmlns:r="http://schemas.openxmlformats.org/officeDocument/2006/relationships" xmlns:p="http://schemas.openxmlformats.org/presentationml/2006/main">
+  <p:cSld>
+    <p:spTree>
+      <p:nvGrpSpPr>
+        <p:cNvPr id="1" name=""/>
+        <p:cNvGrpSpPr/>
+        <p:nvPr/>
+      </p:nvGrpSpPr>
+      <p:grpSpPr>
+        <a:xfrm>
+          <a:off x="0" y="0"/>
+          <a:ext cx="0" cy="0"/>
+          <a:chOff x="0" y="0"/>
+          <a:chExt cx="0" cy="0"/>
+        </a:xfrm>
+      </p:grpSpPr>
+      <p:sp>
+        <p:nvSpPr>
+          <p:cNvPr id="2" name="Title 1"/>
+          <p:cNvSpPr>
+            <a:spLocks noGrp="1"/>
+          </p:cNvSpPr>
+          <p:nvPr>
+            <p:ph type="title"/>
+          </p:nvPr>
+        </p:nvSpPr>
+        <p:spPr>
+          <a:xfrm>
+            <a:off x="228600" y="237744"/>
+            <a:ext cx="9473184" cy="969264"/>
+          </a:xfrm>
+        </p:spPr>
+        <p:txBody>
+          <a:bodyPr/>
+          <a:lstStyle/>
+          <a:p>
+            <a:pPr>
+              <a:spcBef>
+                <a:spcPts val="0"/>
+              </a:spcBef>
+              <a:spcAft>
+                <a:spcPts val="0"/>
+              </a:spcAft>
+            </a:pPr>
+            <a:r>
+              <a:rPr sz="1400" b="1">
+                <a:solidFill>
+                  <a:srgbClr val="000F78"/>
+                </a:solidFill>
+                <a:latin typeface="Yu Gothic"/>
+                <a:ea typeface="Yu Gothic"/>
+              </a:rPr>
+              <a:t>04. 研究方法</a:t>
+            </a:r>
+          </a:p>
+          <a:p>
+            <a:pPr>
+              <a:spcBef>
+                <a:spcPts val="0"/>
+              </a:spcBef>
+              <a:spcAft>
+                <a:spcPts val="0"/>
+              </a:spcAft>
+            </a:pPr>
+            <a:r>
+              <a:rPr b="1">
+                <a:solidFill>
+                  <a:srgbClr val="000F78"/>
+                </a:solidFill>
+                <a:latin typeface="Yu Gothic"/>
+                <a:ea typeface="Yu Gothic"/>
+              </a:rPr>
+              <a:t>4-5. フィードバックロジック</a:t>
+            </a:r>
+          </a:p>
+        </p:txBody>
+      </p:sp>
+      <p:sp>
+        <p:nvSpPr>
+          <p:cNvPr id="3" name="Text Placeholder 2"/>
+          <p:cNvSpPr>
+            <a:spLocks noGrp="1"/>
+          </p:cNvSpPr>
+          <p:nvPr>
+            <p:ph type="body" idx="1"/>
+          </p:nvPr>
+        </p:nvSpPr>
+        <p:spPr>
+          <a:xfrm>
+            <a:off x="274320" y="2212848"/>
+            <a:ext cx="4526280" cy="4297680"/>
+          </a:xfrm>
+        </p:spPr>
+        <p:txBody>
+          <a:bodyPr wrap="square"/>
+          <a:lstStyle/>
+          <a:p>
+            <a:r>
+              <a:rPr>
+                <a:latin typeface="Yu Gothic"/>
+                <a:ea typeface="Yu Gothic"/>
+              </a:rPr>
+              <a:t>出自：ACC（車両追従制御）の状態方程式を波動系へ置き換え</a:t>
+            </a:r>
+          </a:p>
+          <a:p>
+            <a:r>
+              <a:rPr>
+                <a:latin typeface="Yu Gothic"/>
+                <a:ea typeface="Yu Gothic"/>
+              </a:rPr>
+              <a:t>更新：Δf_des=clamp(Kp_e·e) → 必要段数 dN=round(...) → 電圧更新</a:t>
+            </a:r>
+          </a:p>
+          <a:p>
+            <a:r>
+              <a:rPr>
+                <a:latin typeface="Yu Gothic"/>
+                <a:ea typeface="Yu Gothic"/>
+              </a:rPr>
+              <a:t>不感帯で静かに同期。比例・微分（PID）は過剰動作で短期雑音（対比）</a:t>
+            </a:r>
+          </a:p>
+        </p:txBody>
+      </p:sp>
+      <p:sp>
+        <p:nvSpPr>
+          <p:cNvPr id="4" name="Rounded Rectangle 3"/>
+          <p:cNvSpPr/>
+          <p:nvPr/>
+        </p:nvSpPr>
+        <p:spPr>
+          <a:xfrm>
+            <a:off x="274320" y="1335024"/>
+            <a:ext cx="9354312" cy="731520"/>
+          </a:xfrm>
+          <a:prstGeom prst="roundRect">
+            <a:avLst>
+              <a:gd name="adj" fmla="val 8000"/>
+            </a:avLst>
+          </a:prstGeom>
+          <a:solidFill>
+            <a:srgbClr val="EAEFF7"/>
+          </a:solidFill>
+          <a:ln>
+            <a:noFill/>
+          </a:ln>
+          <a:effectLst/>
+        </p:spPr>
+        <p:style>
+          <a:lnRef idx="1">
+            <a:schemeClr val="accent1"/>
+          </a:lnRef>
+          <a:fillRef idx="3">
+            <a:schemeClr val="accent1"/>
+          </a:fillRef>
+          <a:effectRef idx="2">
+            <a:schemeClr val="accent1"/>
+          </a:effectRef>
+          <a:fontRef idx="minor">
+            <a:schemeClr val="lt1"/>
+          </a:fontRef>
+        </p:style>
+        <p:txBody>
+          <a:bodyPr wrap="square" lIns="127000" tIns="25400" rIns="127000" bIns="25400" rtlCol="0" anchor="ctr"/>
           <a:lstStyle/>
           <a:p>
             <a:pPr algn="ctr"/>
@@ -6955,8 +7213,8 @@
 </p:sld>
 </file>
 
-<file path=ppt/slides/slide12.xml><?xml version="1.0" encoding="utf-8"?>
-<p:sld xmlns:a="http://schemas.openxmlformats.org/drawingml/2006/main" xmlns:p="http://schemas.openxmlformats.org/presentationml/2006/main" xmlns:r="http://schemas.openxmlformats.org/officeDocument/2006/relationships">
+<file path=ppt/slides/slide13.xml><?xml version="1.0" encoding="utf-8"?>
+<p:sld xmlns:a="http://schemas.openxmlformats.org/drawingml/2006/main" xmlns:r="http://schemas.openxmlformats.org/officeDocument/2006/relationships" xmlns:p="http://schemas.openxmlformats.org/presentationml/2006/main">
   <p:cSld>
     <p:spTree>
       <p:nvGrpSpPr>
@@ -6964,7 +7222,14 @@
         <p:cNvGrpSpPr/>
         <p:nvPr/>
       </p:nvGrpSpPr>
-      <p:grpSpPr/>
+      <p:grpSpPr>
+        <a:xfrm>
+          <a:off x="0" y="0"/>
+          <a:ext cx="0" cy="0"/>
+          <a:chOff x="0" y="0"/>
+          <a:chExt cx="0" cy="0"/>
+        </a:xfrm>
+      </p:grpSpPr>
       <p:sp>
         <p:nvSpPr>
           <p:cNvPr id="2" name="Title 1"/>
@@ -7026,7 +7291,6 @@
           <a:bodyPr wrap="square"/>
           <a:lstStyle/>
           <a:p>
-            <a:pPr/>
             <a:r>
               <a:rPr>
                 <a:latin typeface="Yu Gothic"/>
@@ -7036,7 +7300,6 @@
             </a:r>
           </a:p>
           <a:p>
-            <a:pPr/>
             <a:r>
               <a:rPr>
                 <a:latin typeface="Yu Gothic"/>
@@ -7086,7 +7349,7 @@
           </a:fontRef>
         </p:style>
         <p:txBody>
-          <a:bodyPr rtlCol="0" anchor="ctr" wrap="square" lIns="127000" rIns="127000" tIns="25400" bIns="25400"/>
+          <a:bodyPr wrap="square" lIns="127000" tIns="25400" rIns="127000" bIns="25400" rtlCol="0" anchor="ctr"/>
           <a:lstStyle/>
           <a:p>
             <a:pPr algn="ctr"/>
@@ -7169,8 +7432,8 @@
 </p:sld>
 </file>
 
-<file path=ppt/slides/slide13.xml><?xml version="1.0" encoding="utf-8"?>
-<p:sld xmlns:a="http://schemas.openxmlformats.org/drawingml/2006/main" xmlns:p="http://schemas.openxmlformats.org/presentationml/2006/main" xmlns:r="http://schemas.openxmlformats.org/officeDocument/2006/relationships">
+<file path=ppt/slides/slide14.xml><?xml version="1.0" encoding="utf-8"?>
+<p:sld xmlns:a="http://schemas.openxmlformats.org/drawingml/2006/main" xmlns:r="http://schemas.openxmlformats.org/officeDocument/2006/relationships" xmlns:p="http://schemas.openxmlformats.org/presentationml/2006/main">
   <p:cSld>
     <p:spTree>
       <p:nvGrpSpPr>
@@ -7178,7 +7441,14 @@
         <p:cNvGrpSpPr/>
         <p:nvPr/>
       </p:nvGrpSpPr>
-      <p:grpSpPr/>
+      <p:grpSpPr>
+        <a:xfrm>
+          <a:off x="0" y="0"/>
+          <a:ext cx="0" cy="0"/>
+          <a:chOff x="0" y="0"/>
+          <a:chExt cx="0" cy="0"/>
+        </a:xfrm>
+      </p:grpSpPr>
       <p:sp>
         <p:nvSpPr>
           <p:cNvPr id="2" name="Title 1"/>
@@ -7240,7 +7510,6 @@
           <a:bodyPr wrap="square"/>
           <a:lstStyle/>
           <a:p>
-            <a:pPr/>
             <a:r>
               <a:rPr>
                 <a:latin typeface="Yu Gothic"/>
@@ -7250,7 +7519,6 @@
             </a:r>
           </a:p>
           <a:p>
-            <a:pPr/>
             <a:r>
               <a:rPr>
                 <a:latin typeface="Yu Gothic"/>
@@ -7260,7 +7528,6 @@
             </a:r>
           </a:p>
           <a:p>
-            <a:pPr/>
             <a:r>
               <a:rPr>
                 <a:latin typeface="Yu Gothic"/>
@@ -7270,7 +7537,6 @@
             </a:r>
           </a:p>
           <a:p>
-            <a:pPr/>
             <a:r>
               <a:rPr>
                 <a:latin typeface="Yu Gothic"/>
@@ -7320,7 +7586,7 @@
           </a:fontRef>
         </p:style>
         <p:txBody>
-          <a:bodyPr rtlCol="0" anchor="ctr" wrap="square" lIns="127000" rIns="127000" tIns="25400" bIns="25400"/>
+          <a:bodyPr wrap="square" lIns="127000" tIns="25400" rIns="127000" bIns="25400" rtlCol="0" anchor="ctr"/>
           <a:lstStyle/>
           <a:p>
             <a:pPr algn="ctr"/>
@@ -7386,7 +7652,7 @@
           </a:fontRef>
         </p:style>
         <p:txBody>
-          <a:bodyPr rtlCol="0" anchor="ctr" wrap="square"/>
+          <a:bodyPr wrap="square" rtlCol="0" anchor="ctr"/>
           <a:lstStyle/>
           <a:p>
             <a:pPr algn="ctr"/>
@@ -8080,18 +8346,6 @@
                 </a:rPr>
                 <a:t>先行研究</a:t>
               </a:r>
-              <a:r>
-                <a:rPr lang="ja-JP" altLang="en-US" sz="2000" b="1" i="0" u="none" strike="noStrike" cap="none">
-                  <a:solidFill>
-                    <a:schemeClr val="dk1"/>
-                  </a:solidFill>
-                  <a:latin typeface="Arial"/>
-                  <a:ea typeface="Arial"/>
-                  <a:cs typeface="Arial"/>
-                  <a:sym typeface="Arial"/>
-                </a:rPr>
-                <a:t/>
-              </a:r>
               <a:endParaRPr lang="en-US" altLang="ja-JP" sz="2000" b="1" i="0" u="none" strike="noStrike" cap="none" dirty="0">
                 <a:solidFill>
                   <a:schemeClr val="dk1"/>
@@ -8354,18 +8608,6 @@
                 </a:rPr>
                 <a:t>研究方法</a:t>
               </a:r>
-              <a:r>
-                <a:rPr lang="ja-JP" altLang="en-US" sz="2000" b="1" i="0" u="none" strike="noStrike" cap="none">
-                  <a:solidFill>
-                    <a:schemeClr val="dk1"/>
-                  </a:solidFill>
-                  <a:latin typeface="Arial"/>
-                  <a:ea typeface="Arial"/>
-                  <a:cs typeface="Arial"/>
-                  <a:sym typeface="Arial"/>
-                </a:rPr>
-                <a:t/>
-              </a:r>
               <a:endParaRPr lang="en-US" altLang="ja-JP" sz="2000" b="1" i="0" u="none" strike="noStrike" cap="none" dirty="0">
                 <a:solidFill>
                   <a:schemeClr val="dk1"/>
@@ -8627,14 +8869,6 @@
                   <a:sym typeface="Arial"/>
                 </a:rPr>
                 <a:t>実験と結果</a:t>
-              </a:r>
-              <a:r>
-                <a:rPr lang="ja-JP" altLang="en-US" sz="2000" b="1">
-                  <a:solidFill>
-                    <a:schemeClr val="dk1"/>
-                  </a:solidFill>
-                </a:rPr>
-                <a:t/>
               </a:r>
               <a:endParaRPr lang="en-US" altLang="ja-JP" sz="2000" b="1" i="0" u="none" strike="noStrike" cap="none" dirty="0">
                 <a:solidFill>
@@ -9230,18 +9464,6 @@
                   <a:sym typeface="Arial"/>
                 </a:rPr>
                 <a:t>考察と今後の展望</a:t>
-              </a:r>
-              <a:r>
-                <a:rPr lang="en-US" altLang="ja-JP" sz="2000" b="1" i="0" u="none" strike="noStrike" cap="none" dirty="0">
-                  <a:solidFill>
-                    <a:schemeClr val="dk1"/>
-                  </a:solidFill>
-                  <a:latin typeface="Arial"/>
-                  <a:ea typeface="Arial"/>
-                  <a:cs typeface="Arial"/>
-                  <a:sym typeface="Arial"/>
-                </a:rPr>
-                <a:t/>
               </a:r>
             </a:p>
           </p:txBody>
@@ -10577,7 +10799,7 @@
 </file>
 
 <file path=ppt/slides/slide4.xml><?xml version="1.0" encoding="utf-8"?>
-<p:sld xmlns:a="http://schemas.openxmlformats.org/drawingml/2006/main" xmlns:p="http://schemas.openxmlformats.org/presentationml/2006/main" xmlns:r="http://schemas.openxmlformats.org/officeDocument/2006/relationships">
+<p:sld xmlns:a="http://schemas.openxmlformats.org/drawingml/2006/main" xmlns:r="http://schemas.openxmlformats.org/officeDocument/2006/relationships" xmlns:p="http://schemas.openxmlformats.org/presentationml/2006/main">
   <p:cSld>
     <p:spTree>
       <p:nvGrpSpPr>
@@ -10585,7 +10807,14 @@
         <p:cNvGrpSpPr/>
         <p:nvPr/>
       </p:nvGrpSpPr>
-      <p:grpSpPr/>
+      <p:grpSpPr>
+        <a:xfrm>
+          <a:off x="0" y="0"/>
+          <a:ext cx="0" cy="0"/>
+          <a:chOff x="0" y="0"/>
+          <a:chExt cx="0" cy="0"/>
+        </a:xfrm>
+      </p:grpSpPr>
       <p:sp>
         <p:nvSpPr>
           <p:cNvPr id="2" name="Title 1"/>
@@ -10615,15 +10844,32 @@
               </a:spcAft>
             </a:pPr>
             <a:r>
-              <a:rPr sz="1400" b="1">
+              <a:rPr sz="1400" b="1" dirty="0">
                 <a:solidFill>
                   <a:srgbClr val="000F78"/>
                 </a:solidFill>
                 <a:latin typeface="Yu Gothic"/>
                 <a:ea typeface="Yu Gothic"/>
               </a:rPr>
-              <a:t>01. 研究背景</a:t>
-            </a:r>
+              <a:t>01. </a:t>
+            </a:r>
+            <a:r>
+              <a:rPr sz="1400" b="1" dirty="0" err="1">
+                <a:solidFill>
+                  <a:srgbClr val="000F78"/>
+                </a:solidFill>
+                <a:latin typeface="Yu Gothic"/>
+                <a:ea typeface="Yu Gothic"/>
+              </a:rPr>
+              <a:t>研究背景</a:t>
+            </a:r>
+            <a:endParaRPr sz="1400" b="1" dirty="0">
+              <a:solidFill>
+                <a:srgbClr val="000F78"/>
+              </a:solidFill>
+              <a:latin typeface="Yu Gothic"/>
+              <a:ea typeface="Yu Gothic"/>
+            </a:endParaRPr>
           </a:p>
           <a:p>
             <a:pPr>
@@ -10635,14 +10881,454 @@
               </a:spcAft>
             </a:pPr>
             <a:r>
-              <a:rPr b="1">
+              <a:rPr b="1" dirty="0">
                 <a:solidFill>
                   <a:srgbClr val="000F78"/>
                 </a:solidFill>
                 <a:latin typeface="Yu Gothic"/>
                 <a:ea typeface="Yu Gothic"/>
               </a:rPr>
-              <a:t>1-2. 基準信号の純度と現状</a:t>
+              <a:t>1-2. </a:t>
+            </a:r>
+            <a:r>
+              <a:rPr b="1" dirty="0" err="1">
+                <a:solidFill>
+                  <a:srgbClr val="000F78"/>
+                </a:solidFill>
+                <a:latin typeface="Yu Gothic"/>
+                <a:ea typeface="Yu Gothic"/>
+              </a:rPr>
+              <a:t>基準信号の純度と現状</a:t>
+            </a:r>
+            <a:endParaRPr b="1" dirty="0">
+              <a:solidFill>
+                <a:srgbClr val="000F78"/>
+              </a:solidFill>
+              <a:latin typeface="Yu Gothic"/>
+              <a:ea typeface="Yu Gothic"/>
+            </a:endParaRPr>
+          </a:p>
+        </p:txBody>
+      </p:sp>
+      <p:pic>
+        <p:nvPicPr>
+          <p:cNvPr id="5" name="Picture 4" descr="image.png"/>
+          <p:cNvPicPr>
+            <a:picLocks noChangeAspect="1"/>
+          </p:cNvPicPr>
+          <p:nvPr/>
+        </p:nvPicPr>
+        <p:blipFill>
+          <a:blip r:embed="rId2"/>
+          <a:stretch>
+            <a:fillRect/>
+          </a:stretch>
+        </p:blipFill>
+        <p:spPr>
+          <a:xfrm>
+            <a:off x="1244755" y="2214879"/>
+            <a:ext cx="7486593" cy="4121040"/>
+          </a:xfrm>
+          <a:prstGeom prst="rect">
+            <a:avLst/>
+          </a:prstGeom>
+        </p:spPr>
+      </p:pic>
+      <p:sp>
+        <p:nvSpPr>
+          <p:cNvPr id="10" name="テキスト プレースホルダー 9">
+            <a:extLst>
+              <a:ext uri="{FF2B5EF4-FFF2-40B4-BE49-F238E27FC236}">
+                <a16:creationId xmlns:a16="http://schemas.microsoft.com/office/drawing/2014/main" id="{D6397270-59F0-9E44-6A0E-6658F3D6793C}"/>
+              </a:ext>
+            </a:extLst>
+          </p:cNvPr>
+          <p:cNvSpPr>
+            <a:spLocks noGrp="1"/>
+          </p:cNvSpPr>
+          <p:nvPr>
+            <p:ph type="body" idx="1"/>
+          </p:nvPr>
+        </p:nvSpPr>
+        <p:spPr>
+          <a:xfrm>
+            <a:off x="213525" y="906114"/>
+            <a:ext cx="9590875" cy="969263"/>
+          </a:xfrm>
+        </p:spPr>
+        <p:txBody>
+          <a:bodyPr/>
+          <a:lstStyle/>
+          <a:p>
+            <a:r>
+              <a:rPr lang="ja-JP" altLang="en-US" b="1" dirty="0">
+                <a:solidFill>
+                  <a:srgbClr val="1B2A5A"/>
+                </a:solidFill>
+                <a:latin typeface="Yu Gothic"/>
+                <a:ea typeface="Yu Gothic"/>
+              </a:rPr>
+              <a:t>通信・測位・計測は基準正弦波の位相雑音に支えられる。原子時計・水素メーザーは高純度だが高価で日単位の計測が必要、</a:t>
+            </a:r>
+            <a:r>
+              <a:rPr lang="en-US" altLang="ja-JP" b="1" dirty="0">
+                <a:solidFill>
+                  <a:srgbClr val="1B2A5A"/>
+                </a:solidFill>
+                <a:latin typeface="Yu Gothic"/>
+                <a:ea typeface="Yu Gothic"/>
+              </a:rPr>
+              <a:t>OCXO</a:t>
+            </a:r>
+            <a:r>
+              <a:rPr lang="ja-JP" altLang="en-US" b="1" dirty="0">
+                <a:solidFill>
+                  <a:srgbClr val="1B2A5A"/>
+                </a:solidFill>
+                <a:latin typeface="Yu Gothic"/>
+                <a:ea typeface="Yu Gothic"/>
+              </a:rPr>
+              <a:t>は安価で数秒</a:t>
+            </a:r>
+            <a:r>
+              <a:rPr lang="en-US" altLang="ja-JP" b="1" dirty="0">
+                <a:solidFill>
+                  <a:srgbClr val="1B2A5A"/>
+                </a:solidFill>
+                <a:latin typeface="Yu Gothic"/>
+                <a:ea typeface="Yu Gothic"/>
+              </a:rPr>
+              <a:t>〜</a:t>
+            </a:r>
+            <a:r>
+              <a:rPr lang="ja-JP" altLang="en-US" b="1" dirty="0">
+                <a:solidFill>
+                  <a:srgbClr val="1B2A5A"/>
+                </a:solidFill>
+                <a:latin typeface="Yu Gothic"/>
+                <a:ea typeface="Yu Gothic"/>
+              </a:rPr>
+              <a:t>数分の安定に優れるが単体に限界。</a:t>
+            </a:r>
+            <a:endParaRPr lang="ja-JP" altLang="en-US" dirty="0">
+              <a:latin typeface="Yu Gothic"/>
+              <a:ea typeface="Yu Gothic"/>
+            </a:endParaRPr>
+          </a:p>
+        </p:txBody>
+      </p:sp>
+    </p:spTree>
+  </p:cSld>
+  <p:clrMapOvr>
+    <a:masterClrMapping/>
+  </p:clrMapOvr>
+</p:sld>
+</file>
+
+<file path=ppt/slides/slide5.xml><?xml version="1.0" encoding="utf-8"?>
+<p:sld xmlns:a="http://schemas.openxmlformats.org/drawingml/2006/main" xmlns:r="http://schemas.openxmlformats.org/officeDocument/2006/relationships" xmlns:p="http://schemas.openxmlformats.org/presentationml/2006/main">
+  <p:cSld>
+    <p:spTree>
+      <p:nvGrpSpPr>
+        <p:cNvPr id="1" name="">
+          <a:extLst>
+            <a:ext uri="{FF2B5EF4-FFF2-40B4-BE49-F238E27FC236}">
+              <a16:creationId xmlns:a16="http://schemas.microsoft.com/office/drawing/2014/main" id="{D2C705A1-D6BB-2DAB-DE08-627802D54ADA}"/>
+            </a:ext>
+          </a:extLst>
+        </p:cNvPr>
+        <p:cNvGrpSpPr/>
+        <p:nvPr/>
+      </p:nvGrpSpPr>
+      <p:grpSpPr>
+        <a:xfrm>
+          <a:off x="0" y="0"/>
+          <a:ext cx="0" cy="0"/>
+          <a:chOff x="0" y="0"/>
+          <a:chExt cx="0" cy="0"/>
+        </a:xfrm>
+      </p:grpSpPr>
+      <p:sp>
+        <p:nvSpPr>
+          <p:cNvPr id="2" name="Title 1">
+            <a:extLst>
+              <a:ext uri="{FF2B5EF4-FFF2-40B4-BE49-F238E27FC236}">
+                <a16:creationId xmlns:a16="http://schemas.microsoft.com/office/drawing/2014/main" id="{29706395-12C2-0397-1CB8-37989F6EA7A3}"/>
+              </a:ext>
+            </a:extLst>
+          </p:cNvPr>
+          <p:cNvSpPr>
+            <a:spLocks noGrp="1"/>
+          </p:cNvSpPr>
+          <p:nvPr>
+            <p:ph type="title"/>
+          </p:nvPr>
+        </p:nvSpPr>
+        <p:spPr>
+          <a:xfrm>
+            <a:off x="228600" y="237744"/>
+            <a:ext cx="9473184" cy="969264"/>
+          </a:xfrm>
+        </p:spPr>
+        <p:txBody>
+          <a:bodyPr/>
+          <a:lstStyle/>
+          <a:p>
+            <a:pPr>
+              <a:spcBef>
+                <a:spcPts val="0"/>
+              </a:spcBef>
+              <a:spcAft>
+                <a:spcPts val="0"/>
+              </a:spcAft>
+            </a:pPr>
+            <a:r>
+              <a:rPr sz="1400" b="1" dirty="0">
+                <a:solidFill>
+                  <a:srgbClr val="000F78"/>
+                </a:solidFill>
+                <a:latin typeface="Yu Gothic"/>
+                <a:ea typeface="Yu Gothic"/>
+              </a:rPr>
+              <a:t>01. </a:t>
+            </a:r>
+            <a:r>
+              <a:rPr sz="1400" b="1" dirty="0" err="1">
+                <a:solidFill>
+                  <a:srgbClr val="000F78"/>
+                </a:solidFill>
+                <a:latin typeface="Yu Gothic"/>
+                <a:ea typeface="Yu Gothic"/>
+              </a:rPr>
+              <a:t>研究背景</a:t>
+            </a:r>
+            <a:endParaRPr sz="1400" b="1" dirty="0">
+              <a:solidFill>
+                <a:srgbClr val="000F78"/>
+              </a:solidFill>
+              <a:latin typeface="Yu Gothic"/>
+              <a:ea typeface="Yu Gothic"/>
+            </a:endParaRPr>
+          </a:p>
+          <a:p>
+            <a:pPr>
+              <a:spcBef>
+                <a:spcPts val="0"/>
+              </a:spcBef>
+              <a:spcAft>
+                <a:spcPts val="0"/>
+              </a:spcAft>
+            </a:pPr>
+            <a:r>
+              <a:rPr b="1" dirty="0">
+                <a:solidFill>
+                  <a:srgbClr val="000F78"/>
+                </a:solidFill>
+                <a:latin typeface="Yu Gothic"/>
+                <a:ea typeface="Yu Gothic"/>
+              </a:rPr>
+              <a:t>1-2. </a:t>
+            </a:r>
+            <a:r>
+              <a:rPr b="1" dirty="0" err="1">
+                <a:solidFill>
+                  <a:srgbClr val="000F78"/>
+                </a:solidFill>
+                <a:latin typeface="Yu Gothic"/>
+                <a:ea typeface="Yu Gothic"/>
+              </a:rPr>
+              <a:t>基準信号の純度と現状</a:t>
+            </a:r>
+            <a:endParaRPr b="1" dirty="0">
+              <a:solidFill>
+                <a:srgbClr val="000F78"/>
+              </a:solidFill>
+              <a:latin typeface="Yu Gothic"/>
+              <a:ea typeface="Yu Gothic"/>
+            </a:endParaRPr>
+          </a:p>
+        </p:txBody>
+      </p:sp>
+      <p:pic>
+        <p:nvPicPr>
+          <p:cNvPr id="5" name="Picture 4" descr="image.png">
+            <a:extLst>
+              <a:ext uri="{FF2B5EF4-FFF2-40B4-BE49-F238E27FC236}">
+                <a16:creationId xmlns:a16="http://schemas.microsoft.com/office/drawing/2014/main" id="{F5884907-F411-83B8-7674-B4A9EDA18BF8}"/>
+              </a:ext>
+            </a:extLst>
+          </p:cNvPr>
+          <p:cNvPicPr>
+            <a:picLocks noChangeAspect="1"/>
+          </p:cNvPicPr>
+          <p:nvPr/>
+        </p:nvPicPr>
+        <p:blipFill>
+          <a:blip r:embed="rId2"/>
+          <a:stretch>
+            <a:fillRect/>
+          </a:stretch>
+        </p:blipFill>
+        <p:spPr>
+          <a:xfrm>
+            <a:off x="1244755" y="2214879"/>
+            <a:ext cx="7486593" cy="4121040"/>
+          </a:xfrm>
+          <a:prstGeom prst="rect">
+            <a:avLst/>
+          </a:prstGeom>
+        </p:spPr>
+      </p:pic>
+      <p:sp>
+        <p:nvSpPr>
+          <p:cNvPr id="10" name="テキスト プレースホルダー 9">
+            <a:extLst>
+              <a:ext uri="{FF2B5EF4-FFF2-40B4-BE49-F238E27FC236}">
+                <a16:creationId xmlns:a16="http://schemas.microsoft.com/office/drawing/2014/main" id="{35C4104F-D17D-7399-C8EA-A70DA215CADB}"/>
+              </a:ext>
+            </a:extLst>
+          </p:cNvPr>
+          <p:cNvSpPr>
+            <a:spLocks noGrp="1"/>
+          </p:cNvSpPr>
+          <p:nvPr>
+            <p:ph type="body" idx="1"/>
+          </p:nvPr>
+        </p:nvSpPr>
+        <p:spPr>
+          <a:xfrm>
+            <a:off x="213525" y="906114"/>
+            <a:ext cx="9590875" cy="969263"/>
+          </a:xfrm>
+        </p:spPr>
+        <p:txBody>
+          <a:bodyPr/>
+          <a:lstStyle/>
+          <a:p>
+            <a:r>
+              <a:rPr lang="ja-JP" altLang="en-US" b="1" dirty="0">
+                <a:solidFill>
+                  <a:srgbClr val="1B2A5A"/>
+                </a:solidFill>
+                <a:latin typeface="Yu Gothic"/>
+                <a:ea typeface="Yu Gothic"/>
+              </a:rPr>
+              <a:t>通信・測位・計測は基準正弦波の位相雑音に支えられる。原子時計・水素メーザーは高純度だが高価で日単位の計測が必要、</a:t>
+            </a:r>
+            <a:r>
+              <a:rPr lang="en-US" altLang="ja-JP" b="1" dirty="0">
+                <a:solidFill>
+                  <a:srgbClr val="1B2A5A"/>
+                </a:solidFill>
+                <a:latin typeface="Yu Gothic"/>
+                <a:ea typeface="Yu Gothic"/>
+              </a:rPr>
+              <a:t>OCXO</a:t>
+            </a:r>
+            <a:r>
+              <a:rPr lang="ja-JP" altLang="en-US" b="1" dirty="0">
+                <a:solidFill>
+                  <a:srgbClr val="1B2A5A"/>
+                </a:solidFill>
+                <a:latin typeface="Yu Gothic"/>
+                <a:ea typeface="Yu Gothic"/>
+              </a:rPr>
+              <a:t>は安価で数秒</a:t>
+            </a:r>
+            <a:r>
+              <a:rPr lang="en-US" altLang="ja-JP" b="1" dirty="0">
+                <a:solidFill>
+                  <a:srgbClr val="1B2A5A"/>
+                </a:solidFill>
+                <a:latin typeface="Yu Gothic"/>
+                <a:ea typeface="Yu Gothic"/>
+              </a:rPr>
+              <a:t>〜</a:t>
+            </a:r>
+            <a:r>
+              <a:rPr lang="ja-JP" altLang="en-US" b="1" dirty="0">
+                <a:solidFill>
+                  <a:srgbClr val="1B2A5A"/>
+                </a:solidFill>
+                <a:latin typeface="Yu Gothic"/>
+                <a:ea typeface="Yu Gothic"/>
+              </a:rPr>
+              <a:t>数分の安定に優れるが単体に限界。</a:t>
+            </a:r>
+            <a:endParaRPr lang="ja-JP" altLang="en-US" dirty="0">
+              <a:latin typeface="Yu Gothic"/>
+              <a:ea typeface="Yu Gothic"/>
+            </a:endParaRPr>
+          </a:p>
+        </p:txBody>
+      </p:sp>
+    </p:spTree>
+    <p:extLst>
+      <p:ext uri="{BB962C8B-B14F-4D97-AF65-F5344CB8AC3E}">
+        <p14:creationId xmlns:p14="http://schemas.microsoft.com/office/powerpoint/2010/main" val="3782676189"/>
+      </p:ext>
+    </p:extLst>
+  </p:cSld>
+  <p:clrMapOvr>
+    <a:masterClrMapping/>
+  </p:clrMapOvr>
+</p:sld>
+</file>
+
+<file path=ppt/slides/slide6.xml><?xml version="1.0" encoding="utf-8"?>
+<p:sld xmlns:a="http://schemas.openxmlformats.org/drawingml/2006/main" xmlns:r="http://schemas.openxmlformats.org/officeDocument/2006/relationships" xmlns:p="http://schemas.openxmlformats.org/presentationml/2006/main">
+  <p:cSld>
+    <p:spTree>
+      <p:nvGrpSpPr>
+        <p:cNvPr id="1" name=""/>
+        <p:cNvGrpSpPr/>
+        <p:nvPr/>
+      </p:nvGrpSpPr>
+      <p:grpSpPr>
+        <a:xfrm>
+          <a:off x="0" y="0"/>
+          <a:ext cx="0" cy="0"/>
+          <a:chOff x="0" y="0"/>
+          <a:chExt cx="0" cy="0"/>
+        </a:xfrm>
+      </p:grpSpPr>
+      <p:sp>
+        <p:nvSpPr>
+          <p:cNvPr id="2" name="Title 1"/>
+          <p:cNvSpPr>
+            <a:spLocks noGrp="1"/>
+          </p:cNvSpPr>
+          <p:nvPr>
+            <p:ph type="title"/>
+          </p:nvPr>
+        </p:nvSpPr>
+        <p:spPr>
+          <a:xfrm>
+            <a:off x="228600" y="237744"/>
+            <a:ext cx="9473184" cy="969264"/>
+          </a:xfrm>
+        </p:spPr>
+        <p:txBody>
+          <a:bodyPr/>
+          <a:lstStyle/>
+          <a:p>
+            <a:pPr>
+              <a:spcBef>
+                <a:spcPts val="0"/>
+              </a:spcBef>
+              <a:spcAft>
+                <a:spcPts val="0"/>
+              </a:spcAft>
+            </a:pPr>
+            <a:r>
+              <a:rPr b="1">
+                <a:solidFill>
+                  <a:srgbClr val="000F78"/>
+                </a:solidFill>
+                <a:latin typeface="Yu Gothic"/>
+                <a:ea typeface="Yu Gothic"/>
+              </a:rPr>
+              <a:t>02. 本研究の目標</a:t>
             </a:r>
           </a:p>
         </p:txBody>
@@ -10667,23 +11353,63 @@
           <a:bodyPr wrap="square"/>
           <a:lstStyle/>
           <a:p>
-            <a:pPr/>
-            <a:r>
-              <a:rPr>
+            <a:r>
+              <a:rPr lang="ja-JP" altLang="en-US" dirty="0">
                 <a:latin typeface="Yu Gothic"/>
                 <a:ea typeface="Yu Gothic"/>
               </a:rPr>
-              <a:t>市販データは概ね 1 Hz 止まり。近傍（0.1–1 Hz）は測定が難しい</a:t>
-            </a:r>
-          </a:p>
-          <a:p>
-            <a:pPr/>
-            <a:r>
-              <a:rPr>
+              <a:t>究極的な目標：安価な水晶発振器（</a:t>
+            </a:r>
+            <a:r>
+              <a:rPr lang="en-US" altLang="ja-JP" dirty="0">
                 <a:latin typeface="Yu Gothic"/>
                 <a:ea typeface="Yu Gothic"/>
               </a:rPr>
-              <a:t>近傍の測定純度をどう高めるかが本研究の論点</a:t>
+              <a:t>OCXO</a:t>
+            </a:r>
+            <a:r>
+              <a:rPr lang="ja-JP" altLang="en-US" dirty="0">
+                <a:latin typeface="Yu Gothic"/>
+                <a:ea typeface="Yu Gothic"/>
+              </a:rPr>
+              <a:t>）で高純度な基準信号源を実現</a:t>
+            </a:r>
+          </a:p>
+          <a:p>
+            <a:r>
+              <a:rPr lang="ja-JP" altLang="en-US" dirty="0">
+                <a:latin typeface="Yu Gothic"/>
+                <a:ea typeface="Yu Gothic"/>
+              </a:rPr>
+              <a:t>アプローチ：複数</a:t>
+            </a:r>
+            <a:r>
+              <a:rPr lang="en-US" altLang="ja-JP" dirty="0">
+                <a:latin typeface="Yu Gothic"/>
+                <a:ea typeface="Yu Gothic"/>
+              </a:rPr>
+              <a:t>OCXO</a:t>
+            </a:r>
+            <a:r>
+              <a:rPr lang="ja-JP" altLang="en-US" dirty="0">
+                <a:latin typeface="Yu Gothic"/>
+                <a:ea typeface="Yu Gothic"/>
+              </a:rPr>
+              <a:t>を同期させ、</a:t>
+            </a:r>
+            <a:r>
+              <a:rPr lang="en-US" altLang="ja-JP" dirty="0">
+                <a:latin typeface="Yu Gothic"/>
+                <a:ea typeface="Yu Gothic"/>
+              </a:rPr>
+              <a:t>1</a:t>
+            </a:r>
+            <a:r>
+              <a:rPr lang="ja-JP" altLang="en-US" dirty="0">
+                <a:latin typeface="Yu Gothic"/>
+                <a:ea typeface="Yu Gothic"/>
+              </a:rPr>
+              <a:t>台では実現できない純度での計測を可能にする</a:t>
             </a:r>
           </a:p>
         </p:txBody>
@@ -10727,7 +11453,7 @@
           </a:fontRef>
         </p:style>
         <p:txBody>
-          <a:bodyPr rtlCol="0" anchor="ctr" wrap="square" lIns="127000" rIns="127000" tIns="25400" bIns="25400"/>
+          <a:bodyPr wrap="square" lIns="127000" tIns="25400" rIns="127000" bIns="25400" rtlCol="0" anchor="ctr"/>
           <a:lstStyle/>
           <a:p>
             <a:pPr algn="ctr"/>
@@ -10749,7 +11475,7 @@
                 <a:latin typeface="Yu Gothic"/>
                 <a:ea typeface="Yu Gothic"/>
               </a:rPr>
-              <a:t>通信・測位・計測は基準正弦波の位相雑音に支えられる。原子時計・水素メーザーは高純度だが高価で日単位の計測が必要、OCXOは安価で数秒〜数分の安定に優れるが単体に限界。</a:t>
+              <a:t>安価なOCXOで可能な限り高純度な基準信号源を実現することを目標とする。</a:t>
             </a:r>
           </a:p>
         </p:txBody>
@@ -10770,8 +11496,8 @@
         </p:blipFill>
         <p:spPr>
           <a:xfrm>
-            <a:off x="5074920" y="2869040"/>
-            <a:ext cx="4526280" cy="2491518"/>
+            <a:off x="5074920" y="2796677"/>
+            <a:ext cx="4526280" cy="2636244"/>
           </a:xfrm>
           <a:prstGeom prst="rect">
             <a:avLst/>
@@ -10786,8 +11512,8 @@
 </p:sld>
 </file>
 
-<file path=ppt/slides/slide5.xml><?xml version="1.0" encoding="utf-8"?>
-<p:sld xmlns:a="http://schemas.openxmlformats.org/drawingml/2006/main" xmlns:p="http://schemas.openxmlformats.org/presentationml/2006/main" xmlns:r="http://schemas.openxmlformats.org/officeDocument/2006/relationships">
+<file path=ppt/slides/slide7.xml><?xml version="1.0" encoding="utf-8"?>
+<p:sld xmlns:a="http://schemas.openxmlformats.org/drawingml/2006/main" xmlns:r="http://schemas.openxmlformats.org/officeDocument/2006/relationships" xmlns:p="http://schemas.openxmlformats.org/presentationml/2006/main">
   <p:cSld>
     <p:spTree>
       <p:nvGrpSpPr>
@@ -10795,7 +11521,14 @@
         <p:cNvGrpSpPr/>
         <p:nvPr/>
       </p:nvGrpSpPr>
-      <p:grpSpPr/>
+      <p:grpSpPr>
+        <a:xfrm>
+          <a:off x="0" y="0"/>
+          <a:ext cx="0" cy="0"/>
+          <a:chOff x="0" y="0"/>
+          <a:chExt cx="0" cy="0"/>
+        </a:xfrm>
+      </p:grpSpPr>
       <p:sp>
         <p:nvSpPr>
           <p:cNvPr id="2" name="Title 1"/>
@@ -10825,14 +11558,34 @@
               </a:spcAft>
             </a:pPr>
             <a:r>
-              <a:rPr b="1">
+              <a:rPr sz="1400" b="1">
                 <a:solidFill>
                   <a:srgbClr val="000F78"/>
                 </a:solidFill>
                 <a:latin typeface="Yu Gothic"/>
                 <a:ea typeface="Yu Gothic"/>
               </a:rPr>
-              <a:t>02. 本研究の目標</a:t>
+              <a:t>03. 先行研究</a:t>
+            </a:r>
+          </a:p>
+          <a:p>
+            <a:pPr>
+              <a:spcBef>
+                <a:spcPts val="0"/>
+              </a:spcBef>
+              <a:spcAft>
+                <a:spcPts val="0"/>
+              </a:spcAft>
+            </a:pPr>
+            <a:r>
+              <a:rPr b="1">
+                <a:solidFill>
+                  <a:srgbClr val="000F78"/>
+                </a:solidFill>
+                <a:latin typeface="Yu Gothic"/>
+                <a:ea typeface="Yu Gothic"/>
+              </a:rPr>
+              <a:t>3-1. 同期・平均による位相雑音の改善（1/N の原理）</a:t>
             </a:r>
           </a:p>
         </p:txBody>
@@ -10857,23 +11610,12 @@
           <a:bodyPr wrap="square"/>
           <a:lstStyle/>
           <a:p>
-            <a:pPr/>
             <a:r>
               <a:rPr>
                 <a:latin typeface="Yu Gothic"/>
                 <a:ea typeface="Yu Gothic"/>
               </a:rPr>
-              <a:t>究極的な目標：安価な水晶発振器（OCXO）で高純度な基準信号源を実現</a:t>
-            </a:r>
-          </a:p>
-          <a:p>
-            <a:pPr/>
-            <a:r>
-              <a:rPr>
-                <a:latin typeface="Yu Gothic"/>
-                <a:ea typeface="Yu Gothic"/>
-              </a:rPr>
-              <a:t>アプローチ：複数OCXOを同期させ、1台では実現できない純度での計測を可能にする</a:t>
+              <a:t>無相関な雑音は平均すると電力が台数分の1（2台で 1/2）になり、近傍位相雑音が −3 dB 改善する</a:t>
             </a:r>
           </a:p>
         </p:txBody>
@@ -10917,7 +11659,7 @@
           </a:fontRef>
         </p:style>
         <p:txBody>
-          <a:bodyPr rtlCol="0" anchor="ctr" wrap="square" lIns="127000" rIns="127000" tIns="25400" bIns="25400"/>
+          <a:bodyPr wrap="square" lIns="127000" tIns="25400" rIns="127000" bIns="25400" rtlCol="0" anchor="ctr"/>
           <a:lstStyle/>
           <a:p>
             <a:pPr algn="ctr"/>
@@ -10939,7 +11681,7 @@
                 <a:latin typeface="Yu Gothic"/>
                 <a:ea typeface="Yu Gothic"/>
               </a:rPr>
-              <a:t>安価なOCXOで可能な限り高純度な基準信号源を実現することを目標とする。</a:t>
+              <a:t>互いに無相関な雑音は平均で打ち消し合うため、位相を揃えた複数OCXOの出力を平均すると単体を超える純度になる。</a:t>
             </a:r>
           </a:p>
         </p:txBody>
@@ -10960,8 +11702,8 @@
         </p:blipFill>
         <p:spPr>
           <a:xfrm>
-            <a:off x="5074920" y="2796677"/>
-            <a:ext cx="4526280" cy="2636244"/>
+            <a:off x="5257333" y="2286000"/>
+            <a:ext cx="4161453" cy="3657600"/>
           </a:xfrm>
           <a:prstGeom prst="rect">
             <a:avLst/>
@@ -10976,8 +11718,8 @@
 </p:sld>
 </file>
 
-<file path=ppt/slides/slide6.xml><?xml version="1.0" encoding="utf-8"?>
-<p:sld xmlns:a="http://schemas.openxmlformats.org/drawingml/2006/main" xmlns:p="http://schemas.openxmlformats.org/presentationml/2006/main" xmlns:r="http://schemas.openxmlformats.org/officeDocument/2006/relationships">
+<file path=ppt/slides/slide8.xml><?xml version="1.0" encoding="utf-8"?>
+<p:sld xmlns:a="http://schemas.openxmlformats.org/drawingml/2006/main" xmlns:r="http://schemas.openxmlformats.org/officeDocument/2006/relationships" xmlns:p="http://schemas.openxmlformats.org/presentationml/2006/main">
   <p:cSld>
     <p:spTree>
       <p:nvGrpSpPr>
@@ -10985,7 +11727,14 @@
         <p:cNvGrpSpPr/>
         <p:nvPr/>
       </p:nvGrpSpPr>
-      <p:grpSpPr/>
+      <p:grpSpPr>
+        <a:xfrm>
+          <a:off x="0" y="0"/>
+          <a:ext cx="0" cy="0"/>
+          <a:chOff x="0" y="0"/>
+          <a:chExt cx="0" cy="0"/>
+        </a:xfrm>
+      </p:grpSpPr>
       <p:sp>
         <p:nvSpPr>
           <p:cNvPr id="2" name="Title 1"/>
@@ -11022,7 +11771,7 @@
                 <a:latin typeface="Yu Gothic"/>
                 <a:ea typeface="Yu Gothic"/>
               </a:rPr>
-              <a:t>03. 先行研究</a:t>
+              <a:t>04. 研究方法</a:t>
             </a:r>
           </a:p>
           <a:p>
@@ -11042,7 +11791,7 @@
                 <a:latin typeface="Yu Gothic"/>
                 <a:ea typeface="Yu Gothic"/>
               </a:rPr>
-              <a:t>3-1. 同期・平均による位相雑音の改善（1/N の原理）</a:t>
+              <a:t>4-1. アプローチ：能動的に同期して平均する</a:t>
             </a:r>
           </a:p>
         </p:txBody>
@@ -11067,13 +11816,30 @@
           <a:bodyPr wrap="square"/>
           <a:lstStyle/>
           <a:p>
-            <a:pPr/>
             <a:r>
               <a:rPr>
                 <a:latin typeface="Yu Gothic"/>
                 <a:ea typeface="Yu Gothic"/>
               </a:rPr>
-              <a:t>無相関な雑音は平均すると電力が台数分の1（2台で 1/2）になり、近傍位相雑音が −3 dB 改善する</a:t>
+              <a:t>平均には各発振器の位相が揃うことが前提</a:t>
+            </a:r>
+          </a:p>
+          <a:p>
+            <a:r>
+              <a:rPr>
+                <a:latin typeface="Yu Gothic"/>
+                <a:ea typeface="Yu Gothic"/>
+              </a:rPr>
+              <a:t>本研究の方式：能動的フィードバックで実時間同期し、出力を平均する</a:t>
+            </a:r>
+          </a:p>
+          <a:p>
+            <a:r>
+              <a:rPr>
+                <a:latin typeface="Yu Gothic"/>
+                <a:ea typeface="Yu Gothic"/>
+              </a:rPr>
+              <a:t>同期を『雑音を加えずに』行うことが中核課題</a:t>
             </a:r>
           </a:p>
         </p:txBody>
@@ -11117,7 +11883,7 @@
           </a:fontRef>
         </p:style>
         <p:txBody>
-          <a:bodyPr rtlCol="0" anchor="ctr" wrap="square" lIns="127000" rIns="127000" tIns="25400" bIns="25400"/>
+          <a:bodyPr wrap="square" lIns="127000" tIns="25400" rIns="127000" bIns="25400" rtlCol="0" anchor="ctr"/>
           <a:lstStyle/>
           <a:p>
             <a:pPr algn="ctr"/>
@@ -11139,7 +11905,7 @@
                 <a:latin typeface="Yu Gothic"/>
                 <a:ea typeface="Yu Gothic"/>
               </a:rPr>
-              <a:t>互いに無相関な雑音は平均で打ち消し合うため、位相を揃えた複数OCXOの出力を平均すると単体を超える純度になる。</a:t>
+              <a:t>互いに無相関な雑音は平均で打ち消し合う。位相を揃えた複数OCXOの出力を能動的フィードバックで実時間に同期・平均し、単体を超える純度を実現する（国際原子時のクロックアンサンブルを小規模・実時間で適用）。</a:t>
             </a:r>
           </a:p>
         </p:txBody>
@@ -11160,8 +11926,8 @@
         </p:blipFill>
         <p:spPr>
           <a:xfrm>
-            <a:off x="5257333" y="2286000"/>
-            <a:ext cx="4161453" cy="3657600"/>
+            <a:off x="5074920" y="2968671"/>
+            <a:ext cx="4526280" cy="2292256"/>
           </a:xfrm>
           <a:prstGeom prst="rect">
             <a:avLst/>
@@ -11176,8 +11942,8 @@
 </p:sld>
 </file>
 
-<file path=ppt/slides/slide7.xml><?xml version="1.0" encoding="utf-8"?>
-<p:sld xmlns:a="http://schemas.openxmlformats.org/drawingml/2006/main" xmlns:p="http://schemas.openxmlformats.org/presentationml/2006/main" xmlns:r="http://schemas.openxmlformats.org/officeDocument/2006/relationships">
+<file path=ppt/slides/slide9.xml><?xml version="1.0" encoding="utf-8"?>
+<p:sld xmlns:a="http://schemas.openxmlformats.org/drawingml/2006/main" xmlns:r="http://schemas.openxmlformats.org/officeDocument/2006/relationships" xmlns:p="http://schemas.openxmlformats.org/presentationml/2006/main">
   <p:cSld>
     <p:spTree>
       <p:nvGrpSpPr>
@@ -11185,7 +11951,14 @@
         <p:cNvGrpSpPr/>
         <p:nvPr/>
       </p:nvGrpSpPr>
-      <p:grpSpPr/>
+      <p:grpSpPr>
+        <a:xfrm>
+          <a:off x="0" y="0"/>
+          <a:ext cx="0" cy="0"/>
+          <a:chOff x="0" y="0"/>
+          <a:chExt cx="0" cy="0"/>
+        </a:xfrm>
+      </p:grpSpPr>
       <p:sp>
         <p:nvSpPr>
           <p:cNvPr id="2" name="Title 1"/>
@@ -11242,7 +12015,7 @@
                 <a:latin typeface="Yu Gothic"/>
                 <a:ea typeface="Yu Gothic"/>
               </a:rPr>
-              <a:t>4-1. アプローチ：能動的に同期して平均する</a:t>
+              <a:t>4-2. 実験系</a:t>
             </a:r>
           </a:p>
         </p:txBody>
@@ -11267,33 +12040,12 @@
           <a:bodyPr wrap="square"/>
           <a:lstStyle/>
           <a:p>
-            <a:pPr/>
             <a:r>
               <a:rPr>
                 <a:latin typeface="Yu Gothic"/>
                 <a:ea typeface="Yu Gothic"/>
               </a:rPr>
-              <a:t>平均には各発振器の位相が揃うことが前提</a:t>
-            </a:r>
-          </a:p>
-          <a:p>
-            <a:pPr/>
-            <a:r>
-              <a:rPr>
-                <a:latin typeface="Yu Gothic"/>
-                <a:ea typeface="Yu Gothic"/>
-              </a:rPr>
-              <a:t>本研究の方式：能動的フィードバックで実時間同期し、出力を平均する</a:t>
-            </a:r>
-          </a:p>
-          <a:p>
-            <a:pPr/>
-            <a:r>
-              <a:rPr>
-                <a:latin typeface="Yu Gothic"/>
-                <a:ea typeface="Yu Gothic"/>
-              </a:rPr>
-              <a:t>同期を『雑音を加えずに』行うことが中核課題</a:t>
+              <a:t>制御系統（オシロ FRFR）と精度評価系統（録音→ヒルベルト変換）の二系統で構成</a:t>
             </a:r>
           </a:p>
         </p:txBody>
@@ -11337,207 +12089,7 @@
           </a:fontRef>
         </p:style>
         <p:txBody>
-          <a:bodyPr rtlCol="0" anchor="ctr" wrap="square" lIns="127000" rIns="127000" tIns="25400" bIns="25400"/>
-          <a:lstStyle/>
-          <a:p>
-            <a:pPr algn="ctr"/>
-            <a:r>
-              <a:rPr sz="1100" b="1">
-                <a:solidFill>
-                  <a:srgbClr val="B03010"/>
-                </a:solidFill>
-                <a:latin typeface="Yu Gothic"/>
-                <a:ea typeface="Yu Gothic"/>
-              </a:rPr>
-              <a:t>結論  </a:t>
-            </a:r>
-            <a:r>
-              <a:rPr sz="1300" b="1">
-                <a:solidFill>
-                  <a:srgbClr val="1B2A5A"/>
-                </a:solidFill>
-                <a:latin typeface="Yu Gothic"/>
-                <a:ea typeface="Yu Gothic"/>
-              </a:rPr>
-              <a:t>互いに無相関な雑音は平均で打ち消し合う。位相を揃えた複数OCXOの出力を能動的フィードバックで実時間に同期・平均し、単体を超える純度を実現する（国際原子時のクロックアンサンブルを小規模・実時間で適用）。</a:t>
-            </a:r>
-          </a:p>
-        </p:txBody>
-      </p:sp>
-      <p:pic>
-        <p:nvPicPr>
-          <p:cNvPr id="5" name="Picture 4" descr="image.png"/>
-          <p:cNvPicPr>
-            <a:picLocks noChangeAspect="1"/>
-          </p:cNvPicPr>
-          <p:nvPr/>
-        </p:nvPicPr>
-        <p:blipFill>
-          <a:blip r:embed="rId2"/>
-          <a:stretch>
-            <a:fillRect/>
-          </a:stretch>
-        </p:blipFill>
-        <p:spPr>
-          <a:xfrm>
-            <a:off x="5074920" y="2968671"/>
-            <a:ext cx="4526280" cy="2292256"/>
-          </a:xfrm>
-          <a:prstGeom prst="rect">
-            <a:avLst/>
-          </a:prstGeom>
-        </p:spPr>
-      </p:pic>
-    </p:spTree>
-  </p:cSld>
-  <p:clrMapOvr>
-    <a:masterClrMapping/>
-  </p:clrMapOvr>
-</p:sld>
-</file>
-
-<file path=ppt/slides/slide8.xml><?xml version="1.0" encoding="utf-8"?>
-<p:sld xmlns:a="http://schemas.openxmlformats.org/drawingml/2006/main" xmlns:p="http://schemas.openxmlformats.org/presentationml/2006/main" xmlns:r="http://schemas.openxmlformats.org/officeDocument/2006/relationships">
-  <p:cSld>
-    <p:spTree>
-      <p:nvGrpSpPr>
-        <p:cNvPr id="1" name=""/>
-        <p:cNvGrpSpPr/>
-        <p:nvPr/>
-      </p:nvGrpSpPr>
-      <p:grpSpPr/>
-      <p:sp>
-        <p:nvSpPr>
-          <p:cNvPr id="2" name="Title 1"/>
-          <p:cNvSpPr>
-            <a:spLocks noGrp="1"/>
-          </p:cNvSpPr>
-          <p:nvPr>
-            <p:ph type="title"/>
-          </p:nvPr>
-        </p:nvSpPr>
-        <p:spPr>
-          <a:xfrm>
-            <a:off x="228600" y="237744"/>
-            <a:ext cx="9473184" cy="969264"/>
-          </a:xfrm>
-        </p:spPr>
-        <p:txBody>
-          <a:bodyPr/>
-          <a:lstStyle/>
-          <a:p>
-            <a:pPr>
-              <a:spcBef>
-                <a:spcPts val="0"/>
-              </a:spcBef>
-              <a:spcAft>
-                <a:spcPts val="0"/>
-              </a:spcAft>
-            </a:pPr>
-            <a:r>
-              <a:rPr sz="1400" b="1">
-                <a:solidFill>
-                  <a:srgbClr val="000F78"/>
-                </a:solidFill>
-                <a:latin typeface="Yu Gothic"/>
-                <a:ea typeface="Yu Gothic"/>
-              </a:rPr>
-              <a:t>04. 研究方法</a:t>
-            </a:r>
-          </a:p>
-          <a:p>
-            <a:pPr>
-              <a:spcBef>
-                <a:spcPts val="0"/>
-              </a:spcBef>
-              <a:spcAft>
-                <a:spcPts val="0"/>
-              </a:spcAft>
-            </a:pPr>
-            <a:r>
-              <a:rPr b="1">
-                <a:solidFill>
-                  <a:srgbClr val="000F78"/>
-                </a:solidFill>
-                <a:latin typeface="Yu Gothic"/>
-                <a:ea typeface="Yu Gothic"/>
-              </a:rPr>
-              <a:t>4-2. 実験系</a:t>
-            </a:r>
-          </a:p>
-        </p:txBody>
-      </p:sp>
-      <p:sp>
-        <p:nvSpPr>
-          <p:cNvPr id="3" name="Text Placeholder 2"/>
-          <p:cNvSpPr>
-            <a:spLocks noGrp="1"/>
-          </p:cNvSpPr>
-          <p:nvPr>
-            <p:ph type="body" idx="1"/>
-          </p:nvPr>
-        </p:nvSpPr>
-        <p:spPr>
-          <a:xfrm>
-            <a:off x="274320" y="2212848"/>
-            <a:ext cx="4526280" cy="4297680"/>
-          </a:xfrm>
-        </p:spPr>
-        <p:txBody>
-          <a:bodyPr wrap="square"/>
-          <a:lstStyle/>
-          <a:p>
-            <a:pPr/>
-            <a:r>
-              <a:rPr>
-                <a:latin typeface="Yu Gothic"/>
-                <a:ea typeface="Yu Gothic"/>
-              </a:rPr>
-              <a:t>制御系統（オシロ FRFR）と精度評価系統（録音→ヒルベルト変換）の二系統で構成</a:t>
-            </a:r>
-          </a:p>
-        </p:txBody>
-      </p:sp>
-      <p:sp>
-        <p:nvSpPr>
-          <p:cNvPr id="4" name="Rounded Rectangle 3"/>
-          <p:cNvSpPr/>
-          <p:nvPr/>
-        </p:nvSpPr>
-        <p:spPr>
-          <a:xfrm>
-            <a:off x="274320" y="1335024"/>
-            <a:ext cx="9354312" cy="731520"/>
-          </a:xfrm>
-          <a:prstGeom prst="roundRect">
-            <a:avLst>
-              <a:gd name="adj" fmla="val 8000"/>
-            </a:avLst>
-          </a:prstGeom>
-          <a:solidFill>
-            <a:srgbClr val="EAEFF7"/>
-          </a:solidFill>
-          <a:ln>
-            <a:noFill/>
-          </a:ln>
-          <a:effectLst/>
-        </p:spPr>
-        <p:style>
-          <a:lnRef idx="1">
-            <a:schemeClr val="accent1"/>
-          </a:lnRef>
-          <a:fillRef idx="3">
-            <a:schemeClr val="accent1"/>
-          </a:fillRef>
-          <a:effectRef idx="2">
-            <a:schemeClr val="accent1"/>
-          </a:effectRef>
-          <a:fontRef idx="minor">
-            <a:schemeClr val="lt1"/>
-          </a:fontRef>
-        </p:style>
-        <p:txBody>
-          <a:bodyPr rtlCol="0" anchor="ctr" wrap="square" lIns="127000" rIns="127000" tIns="25400" bIns="25400"/>
+          <a:bodyPr wrap="square" lIns="127000" tIns="25400" rIns="127000" bIns="25400" rtlCol="0" anchor="ctr"/>
           <a:lstStyle/>
           <a:p>
             <a:pPr algn="ctr"/>
@@ -11603,7 +12155,7 @@
           </a:fontRef>
         </p:style>
         <p:txBody>
-          <a:bodyPr rtlCol="0" anchor="ctr" wrap="square"/>
+          <a:bodyPr wrap="square" rtlCol="0" anchor="ctr"/>
           <a:lstStyle/>
           <a:p>
             <a:pPr algn="ctr"/>
@@ -11618,249 +12170,6 @@
               <a:t>実験系ブロック図
 （image1.png を白黒で清書。
 FB→OCXO 帰還矢印・PC(MATLAB) ラベルを追記）</a:t>
-            </a:r>
-          </a:p>
-        </p:txBody>
-      </p:sp>
-    </p:spTree>
-  </p:cSld>
-  <p:clrMapOvr>
-    <a:masterClrMapping/>
-  </p:clrMapOvr>
-</p:sld>
-</file>
-
-<file path=ppt/slides/slide9.xml><?xml version="1.0" encoding="utf-8"?>
-<p:sld xmlns:a="http://schemas.openxmlformats.org/drawingml/2006/main" xmlns:p="http://schemas.openxmlformats.org/presentationml/2006/main" xmlns:r="http://schemas.openxmlformats.org/officeDocument/2006/relationships">
-  <p:cSld>
-    <p:spTree>
-      <p:nvGrpSpPr>
-        <p:cNvPr id="1" name=""/>
-        <p:cNvGrpSpPr/>
-        <p:nvPr/>
-      </p:nvGrpSpPr>
-      <p:grpSpPr/>
-      <p:sp>
-        <p:nvSpPr>
-          <p:cNvPr id="2" name="Title 1"/>
-          <p:cNvSpPr>
-            <a:spLocks noGrp="1"/>
-          </p:cNvSpPr>
-          <p:nvPr>
-            <p:ph type="title"/>
-          </p:nvPr>
-        </p:nvSpPr>
-        <p:spPr>
-          <a:xfrm>
-            <a:off x="228600" y="237744"/>
-            <a:ext cx="9473184" cy="969264"/>
-          </a:xfrm>
-        </p:spPr>
-        <p:txBody>
-          <a:bodyPr/>
-          <a:lstStyle/>
-          <a:p>
-            <a:pPr>
-              <a:spcBef>
-                <a:spcPts val="0"/>
-              </a:spcBef>
-              <a:spcAft>
-                <a:spcPts val="0"/>
-              </a:spcAft>
-            </a:pPr>
-            <a:r>
-              <a:rPr sz="1400" b="1">
-                <a:solidFill>
-                  <a:srgbClr val="000F78"/>
-                </a:solidFill>
-                <a:latin typeface="Yu Gothic"/>
-                <a:ea typeface="Yu Gothic"/>
-              </a:rPr>
-              <a:t>04. 研究方法</a:t>
-            </a:r>
-          </a:p>
-          <a:p>
-            <a:pPr>
-              <a:spcBef>
-                <a:spcPts val="0"/>
-              </a:spcBef>
-              <a:spcAft>
-                <a:spcPts val="0"/>
-              </a:spcAft>
-            </a:pPr>
-            <a:r>
-              <a:rPr b="1">
-                <a:solidFill>
-                  <a:srgbClr val="000F78"/>
-                </a:solidFill>
-                <a:latin typeface="Yu Gothic"/>
-                <a:ea typeface="Yu Gothic"/>
-              </a:rPr>
-              <a:t>4-3. 測定法：オーディオレコーダを使う理由</a:t>
-            </a:r>
-          </a:p>
-        </p:txBody>
-      </p:sp>
-      <p:sp>
-        <p:nvSpPr>
-          <p:cNvPr id="3" name="Text Placeholder 2"/>
-          <p:cNvSpPr>
-            <a:spLocks noGrp="1"/>
-          </p:cNvSpPr>
-          <p:nvPr>
-            <p:ph type="body" idx="1"/>
-          </p:nvPr>
-        </p:nvSpPr>
-        <p:spPr>
-          <a:xfrm>
-            <a:off x="274320" y="2212848"/>
-            <a:ext cx="4526280" cy="4297680"/>
-          </a:xfrm>
-        </p:spPr>
-        <p:txBody>
-          <a:bodyPr wrap="square"/>
-          <a:lstStyle/>
-          <a:p>
-            <a:pPr/>
-            <a:r>
-              <a:rPr>
-                <a:latin typeface="Yu Gothic"/>
-                <a:ea typeface="Yu Gothic"/>
-              </a:rPr>
-              <a:t>オシロの FRFR は精度が要る／録音は高精度・長時間測定が可能</a:t>
-            </a:r>
-          </a:p>
-          <a:p>
-            <a:pPr/>
-            <a:r>
-              <a:rPr>
-                <a:latin typeface="Yu Gothic"/>
-                <a:ea typeface="Yu Gothic"/>
-              </a:rPr>
-              <a:t>卒論で確立した測定法を継承</a:t>
-            </a:r>
-          </a:p>
-        </p:txBody>
-      </p:sp>
-      <p:sp>
-        <p:nvSpPr>
-          <p:cNvPr id="4" name="Rounded Rectangle 3"/>
-          <p:cNvSpPr/>
-          <p:nvPr/>
-        </p:nvSpPr>
-        <p:spPr>
-          <a:xfrm>
-            <a:off x="274320" y="1335024"/>
-            <a:ext cx="9354312" cy="731520"/>
-          </a:xfrm>
-          <a:prstGeom prst="roundRect">
-            <a:avLst>
-              <a:gd name="adj" fmla="val 8000"/>
-            </a:avLst>
-          </a:prstGeom>
-          <a:solidFill>
-            <a:srgbClr val="EAEFF7"/>
-          </a:solidFill>
-          <a:ln>
-            <a:noFill/>
-          </a:ln>
-          <a:effectLst/>
-        </p:spPr>
-        <p:style>
-          <a:lnRef idx="1">
-            <a:schemeClr val="accent1"/>
-          </a:lnRef>
-          <a:fillRef idx="3">
-            <a:schemeClr val="accent1"/>
-          </a:fillRef>
-          <a:effectRef idx="2">
-            <a:schemeClr val="accent1"/>
-          </a:effectRef>
-          <a:fontRef idx="minor">
-            <a:schemeClr val="lt1"/>
-          </a:fontRef>
-        </p:style>
-        <p:txBody>
-          <a:bodyPr rtlCol="0" anchor="ctr" wrap="square" lIns="127000" rIns="127000" tIns="25400" bIns="25400"/>
-          <a:lstStyle/>
-          <a:p>
-            <a:pPr algn="ctr"/>
-            <a:r>
-              <a:rPr sz="1100" b="1">
-                <a:solidFill>
-                  <a:srgbClr val="B03010"/>
-                </a:solidFill>
-                <a:latin typeface="Yu Gothic"/>
-                <a:ea typeface="Yu Gothic"/>
-              </a:rPr>
-              <a:t>結論  </a:t>
-            </a:r>
-            <a:r>
-              <a:rPr sz="1300" b="1">
-                <a:solidFill>
-                  <a:srgbClr val="1B2A5A"/>
-                </a:solidFill>
-                <a:latin typeface="Yu Gothic"/>
-                <a:ea typeface="Yu Gothic"/>
-              </a:rPr>
-              <a:t>オーディオレコーディングは高分解能（10秒測定で std 20–30 ps）かつ長時間測定が可能で、0.1–1 Hz の評価に向いている。</a:t>
-            </a:r>
-          </a:p>
-        </p:txBody>
-      </p:sp>
-      <p:sp>
-        <p:nvSpPr>
-          <p:cNvPr id="5" name="Rounded Rectangle 4"/>
-          <p:cNvSpPr/>
-          <p:nvPr/>
-        </p:nvSpPr>
-        <p:spPr>
-          <a:xfrm>
-            <a:off x="5074920" y="2286000"/>
-            <a:ext cx="4526280" cy="3566160"/>
-          </a:xfrm>
-          <a:prstGeom prst="roundRect">
-            <a:avLst/>
-          </a:prstGeom>
-          <a:solidFill>
-            <a:srgbClr val="F2F2F2"/>
-          </a:solidFill>
-          <a:ln w="12700">
-            <a:solidFill>
-              <a:srgbClr val="595959"/>
-            </a:solidFill>
-          </a:ln>
-          <a:effectLst/>
-        </p:spPr>
-        <p:style>
-          <a:lnRef idx="1">
-            <a:schemeClr val="accent1"/>
-          </a:lnRef>
-          <a:fillRef idx="3">
-            <a:schemeClr val="accent1"/>
-          </a:fillRef>
-          <a:effectRef idx="2">
-            <a:schemeClr val="accent1"/>
-          </a:effectRef>
-          <a:fontRef idx="minor">
-            <a:schemeClr val="lt1"/>
-          </a:fontRef>
-        </p:style>
-        <p:txBody>
-          <a:bodyPr rtlCol="0" anchor="ctr" wrap="square"/>
-          <a:lstStyle/>
-          <a:p>
-            <a:pPr algn="ctr"/>
-            <a:r>
-              <a:rPr sz="1200">
-                <a:solidFill>
-                  <a:srgbClr val="595959"/>
-                </a:solidFill>
-                <a:latin typeface="Yu Gothic"/>
-                <a:ea typeface="Yu Gothic"/>
-              </a:rPr>
-              <a:t>録音系統図・分周・サンプル数比較表
-（卒論PPTXの該当図を流用）</a:t>
             </a:r>
           </a:p>
         </p:txBody>

</xml_diff>